<commit_message>
Add confirmed Tyler ADS address
</commit_message>
<xml_diff>
--- a/sba_application/21_profound_ads_partnership_2026-08-06/Profound ADS Partnership Working Session - Revision 1.00 - 081026.pptx
+++ b/sba_application/21_profound_ads_partnership_2026-08-06/Profound ADS Partnership Working Session - Revision 1.00 - 081026.pptx
@@ -2,33 +2,33 @@
 <file path=ppt/presentation.xml><?xml version="1.0" encoding="utf-8"?>
 <p:presentation xmlns:p="http://schemas.openxmlformats.org/presentationml/2006/main">
   <p:sldMasterIdLst>
-    <p:sldMasterId xmlns:r="http://schemas.openxmlformats.org/officeDocument/2006/relationships" id="2147483648" r:id="R71100cbac50641e7"/>
+    <p:sldMasterId xmlns:r="http://schemas.openxmlformats.org/officeDocument/2006/relationships" id="2147483648" r:id="Rbecf6f510c4b40e4"/>
   </p:sldMasterIdLst>
   <p:notesMasterIdLst>
-    <p:notesMasterId xmlns:r="http://schemas.openxmlformats.org/officeDocument/2006/relationships" r:id="R428b1a547e6340d3"/>
+    <p:notesMasterId xmlns:r="http://schemas.openxmlformats.org/officeDocument/2006/relationships" r:id="Rb35f3ab349bd495c"/>
   </p:notesMasterIdLst>
   <p:sldIdLst>
-    <p:sldId xmlns:r="http://schemas.openxmlformats.org/officeDocument/2006/relationships" id="256" r:id="Rb90c61eae4a14033"/>
-    <p:sldId xmlns:r="http://schemas.openxmlformats.org/officeDocument/2006/relationships" id="257" r:id="Refd6ff87e32a49b0"/>
-    <p:sldId xmlns:r="http://schemas.openxmlformats.org/officeDocument/2006/relationships" id="258" r:id="R3d9b3e0bf4c54876"/>
-    <p:sldId xmlns:r="http://schemas.openxmlformats.org/officeDocument/2006/relationships" id="259" r:id="Rf274cf484cd242ee"/>
-    <p:sldId xmlns:r="http://schemas.openxmlformats.org/officeDocument/2006/relationships" id="260" r:id="Rbf9b7383a37445a2"/>
-    <p:sldId xmlns:r="http://schemas.openxmlformats.org/officeDocument/2006/relationships" id="261" r:id="R31c1f0dfaaf04832"/>
-    <p:sldId xmlns:r="http://schemas.openxmlformats.org/officeDocument/2006/relationships" id="262" r:id="Re4aecc0fd0834ec2"/>
-    <p:sldId xmlns:r="http://schemas.openxmlformats.org/officeDocument/2006/relationships" id="263" r:id="R6df75394e7e84b04"/>
-    <p:sldId xmlns:r="http://schemas.openxmlformats.org/officeDocument/2006/relationships" id="264" r:id="R0bc94dad4cb644a4"/>
-    <p:sldId xmlns:r="http://schemas.openxmlformats.org/officeDocument/2006/relationships" id="265" r:id="Rac341822892a48ec"/>
-    <p:sldId xmlns:r="http://schemas.openxmlformats.org/officeDocument/2006/relationships" id="266" r:id="R1c4ca62f376b4830"/>
-    <p:sldId xmlns:r="http://schemas.openxmlformats.org/officeDocument/2006/relationships" id="267" r:id="R6cd67cf6b44a444a"/>
-    <p:sldId xmlns:r="http://schemas.openxmlformats.org/officeDocument/2006/relationships" id="268" r:id="R5c18fbe39c194400"/>
-    <p:sldId xmlns:r="http://schemas.openxmlformats.org/officeDocument/2006/relationships" id="269" r:id="Reabd8d33934a461a"/>
-    <p:sldId xmlns:r="http://schemas.openxmlformats.org/officeDocument/2006/relationships" id="270" r:id="Rc6b56d95944c40f7"/>
-    <p:sldId xmlns:r="http://schemas.openxmlformats.org/officeDocument/2006/relationships" id="271" r:id="R9da977b7f539423c"/>
-    <p:sldId xmlns:r="http://schemas.openxmlformats.org/officeDocument/2006/relationships" id="272" r:id="Redd75ea4df4e422c"/>
-    <p:sldId xmlns:r="http://schemas.openxmlformats.org/officeDocument/2006/relationships" id="273" r:id="Rc9755839bbbd4f02"/>
-    <p:sldId xmlns:r="http://schemas.openxmlformats.org/officeDocument/2006/relationships" id="274" r:id="R62958d95eed34294"/>
-    <p:sldId xmlns:r="http://schemas.openxmlformats.org/officeDocument/2006/relationships" id="275" r:id="Raeda8013d75342eb"/>
-    <p:sldId xmlns:r="http://schemas.openxmlformats.org/officeDocument/2006/relationships" id="276" r:id="Ra64c1ea03e344495"/>
+    <p:sldId xmlns:r="http://schemas.openxmlformats.org/officeDocument/2006/relationships" id="256" r:id="R22646d4e9dbf45ec"/>
+    <p:sldId xmlns:r="http://schemas.openxmlformats.org/officeDocument/2006/relationships" id="257" r:id="R65b057c3adde4ae3"/>
+    <p:sldId xmlns:r="http://schemas.openxmlformats.org/officeDocument/2006/relationships" id="258" r:id="Rd3cd4fd3c0174557"/>
+    <p:sldId xmlns:r="http://schemas.openxmlformats.org/officeDocument/2006/relationships" id="259" r:id="Ree9ae59f58c140b2"/>
+    <p:sldId xmlns:r="http://schemas.openxmlformats.org/officeDocument/2006/relationships" id="260" r:id="R57726b9bc9a74ecd"/>
+    <p:sldId xmlns:r="http://schemas.openxmlformats.org/officeDocument/2006/relationships" id="261" r:id="R673b4c1c0f974d91"/>
+    <p:sldId xmlns:r="http://schemas.openxmlformats.org/officeDocument/2006/relationships" id="262" r:id="R3370b79d4294474e"/>
+    <p:sldId xmlns:r="http://schemas.openxmlformats.org/officeDocument/2006/relationships" id="263" r:id="Rb4524805cdbe4118"/>
+    <p:sldId xmlns:r="http://schemas.openxmlformats.org/officeDocument/2006/relationships" id="264" r:id="Rd56e3ce49faf4c81"/>
+    <p:sldId xmlns:r="http://schemas.openxmlformats.org/officeDocument/2006/relationships" id="265" r:id="Rbb29af1807364f26"/>
+    <p:sldId xmlns:r="http://schemas.openxmlformats.org/officeDocument/2006/relationships" id="266" r:id="Rd0f835b6d67b4c8c"/>
+    <p:sldId xmlns:r="http://schemas.openxmlformats.org/officeDocument/2006/relationships" id="267" r:id="R392b50693ad645db"/>
+    <p:sldId xmlns:r="http://schemas.openxmlformats.org/officeDocument/2006/relationships" id="268" r:id="Rd2a730afbce44c12"/>
+    <p:sldId xmlns:r="http://schemas.openxmlformats.org/officeDocument/2006/relationships" id="269" r:id="Rd5e5ab0f65894dc1"/>
+    <p:sldId xmlns:r="http://schemas.openxmlformats.org/officeDocument/2006/relationships" id="270" r:id="R4cb1b28b9dd24f85"/>
+    <p:sldId xmlns:r="http://schemas.openxmlformats.org/officeDocument/2006/relationships" id="271" r:id="Rdd28663e89a04ed8"/>
+    <p:sldId xmlns:r="http://schemas.openxmlformats.org/officeDocument/2006/relationships" id="272" r:id="R468bab28fa5d4e2f"/>
+    <p:sldId xmlns:r="http://schemas.openxmlformats.org/officeDocument/2006/relationships" id="273" r:id="R80b42aca10d440a5"/>
+    <p:sldId xmlns:r="http://schemas.openxmlformats.org/officeDocument/2006/relationships" id="274" r:id="R1c1623584cb04482"/>
+    <p:sldId xmlns:r="http://schemas.openxmlformats.org/officeDocument/2006/relationships" id="275" r:id="R5172ee4ebd904628"/>
+    <p:sldId xmlns:r="http://schemas.openxmlformats.org/officeDocument/2006/relationships" id="276" r:id="R5abdf441cdac4115"/>
   </p:sldIdLst>
   <p:sldSz cx="12192000" cy="6858000"/>
   <p:notesSz cx="6858000" cy="9144000"/>
@@ -837,6 +837,11 @@
           </a:p>
           <a:p xmlns:a="http://schemas.openxmlformats.org/drawingml/2006/main">
             <a:r>
+              <a:t>- Tyler ADS address provided by Geoff Schackmann on August 6, 2026.</a:t>
+            </a:r>
+          </a:p>
+          <a:p xmlns:a="http://schemas.openxmlformats.org/drawingml/2006/main">
+            <a:r>
               <a:t>- Texas TULIP training guide: https://www.hhs.texas.gov/sites/default/files/documents/doing-business-with-hhs/licensing-credentialing-regulation/tulip/tulip-training-guide.pdf</a:t>
             </a:r>
           </a:p>
@@ -2300,7 +2305,7 @@
   </p:cSld>
   <p:clrMap bg1="lt1" tx1="dk1" bg2="lt2" tx2="dk2" accent1="accent1" accent2="accent2" accent3="accent3" accent4="accent4" accent5="accent5" accent6="accent6" hlink="hlink" folHlink="folHlink"/>
   <p:sldLayoutIdLst>
-    <p:sldLayoutId xmlns:r="http://schemas.openxmlformats.org/officeDocument/2006/relationships" id="2147483649" r:id="Rfb1b52610afd401b"/>
+    <p:sldLayoutId xmlns:r="http://schemas.openxmlformats.org/officeDocument/2006/relationships" id="2147483649" r:id="R875d2e46ca3d4408"/>
   </p:sldLayoutIdLst>
   <p:txStyles>
     <p:titleStyle>
@@ -2851,7 +2856,7 @@
           <p:cNvPr id="6" name="">
             <a:extLst xmlns:a="http://schemas.openxmlformats.org/drawingml/2006/main">
               <a:ext uri="{FF2B5EF4-FFF2-40B4-BE49-F238E27FC236}">
-                <a16:creationId xmlns:a16="http://schemas.microsoft.com/office/drawing/2014/main" id="{D13D9A70-E95F-4A72-82D6-CDEDC2C04148}"/>
+                <a16:creationId xmlns:a16="http://schemas.microsoft.com/office/drawing/2014/main" id="{D421D69F-2397-4ADB-86E8-AF87C691F98A}"/>
               </a:ext>
             </a:extLst>
           </p:cNvPr>
@@ -2903,7 +2908,7 @@
           <p:cNvPr id="2" name="">
             <a:extLst xmlns:a="http://schemas.openxmlformats.org/drawingml/2006/main">
               <a:ext uri="{FF2B5EF4-FFF2-40B4-BE49-F238E27FC236}">
-                <a16:creationId xmlns:a16="http://schemas.microsoft.com/office/drawing/2014/main" id="{907B3E59-68C3-4534-AB9E-20BEF08183FC}"/>
+                <a16:creationId xmlns:a16="http://schemas.microsoft.com/office/drawing/2014/main" id="{9CA4E0E3-0D6E-4A2D-A622-708BE6F5FC57}"/>
               </a:ext>
             </a:extLst>
           </p:cNvPr>
@@ -2972,7 +2977,7 @@
           <p:cNvPr id="3" name="">
             <a:extLst xmlns:a="http://schemas.openxmlformats.org/drawingml/2006/main">
               <a:ext uri="{FF2B5EF4-FFF2-40B4-BE49-F238E27FC236}">
-                <a16:creationId xmlns:a16="http://schemas.microsoft.com/office/drawing/2014/main" id="{3FD54CEE-E9A5-43A7-ADA8-C3E756238F0E}"/>
+                <a16:creationId xmlns:a16="http://schemas.microsoft.com/office/drawing/2014/main" id="{09F2DAEC-9ECE-4537-BB93-CD24DF943340}"/>
               </a:ext>
             </a:extLst>
           </p:cNvPr>
@@ -3003,7 +3008,7 @@
           <p:cNvPr id="4" name="">
             <a:extLst xmlns:a="http://schemas.openxmlformats.org/drawingml/2006/main">
               <a:ext uri="{FF2B5EF4-FFF2-40B4-BE49-F238E27FC236}">
-                <a16:creationId xmlns:a16="http://schemas.microsoft.com/office/drawing/2014/main" id="{9433822E-3E8D-4A7E-8536-93D463125478}"/>
+                <a16:creationId xmlns:a16="http://schemas.microsoft.com/office/drawing/2014/main" id="{32F74773-2440-4A1F-ADB8-B3609B247942}"/>
               </a:ext>
             </a:extLst>
           </p:cNvPr>
@@ -3055,7 +3060,7 @@
           <p:cNvPr id="5" name="">
             <a:extLst xmlns:a="http://schemas.openxmlformats.org/drawingml/2006/main">
               <a:ext uri="{FF2B5EF4-FFF2-40B4-BE49-F238E27FC236}">
-                <a16:creationId xmlns:a16="http://schemas.microsoft.com/office/drawing/2014/main" id="{E9F491E3-0430-4C9B-99E5-6592E541C8CE}"/>
+                <a16:creationId xmlns:a16="http://schemas.microsoft.com/office/drawing/2014/main" id="{44E4969D-1E5A-44AF-99EE-770F6D766EE1}"/>
               </a:ext>
             </a:extLst>
           </p:cNvPr>
@@ -3105,7 +3110,7 @@
     </p:spTree>
     <p:extLst>
       <p:ext uri="{BB962C8B-B14F-4D97-AF65-F5344CB8AC3E}">
-        <p14:creationId xmlns:p14="http://schemas.microsoft.com/office/powerpoint/2010/main" val="1212470243"/>
+        <p14:creationId xmlns:p14="http://schemas.microsoft.com/office/powerpoint/2010/main" val="1784785566"/>
       </p:ext>
     </p:extLst>
   </p:cSld>
@@ -3129,7 +3134,7 @@
           <p:cNvPr id="23" name="">
             <a:extLst xmlns:a="http://schemas.openxmlformats.org/drawingml/2006/main">
               <a:ext uri="{FF2B5EF4-FFF2-40B4-BE49-F238E27FC236}">
-                <a16:creationId xmlns:a16="http://schemas.microsoft.com/office/drawing/2014/main" id="{3D68686F-4E76-4752-915E-2BBE4DB9729D}"/>
+                <a16:creationId xmlns:a16="http://schemas.microsoft.com/office/drawing/2014/main" id="{69BE7D71-D94A-4485-9A36-ABF9063AFD8E}"/>
               </a:ext>
             </a:extLst>
           </p:cNvPr>
@@ -3181,7 +3186,7 @@
           <p:cNvPr id="2" name="">
             <a:extLst xmlns:a="http://schemas.openxmlformats.org/drawingml/2006/main">
               <a:ext uri="{FF2B5EF4-FFF2-40B4-BE49-F238E27FC236}">
-                <a16:creationId xmlns:a16="http://schemas.microsoft.com/office/drawing/2014/main" id="{267316E6-0A6B-4AC5-83D9-52D85547B998}"/>
+                <a16:creationId xmlns:a16="http://schemas.microsoft.com/office/drawing/2014/main" id="{F84BEE24-D826-40C4-9407-4488415FD351}"/>
               </a:ext>
             </a:extLst>
           </p:cNvPr>
@@ -3255,7 +3260,7 @@
           <p:cNvPr id="4" name="">
             <a:extLst xmlns:a="http://schemas.openxmlformats.org/drawingml/2006/main">
               <a:ext uri="{FF2B5EF4-FFF2-40B4-BE49-F238E27FC236}">
-                <a16:creationId xmlns:a16="http://schemas.microsoft.com/office/drawing/2014/main" id="{98383E1E-BF26-4BDB-8ED3-28A277FAC395}"/>
+                <a16:creationId xmlns:a16="http://schemas.microsoft.com/office/drawing/2014/main" id="{4F0AEFBE-BC1B-4691-9486-FE56B7933816}"/>
               </a:ext>
             </a:extLst>
           </p:cNvPr>
@@ -3307,7 +3312,7 @@
           <p:cNvPr id="5" name="">
             <a:extLst xmlns:a="http://schemas.openxmlformats.org/drawingml/2006/main">
               <a:ext uri="{FF2B5EF4-FFF2-40B4-BE49-F238E27FC236}">
-                <a16:creationId xmlns:a16="http://schemas.microsoft.com/office/drawing/2014/main" id="{3A4CD085-147C-4907-9D66-01FA5DB1DA74}"/>
+                <a16:creationId xmlns:a16="http://schemas.microsoft.com/office/drawing/2014/main" id="{15D19BED-E7A5-44D3-A257-0720C1A0B5D7}"/>
               </a:ext>
             </a:extLst>
           </p:cNvPr>
@@ -3359,7 +3364,7 @@
           <p:cNvPr id="6" name="">
             <a:extLst xmlns:a="http://schemas.openxmlformats.org/drawingml/2006/main">
               <a:ext uri="{FF2B5EF4-FFF2-40B4-BE49-F238E27FC236}">
-                <a16:creationId xmlns:a16="http://schemas.microsoft.com/office/drawing/2014/main" id="{46CFB4EA-43D0-403C-B4A6-68FCEE4E49EC}"/>
+                <a16:creationId xmlns:a16="http://schemas.microsoft.com/office/drawing/2014/main" id="{87DCCC5F-EB77-4D0E-BFDD-2890E4DD7BDD}"/>
               </a:ext>
             </a:extLst>
           </p:cNvPr>
@@ -3411,7 +3416,7 @@
           <p:cNvPr id="7" name="">
             <a:extLst xmlns:a="http://schemas.openxmlformats.org/drawingml/2006/main">
               <a:ext uri="{FF2B5EF4-FFF2-40B4-BE49-F238E27FC236}">
-                <a16:creationId xmlns:a16="http://schemas.microsoft.com/office/drawing/2014/main" id="{86D6DC2C-E8AC-4BE0-8B80-ABC70ADCC620}"/>
+                <a16:creationId xmlns:a16="http://schemas.microsoft.com/office/drawing/2014/main" id="{7AD8121C-75E3-4426-BDE5-2A1B2B69A6BE}"/>
               </a:ext>
             </a:extLst>
           </p:cNvPr>
@@ -3444,7 +3449,7 @@
           <p:cNvPr id="8" name="">
             <a:extLst xmlns:a="http://schemas.openxmlformats.org/drawingml/2006/main">
               <a:ext uri="{FF2B5EF4-FFF2-40B4-BE49-F238E27FC236}">
-                <a16:creationId xmlns:a16="http://schemas.microsoft.com/office/drawing/2014/main" id="{8DB0FEB5-153E-43BA-BC31-2D1672E65920}"/>
+                <a16:creationId xmlns:a16="http://schemas.microsoft.com/office/drawing/2014/main" id="{E09D9C39-B9BE-4426-891D-7D76AE060CC1}"/>
               </a:ext>
             </a:extLst>
           </p:cNvPr>
@@ -3496,7 +3501,7 @@
           <p:cNvPr id="9" name="">
             <a:extLst xmlns:a="http://schemas.openxmlformats.org/drawingml/2006/main">
               <a:ext uri="{FF2B5EF4-FFF2-40B4-BE49-F238E27FC236}">
-                <a16:creationId xmlns:a16="http://schemas.microsoft.com/office/drawing/2014/main" id="{446EBBEA-D662-4FCD-A0E3-EC8C07970C8F}"/>
+                <a16:creationId xmlns:a16="http://schemas.microsoft.com/office/drawing/2014/main" id="{288BF50C-7DDF-4018-89B8-4B1474D671EB}"/>
               </a:ext>
             </a:extLst>
           </p:cNvPr>
@@ -3548,7 +3553,7 @@
           <p:cNvPr id="10" name="">
             <a:extLst xmlns:a="http://schemas.openxmlformats.org/drawingml/2006/main">
               <a:ext uri="{FF2B5EF4-FFF2-40B4-BE49-F238E27FC236}">
-                <a16:creationId xmlns:a16="http://schemas.microsoft.com/office/drawing/2014/main" id="{067FA5D3-F5E9-482A-8B94-B6C693F68C3B}"/>
+                <a16:creationId xmlns:a16="http://schemas.microsoft.com/office/drawing/2014/main" id="{70EC2FC8-0F0E-4CDD-999D-54B1EFE4631D}"/>
               </a:ext>
             </a:extLst>
           </p:cNvPr>
@@ -3600,7 +3605,7 @@
           <p:cNvPr id="11" name="">
             <a:extLst xmlns:a="http://schemas.openxmlformats.org/drawingml/2006/main">
               <a:ext uri="{FF2B5EF4-FFF2-40B4-BE49-F238E27FC236}">
-                <a16:creationId xmlns:a16="http://schemas.microsoft.com/office/drawing/2014/main" id="{C6D3E426-68A7-47EC-92C1-8A2704CF611C}"/>
+                <a16:creationId xmlns:a16="http://schemas.microsoft.com/office/drawing/2014/main" id="{DBE1EFC3-0FF6-488B-8EC8-7ABA0F756FBA}"/>
               </a:ext>
             </a:extLst>
           </p:cNvPr>
@@ -3633,7 +3638,7 @@
           <p:cNvPr id="12" name="">
             <a:extLst xmlns:a="http://schemas.openxmlformats.org/drawingml/2006/main">
               <a:ext uri="{FF2B5EF4-FFF2-40B4-BE49-F238E27FC236}">
-                <a16:creationId xmlns:a16="http://schemas.microsoft.com/office/drawing/2014/main" id="{E9B3720C-45DD-4828-962D-04ACC96C222D}"/>
+                <a16:creationId xmlns:a16="http://schemas.microsoft.com/office/drawing/2014/main" id="{042D85AA-EF03-406A-B238-CD693E1AE004}"/>
               </a:ext>
             </a:extLst>
           </p:cNvPr>
@@ -3685,7 +3690,7 @@
           <p:cNvPr id="13" name="">
             <a:extLst xmlns:a="http://schemas.openxmlformats.org/drawingml/2006/main">
               <a:ext uri="{FF2B5EF4-FFF2-40B4-BE49-F238E27FC236}">
-                <a16:creationId xmlns:a16="http://schemas.microsoft.com/office/drawing/2014/main" id="{59AF955B-2BC3-4B73-9CAB-FF0689DC5F24}"/>
+                <a16:creationId xmlns:a16="http://schemas.microsoft.com/office/drawing/2014/main" id="{F1FD077A-0EDF-49E8-8F85-31C090B0E918}"/>
               </a:ext>
             </a:extLst>
           </p:cNvPr>
@@ -3737,7 +3742,7 @@
           <p:cNvPr id="14" name="">
             <a:extLst xmlns:a="http://schemas.openxmlformats.org/drawingml/2006/main">
               <a:ext uri="{FF2B5EF4-FFF2-40B4-BE49-F238E27FC236}">
-                <a16:creationId xmlns:a16="http://schemas.microsoft.com/office/drawing/2014/main" id="{496B2FFC-496E-40D3-94AB-A348BE825525}"/>
+                <a16:creationId xmlns:a16="http://schemas.microsoft.com/office/drawing/2014/main" id="{084C2F36-F10A-4790-ADE9-221DD94D28A8}"/>
               </a:ext>
             </a:extLst>
           </p:cNvPr>
@@ -3789,7 +3794,7 @@
           <p:cNvPr id="15" name="">
             <a:extLst xmlns:a="http://schemas.openxmlformats.org/drawingml/2006/main">
               <a:ext uri="{FF2B5EF4-FFF2-40B4-BE49-F238E27FC236}">
-                <a16:creationId xmlns:a16="http://schemas.microsoft.com/office/drawing/2014/main" id="{140CA875-FA21-4757-9FD7-C92948CB92DE}"/>
+                <a16:creationId xmlns:a16="http://schemas.microsoft.com/office/drawing/2014/main" id="{A63F7F7B-EED5-466E-B721-5F99A66FB463}"/>
               </a:ext>
             </a:extLst>
           </p:cNvPr>
@@ -3822,7 +3827,7 @@
           <p:cNvPr id="16" name="">
             <a:extLst xmlns:a="http://schemas.openxmlformats.org/drawingml/2006/main">
               <a:ext uri="{FF2B5EF4-FFF2-40B4-BE49-F238E27FC236}">
-                <a16:creationId xmlns:a16="http://schemas.microsoft.com/office/drawing/2014/main" id="{EB7977F0-760B-4E95-A660-92F29E4F01EC}"/>
+                <a16:creationId xmlns:a16="http://schemas.microsoft.com/office/drawing/2014/main" id="{BF19B233-C876-4F85-9504-8726D427B2BC}"/>
               </a:ext>
             </a:extLst>
           </p:cNvPr>
@@ -3874,7 +3879,7 @@
           <p:cNvPr id="17" name="">
             <a:extLst xmlns:a="http://schemas.openxmlformats.org/drawingml/2006/main">
               <a:ext uri="{FF2B5EF4-FFF2-40B4-BE49-F238E27FC236}">
-                <a16:creationId xmlns:a16="http://schemas.microsoft.com/office/drawing/2014/main" id="{98F832FF-8ED7-4B29-9AAD-3992D71D02D3}"/>
+                <a16:creationId xmlns:a16="http://schemas.microsoft.com/office/drawing/2014/main" id="{14CCB056-8050-4B81-862C-6B6990A724E0}"/>
               </a:ext>
             </a:extLst>
           </p:cNvPr>
@@ -3926,7 +3931,7 @@
           <p:cNvPr id="18" name="">
             <a:extLst xmlns:a="http://schemas.openxmlformats.org/drawingml/2006/main">
               <a:ext uri="{FF2B5EF4-FFF2-40B4-BE49-F238E27FC236}">
-                <a16:creationId xmlns:a16="http://schemas.microsoft.com/office/drawing/2014/main" id="{55E1B813-F4AC-4DA3-9077-A922FD26E51E}"/>
+                <a16:creationId xmlns:a16="http://schemas.microsoft.com/office/drawing/2014/main" id="{1822FBCB-E9EE-4C5F-B5D4-316A4C6E0287}"/>
               </a:ext>
             </a:extLst>
           </p:cNvPr>
@@ -3978,7 +3983,7 @@
           <p:cNvPr id="19" name="">
             <a:extLst xmlns:a="http://schemas.openxmlformats.org/drawingml/2006/main">
               <a:ext uri="{FF2B5EF4-FFF2-40B4-BE49-F238E27FC236}">
-                <a16:creationId xmlns:a16="http://schemas.microsoft.com/office/drawing/2014/main" id="{EF729D78-2AAD-4B21-9C70-F97203E204FB}"/>
+                <a16:creationId xmlns:a16="http://schemas.microsoft.com/office/drawing/2014/main" id="{7BC92C51-992F-492E-AE26-5AFD76E62B3F}"/>
               </a:ext>
             </a:extLst>
           </p:cNvPr>
@@ -4011,7 +4016,7 @@
           <p:cNvPr id="20" name="">
             <a:extLst xmlns:a="http://schemas.openxmlformats.org/drawingml/2006/main">
               <a:ext uri="{FF2B5EF4-FFF2-40B4-BE49-F238E27FC236}">
-                <a16:creationId xmlns:a16="http://schemas.microsoft.com/office/drawing/2014/main" id="{C1850DCC-55C4-4420-9312-71B7F2305CE0}"/>
+                <a16:creationId xmlns:a16="http://schemas.microsoft.com/office/drawing/2014/main" id="{3FD4EA6A-DE83-4B28-9F7A-61C5DBB66666}"/>
               </a:ext>
             </a:extLst>
           </p:cNvPr>
@@ -4063,7 +4068,7 @@
           <p:cNvPr id="21" name="">
             <a:extLst xmlns:a="http://schemas.openxmlformats.org/drawingml/2006/main">
               <a:ext uri="{FF2B5EF4-FFF2-40B4-BE49-F238E27FC236}">
-                <a16:creationId xmlns:a16="http://schemas.microsoft.com/office/drawing/2014/main" id="{3DB3A0E6-8F65-4116-8F3A-BFE86C006797}"/>
+                <a16:creationId xmlns:a16="http://schemas.microsoft.com/office/drawing/2014/main" id="{B7EB3A25-EC4A-4995-AA69-8158CC765BFE}"/>
               </a:ext>
             </a:extLst>
           </p:cNvPr>
@@ -4115,7 +4120,7 @@
           <p:cNvPr id="22" name="">
             <a:extLst xmlns:a="http://schemas.openxmlformats.org/drawingml/2006/main">
               <a:ext uri="{FF2B5EF4-FFF2-40B4-BE49-F238E27FC236}">
-                <a16:creationId xmlns:a16="http://schemas.microsoft.com/office/drawing/2014/main" id="{BF37148A-A51E-4DC8-89BE-FF47A503AA9F}"/>
+                <a16:creationId xmlns:a16="http://schemas.microsoft.com/office/drawing/2014/main" id="{2123ED43-8464-4F67-B513-8892D5FEB5F6}"/>
               </a:ext>
             </a:extLst>
           </p:cNvPr>
@@ -4165,7 +4170,7 @@
     </p:spTree>
     <p:extLst>
       <p:ext uri="{BB962C8B-B14F-4D97-AF65-F5344CB8AC3E}">
-        <p14:creationId xmlns:p14="http://schemas.microsoft.com/office/powerpoint/2010/main" val="228515258"/>
+        <p14:creationId xmlns:p14="http://schemas.microsoft.com/office/powerpoint/2010/main" val="1773732028"/>
       </p:ext>
     </p:extLst>
   </p:cSld>
@@ -4189,7 +4194,7 @@
           <p:cNvPr id="13" name="">
             <a:extLst xmlns:a="http://schemas.openxmlformats.org/drawingml/2006/main">
               <a:ext uri="{FF2B5EF4-FFF2-40B4-BE49-F238E27FC236}">
-                <a16:creationId xmlns:a16="http://schemas.microsoft.com/office/drawing/2014/main" id="{06F33D8D-E639-42A5-A3C0-A62FA91EC933}"/>
+                <a16:creationId xmlns:a16="http://schemas.microsoft.com/office/drawing/2014/main" id="{6426C410-FC67-477A-8CA1-7AA327466C2B}"/>
               </a:ext>
             </a:extLst>
           </p:cNvPr>
@@ -4241,7 +4246,7 @@
           <p:cNvPr id="2" name="">
             <a:extLst xmlns:a="http://schemas.openxmlformats.org/drawingml/2006/main">
               <a:ext uri="{FF2B5EF4-FFF2-40B4-BE49-F238E27FC236}">
-                <a16:creationId xmlns:a16="http://schemas.microsoft.com/office/drawing/2014/main" id="{CB5B3866-D8E4-4382-99A5-9DC0B0F6CEBD}"/>
+                <a16:creationId xmlns:a16="http://schemas.microsoft.com/office/drawing/2014/main" id="{340D6704-320A-4963-8FAB-BC4E43A1750B}"/>
               </a:ext>
             </a:extLst>
           </p:cNvPr>
@@ -4315,7 +4320,7 @@
           <p:cNvPr id="4" name="">
             <a:extLst xmlns:a="http://schemas.openxmlformats.org/drawingml/2006/main">
               <a:ext uri="{FF2B5EF4-FFF2-40B4-BE49-F238E27FC236}">
-                <a16:creationId xmlns:a16="http://schemas.microsoft.com/office/drawing/2014/main" id="{BFE0D9E1-70B8-49C1-B454-F9CA2E0692EC}"/>
+                <a16:creationId xmlns:a16="http://schemas.microsoft.com/office/drawing/2014/main" id="{920D07EA-CF97-4F25-BD8C-2AD87E2CB7DD}"/>
               </a:ext>
             </a:extLst>
           </p:cNvPr>
@@ -4367,7 +4372,7 @@
           <p:cNvPr id="5" name="">
             <a:extLst xmlns:a="http://schemas.openxmlformats.org/drawingml/2006/main">
               <a:ext uri="{FF2B5EF4-FFF2-40B4-BE49-F238E27FC236}">
-                <a16:creationId xmlns:a16="http://schemas.microsoft.com/office/drawing/2014/main" id="{7A11CF90-A8EB-4F14-8784-F8EB5DD4DE2A}"/>
+                <a16:creationId xmlns:a16="http://schemas.microsoft.com/office/drawing/2014/main" id="{58B288BA-F4DA-42B0-8E33-8FF99BA0EB74}"/>
               </a:ext>
             </a:extLst>
           </p:cNvPr>
@@ -4398,7 +4403,7 @@
           <p:cNvPr id="6" name="">
             <a:extLst xmlns:a="http://schemas.openxmlformats.org/drawingml/2006/main">
               <a:ext uri="{FF2B5EF4-FFF2-40B4-BE49-F238E27FC236}">
-                <a16:creationId xmlns:a16="http://schemas.microsoft.com/office/drawing/2014/main" id="{52E26B38-A811-48E1-8CD3-4B8C33568FF9}"/>
+                <a16:creationId xmlns:a16="http://schemas.microsoft.com/office/drawing/2014/main" id="{AEF98DA5-310E-4FC0-AC37-EC142E1CD32D}"/>
               </a:ext>
             </a:extLst>
           </p:cNvPr>
@@ -4450,7 +4455,7 @@
           <p:cNvPr id="7" name="">
             <a:extLst xmlns:a="http://schemas.openxmlformats.org/drawingml/2006/main">
               <a:ext uri="{FF2B5EF4-FFF2-40B4-BE49-F238E27FC236}">
-                <a16:creationId xmlns:a16="http://schemas.microsoft.com/office/drawing/2014/main" id="{45A6E621-7BDB-4EC3-AB4C-45FC3EA954B2}"/>
+                <a16:creationId xmlns:a16="http://schemas.microsoft.com/office/drawing/2014/main" id="{76454520-BBEF-4DCE-99BA-B2AF4147E0B1}"/>
               </a:ext>
             </a:extLst>
           </p:cNvPr>
@@ -4587,7 +4592,7 @@
           <p:cNvPr id="8" name="">
             <a:extLst xmlns:a="http://schemas.openxmlformats.org/drawingml/2006/main">
               <a:ext uri="{FF2B5EF4-FFF2-40B4-BE49-F238E27FC236}">
-                <a16:creationId xmlns:a16="http://schemas.microsoft.com/office/drawing/2014/main" id="{2B23818B-8986-4B05-A777-D44519A2D7AC}"/>
+                <a16:creationId xmlns:a16="http://schemas.microsoft.com/office/drawing/2014/main" id="{3D9C8425-D80F-4614-BA57-A910EC494BEF}"/>
               </a:ext>
             </a:extLst>
           </p:cNvPr>
@@ -4618,7 +4623,7 @@
           <p:cNvPr id="9" name="">
             <a:extLst xmlns:a="http://schemas.openxmlformats.org/drawingml/2006/main">
               <a:ext uri="{FF2B5EF4-FFF2-40B4-BE49-F238E27FC236}">
-                <a16:creationId xmlns:a16="http://schemas.microsoft.com/office/drawing/2014/main" id="{2E14DA61-FEEA-49C5-B980-4FD3AA736777}"/>
+                <a16:creationId xmlns:a16="http://schemas.microsoft.com/office/drawing/2014/main" id="{5CEDB89E-1D3C-4D6E-A1C3-688181252885}"/>
               </a:ext>
             </a:extLst>
           </p:cNvPr>
@@ -4670,7 +4675,7 @@
           <p:cNvPr id="10" name="">
             <a:extLst xmlns:a="http://schemas.openxmlformats.org/drawingml/2006/main">
               <a:ext uri="{FF2B5EF4-FFF2-40B4-BE49-F238E27FC236}">
-                <a16:creationId xmlns:a16="http://schemas.microsoft.com/office/drawing/2014/main" id="{8B77EB0D-3BC6-49FC-8989-B30513B2DAF0}"/>
+                <a16:creationId xmlns:a16="http://schemas.microsoft.com/office/drawing/2014/main" id="{F150C4CB-A877-47B8-972F-A35CDFBB8070}"/>
               </a:ext>
             </a:extLst>
           </p:cNvPr>
@@ -4807,7 +4812,7 @@
           <p:cNvPr id="11" name="">
             <a:extLst xmlns:a="http://schemas.openxmlformats.org/drawingml/2006/main">
               <a:ext uri="{FF2B5EF4-FFF2-40B4-BE49-F238E27FC236}">
-                <a16:creationId xmlns:a16="http://schemas.microsoft.com/office/drawing/2014/main" id="{B9682F32-536E-4CF6-97EA-9E8401693464}"/>
+                <a16:creationId xmlns:a16="http://schemas.microsoft.com/office/drawing/2014/main" id="{8EA7CBE7-6742-4C80-B592-96B44BB0708B}"/>
               </a:ext>
             </a:extLst>
           </p:cNvPr>
@@ -4859,7 +4864,7 @@
           <p:cNvPr id="12" name="">
             <a:extLst xmlns:a="http://schemas.openxmlformats.org/drawingml/2006/main">
               <a:ext uri="{FF2B5EF4-FFF2-40B4-BE49-F238E27FC236}">
-                <a16:creationId xmlns:a16="http://schemas.microsoft.com/office/drawing/2014/main" id="{2620C6F8-535B-467F-B2CB-B71B4106D5F9}"/>
+                <a16:creationId xmlns:a16="http://schemas.microsoft.com/office/drawing/2014/main" id="{0471A072-5607-441D-AB6E-2F239B9CC017}"/>
               </a:ext>
             </a:extLst>
           </p:cNvPr>
@@ -4909,7 +4914,7 @@
     </p:spTree>
     <p:extLst>
       <p:ext uri="{BB962C8B-B14F-4D97-AF65-F5344CB8AC3E}">
-        <p14:creationId xmlns:p14="http://schemas.microsoft.com/office/powerpoint/2010/main" val="1232476372"/>
+        <p14:creationId xmlns:p14="http://schemas.microsoft.com/office/powerpoint/2010/main" val="741310600"/>
       </p:ext>
     </p:extLst>
   </p:cSld>
@@ -4933,7 +4938,7 @@
           <p:cNvPr id="24" name="">
             <a:extLst xmlns:a="http://schemas.openxmlformats.org/drawingml/2006/main">
               <a:ext uri="{FF2B5EF4-FFF2-40B4-BE49-F238E27FC236}">
-                <a16:creationId xmlns:a16="http://schemas.microsoft.com/office/drawing/2014/main" id="{4EA5660A-B6C9-4BC5-9E0D-A23D59F691C3}"/>
+                <a16:creationId xmlns:a16="http://schemas.microsoft.com/office/drawing/2014/main" id="{FF8A6B5C-184D-4C50-B72E-C359408AB7D9}"/>
               </a:ext>
             </a:extLst>
           </p:cNvPr>
@@ -4985,7 +4990,7 @@
           <p:cNvPr id="2" name="">
             <a:extLst xmlns:a="http://schemas.openxmlformats.org/drawingml/2006/main">
               <a:ext uri="{FF2B5EF4-FFF2-40B4-BE49-F238E27FC236}">
-                <a16:creationId xmlns:a16="http://schemas.microsoft.com/office/drawing/2014/main" id="{D2652BA4-7BBB-4AF5-BEFC-9890A88C8F89}"/>
+                <a16:creationId xmlns:a16="http://schemas.microsoft.com/office/drawing/2014/main" id="{D13B03B0-10CF-49B6-B194-CD722B32A0A3}"/>
               </a:ext>
             </a:extLst>
           </p:cNvPr>
@@ -5059,7 +5064,7 @@
           <p:cNvPr id="4" name="">
             <a:extLst xmlns:a="http://schemas.openxmlformats.org/drawingml/2006/main">
               <a:ext uri="{FF2B5EF4-FFF2-40B4-BE49-F238E27FC236}">
-                <a16:creationId xmlns:a16="http://schemas.microsoft.com/office/drawing/2014/main" id="{7A8C44D2-6BD7-421A-8E95-5763D8B47B5D}"/>
+                <a16:creationId xmlns:a16="http://schemas.microsoft.com/office/drawing/2014/main" id="{44A07EE6-3B92-4C5F-BF56-D0EA5DDF49B2}"/>
               </a:ext>
             </a:extLst>
           </p:cNvPr>
@@ -5177,7 +5182,7 @@
           <p:cNvPr id="8" name="">
             <a:extLst xmlns:a="http://schemas.openxmlformats.org/drawingml/2006/main">
               <a:ext uri="{FF2B5EF4-FFF2-40B4-BE49-F238E27FC236}">
-                <a16:creationId xmlns:a16="http://schemas.microsoft.com/office/drawing/2014/main" id="{6DB8A866-3010-4648-B493-EBAFCDB5986F}"/>
+                <a16:creationId xmlns:a16="http://schemas.microsoft.com/office/drawing/2014/main" id="{7A1591B2-7B85-42A7-9227-2BFFF1BF792D}"/>
               </a:ext>
             </a:extLst>
           </p:cNvPr>
@@ -5208,7 +5213,7 @@
           <p:cNvPr id="9" name="">
             <a:extLst xmlns:a="http://schemas.openxmlformats.org/drawingml/2006/main">
               <a:ext uri="{FF2B5EF4-FFF2-40B4-BE49-F238E27FC236}">
-                <a16:creationId xmlns:a16="http://schemas.microsoft.com/office/drawing/2014/main" id="{B264CC91-C3A6-4453-8A7C-C240E8E07FCE}"/>
+                <a16:creationId xmlns:a16="http://schemas.microsoft.com/office/drawing/2014/main" id="{DE0408B6-F111-489B-8F52-16FFE2D105CA}"/>
               </a:ext>
             </a:extLst>
           </p:cNvPr>
@@ -5260,7 +5265,7 @@
           <p:cNvPr id="10" name="">
             <a:extLst xmlns:a="http://schemas.openxmlformats.org/drawingml/2006/main">
               <a:ext uri="{FF2B5EF4-FFF2-40B4-BE49-F238E27FC236}">
-                <a16:creationId xmlns:a16="http://schemas.microsoft.com/office/drawing/2014/main" id="{8D9FD4A2-8333-49E7-83B2-B2AD4BE5671E}"/>
+                <a16:creationId xmlns:a16="http://schemas.microsoft.com/office/drawing/2014/main" id="{37B77CFD-5DFA-4DEE-BDF9-CC23F0E26F1F}"/>
               </a:ext>
             </a:extLst>
           </p:cNvPr>
@@ -5312,7 +5317,7 @@
           <p:cNvPr id="11" name="">
             <a:extLst xmlns:a="http://schemas.openxmlformats.org/drawingml/2006/main">
               <a:ext uri="{FF2B5EF4-FFF2-40B4-BE49-F238E27FC236}">
-                <a16:creationId xmlns:a16="http://schemas.microsoft.com/office/drawing/2014/main" id="{847D1A88-7773-46BB-8E65-EA79A698C5E2}"/>
+                <a16:creationId xmlns:a16="http://schemas.microsoft.com/office/drawing/2014/main" id="{C8C81F54-89CC-48A1-AF02-FF08952B3CD6}"/>
               </a:ext>
             </a:extLst>
           </p:cNvPr>
@@ -5343,7 +5348,7 @@
           <p:cNvPr id="12" name="">
             <a:extLst xmlns:a="http://schemas.openxmlformats.org/drawingml/2006/main">
               <a:ext uri="{FF2B5EF4-FFF2-40B4-BE49-F238E27FC236}">
-                <a16:creationId xmlns:a16="http://schemas.microsoft.com/office/drawing/2014/main" id="{69EDBBCA-C777-4000-97AF-D5A1BFBDB84C}"/>
+                <a16:creationId xmlns:a16="http://schemas.microsoft.com/office/drawing/2014/main" id="{824860E5-675D-46BB-A3CF-3F6D599A937D}"/>
               </a:ext>
             </a:extLst>
           </p:cNvPr>
@@ -5395,7 +5400,7 @@
           <p:cNvPr id="13" name="">
             <a:extLst xmlns:a="http://schemas.openxmlformats.org/drawingml/2006/main">
               <a:ext uri="{FF2B5EF4-FFF2-40B4-BE49-F238E27FC236}">
-                <a16:creationId xmlns:a16="http://schemas.microsoft.com/office/drawing/2014/main" id="{E8273833-2AC8-4140-A921-937209BBC22F}"/>
+                <a16:creationId xmlns:a16="http://schemas.microsoft.com/office/drawing/2014/main" id="{A8441EF9-1156-430A-86C3-99A92EF5B594}"/>
               </a:ext>
             </a:extLst>
           </p:cNvPr>
@@ -5447,7 +5452,7 @@
           <p:cNvPr id="14" name="">
             <a:extLst xmlns:a="http://schemas.openxmlformats.org/drawingml/2006/main">
               <a:ext uri="{FF2B5EF4-FFF2-40B4-BE49-F238E27FC236}">
-                <a16:creationId xmlns:a16="http://schemas.microsoft.com/office/drawing/2014/main" id="{FD7E3D86-AE3B-41AD-AD02-785EFE4A619B}"/>
+                <a16:creationId xmlns:a16="http://schemas.microsoft.com/office/drawing/2014/main" id="{6E4F0D7A-2767-46B2-B0D6-262EEEE8E64E}"/>
               </a:ext>
             </a:extLst>
           </p:cNvPr>
@@ -5478,7 +5483,7 @@
           <p:cNvPr id="15" name="">
             <a:extLst xmlns:a="http://schemas.openxmlformats.org/drawingml/2006/main">
               <a:ext uri="{FF2B5EF4-FFF2-40B4-BE49-F238E27FC236}">
-                <a16:creationId xmlns:a16="http://schemas.microsoft.com/office/drawing/2014/main" id="{6363BA36-7A2D-435B-A6DB-41BC3A67C47E}"/>
+                <a16:creationId xmlns:a16="http://schemas.microsoft.com/office/drawing/2014/main" id="{D224D600-6D38-4BB7-9B97-3FF0F0211200}"/>
               </a:ext>
             </a:extLst>
           </p:cNvPr>
@@ -5530,7 +5535,7 @@
           <p:cNvPr id="16" name="">
             <a:extLst xmlns:a="http://schemas.openxmlformats.org/drawingml/2006/main">
               <a:ext uri="{FF2B5EF4-FFF2-40B4-BE49-F238E27FC236}">
-                <a16:creationId xmlns:a16="http://schemas.microsoft.com/office/drawing/2014/main" id="{0227159B-A91F-4C04-98EE-CBB48E3E3E0B}"/>
+                <a16:creationId xmlns:a16="http://schemas.microsoft.com/office/drawing/2014/main" id="{DAB00A2F-0F5F-4653-A627-63278C552887}"/>
               </a:ext>
             </a:extLst>
           </p:cNvPr>
@@ -5582,7 +5587,7 @@
           <p:cNvPr id="17" name="">
             <a:extLst xmlns:a="http://schemas.openxmlformats.org/drawingml/2006/main">
               <a:ext uri="{FF2B5EF4-FFF2-40B4-BE49-F238E27FC236}">
-                <a16:creationId xmlns:a16="http://schemas.microsoft.com/office/drawing/2014/main" id="{71A1243B-7266-4777-87E4-81CF049205A3}"/>
+                <a16:creationId xmlns:a16="http://schemas.microsoft.com/office/drawing/2014/main" id="{41E4B787-EC96-49BD-9973-C09EC09FC3C4}"/>
               </a:ext>
             </a:extLst>
           </p:cNvPr>
@@ -5613,7 +5618,7 @@
           <p:cNvPr id="18" name="">
             <a:extLst xmlns:a="http://schemas.openxmlformats.org/drawingml/2006/main">
               <a:ext uri="{FF2B5EF4-FFF2-40B4-BE49-F238E27FC236}">
-                <a16:creationId xmlns:a16="http://schemas.microsoft.com/office/drawing/2014/main" id="{0EF53409-A205-433C-B84B-1BB2AA96D852}"/>
+                <a16:creationId xmlns:a16="http://schemas.microsoft.com/office/drawing/2014/main" id="{3C9B6014-B670-4360-8FF8-980AFC786D95}"/>
               </a:ext>
             </a:extLst>
           </p:cNvPr>
@@ -5665,7 +5670,7 @@
           <p:cNvPr id="19" name="">
             <a:extLst xmlns:a="http://schemas.openxmlformats.org/drawingml/2006/main">
               <a:ext uri="{FF2B5EF4-FFF2-40B4-BE49-F238E27FC236}">
-                <a16:creationId xmlns:a16="http://schemas.microsoft.com/office/drawing/2014/main" id="{9E97C234-29CF-4D34-AA07-D61D0E1A12AF}"/>
+                <a16:creationId xmlns:a16="http://schemas.microsoft.com/office/drawing/2014/main" id="{95F99FA4-E1C7-4DD1-AD31-2FA087F1825D}"/>
               </a:ext>
             </a:extLst>
           </p:cNvPr>
@@ -5717,7 +5722,7 @@
           <p:cNvPr id="20" name="">
             <a:extLst xmlns:a="http://schemas.openxmlformats.org/drawingml/2006/main">
               <a:ext uri="{FF2B5EF4-FFF2-40B4-BE49-F238E27FC236}">
-                <a16:creationId xmlns:a16="http://schemas.microsoft.com/office/drawing/2014/main" id="{17544B78-41FD-4E23-A1A3-EAA0E9A43C7E}"/>
+                <a16:creationId xmlns:a16="http://schemas.microsoft.com/office/drawing/2014/main" id="{41A20225-5FA1-48D2-92EF-AEE141EDBD1F}"/>
               </a:ext>
             </a:extLst>
           </p:cNvPr>
@@ -5769,7 +5774,7 @@
           <p:cNvPr id="21" name="">
             <a:extLst xmlns:a="http://schemas.openxmlformats.org/drawingml/2006/main">
               <a:ext uri="{FF2B5EF4-FFF2-40B4-BE49-F238E27FC236}">
-                <a16:creationId xmlns:a16="http://schemas.microsoft.com/office/drawing/2014/main" id="{5953249B-30C3-4E73-A839-C3D33D9B8CE5}"/>
+                <a16:creationId xmlns:a16="http://schemas.microsoft.com/office/drawing/2014/main" id="{F4180DC0-A15B-43E1-8002-612ABBCB5023}"/>
               </a:ext>
             </a:extLst>
           </p:cNvPr>
@@ -5889,7 +5894,7 @@
           <p:cNvPr id="22" name="">
             <a:extLst xmlns:a="http://schemas.openxmlformats.org/drawingml/2006/main">
               <a:ext uri="{FF2B5EF4-FFF2-40B4-BE49-F238E27FC236}">
-                <a16:creationId xmlns:a16="http://schemas.microsoft.com/office/drawing/2014/main" id="{92A929AA-0ACC-4FB5-BC23-78D7746F0740}"/>
+                <a16:creationId xmlns:a16="http://schemas.microsoft.com/office/drawing/2014/main" id="{BA242D9B-C444-4CD7-9C25-E2096B713C2E}"/>
               </a:ext>
             </a:extLst>
           </p:cNvPr>
@@ -5941,7 +5946,7 @@
           <p:cNvPr id="23" name="">
             <a:extLst xmlns:a="http://schemas.openxmlformats.org/drawingml/2006/main">
               <a:ext uri="{FF2B5EF4-FFF2-40B4-BE49-F238E27FC236}">
-                <a16:creationId xmlns:a16="http://schemas.microsoft.com/office/drawing/2014/main" id="{E3D7AB59-03B0-4934-8A3E-587EF130DDDD}"/>
+                <a16:creationId xmlns:a16="http://schemas.microsoft.com/office/drawing/2014/main" id="{4B7B41B2-4D3B-4D4A-A6D8-B05116A68DC4}"/>
               </a:ext>
             </a:extLst>
           </p:cNvPr>
@@ -5991,7 +5996,7 @@
     </p:spTree>
     <p:extLst>
       <p:ext uri="{BB962C8B-B14F-4D97-AF65-F5344CB8AC3E}">
-        <p14:creationId xmlns:p14="http://schemas.microsoft.com/office/powerpoint/2010/main" val="1310988564"/>
+        <p14:creationId xmlns:p14="http://schemas.microsoft.com/office/powerpoint/2010/main" val="874276834"/>
       </p:ext>
     </p:extLst>
   </p:cSld>
@@ -6012,10 +6017,10 @@
       </p:grpSpPr>
       <p:sp>
         <p:nvSpPr>
-          <p:cNvPr id="30" name="">
-            <a:extLst xmlns:a="http://schemas.openxmlformats.org/drawingml/2006/main">
-              <a:ext uri="{FF2B5EF4-FFF2-40B4-BE49-F238E27FC236}">
-                <a16:creationId xmlns:a16="http://schemas.microsoft.com/office/drawing/2014/main" id="{BA015204-C7EE-4A76-B638-887F2115221E}"/>
+          <p:cNvPr id="31" name="">
+            <a:extLst xmlns:a="http://schemas.openxmlformats.org/drawingml/2006/main">
+              <a:ext uri="{FF2B5EF4-FFF2-40B4-BE49-F238E27FC236}">
+                <a16:creationId xmlns:a16="http://schemas.microsoft.com/office/drawing/2014/main" id="{31836C98-B0E1-4FA2-97DA-B8612001F26B}"/>
               </a:ext>
             </a:extLst>
           </p:cNvPr>
@@ -6067,7 +6072,7 @@
           <p:cNvPr id="2" name="">
             <a:extLst xmlns:a="http://schemas.openxmlformats.org/drawingml/2006/main">
               <a:ext uri="{FF2B5EF4-FFF2-40B4-BE49-F238E27FC236}">
-                <a16:creationId xmlns:a16="http://schemas.microsoft.com/office/drawing/2014/main" id="{BE14E763-1664-4D41-BF0C-221CAACA05DA}"/>
+                <a16:creationId xmlns:a16="http://schemas.microsoft.com/office/drawing/2014/main" id="{0ADD079C-FB2E-4285-B930-462DC8DB4C07}"/>
               </a:ext>
             </a:extLst>
           </p:cNvPr>
@@ -6116,7 +6121,7 @@
       </p:sp>
       <p:cxnSp>
         <p:nvCxnSpPr>
-          <p:cNvPr id="32" name=""/>
+          <p:cNvPr id="33" name=""/>
           <p:cNvCxnSpPr/>
           <p:nvPr/>
         </p:nvCxnSpPr>
@@ -6141,7 +6146,7 @@
           <p:cNvPr id="4" name="">
             <a:extLst xmlns:a="http://schemas.openxmlformats.org/drawingml/2006/main">
               <a:ext uri="{FF2B5EF4-FFF2-40B4-BE49-F238E27FC236}">
-                <a16:creationId xmlns:a16="http://schemas.microsoft.com/office/drawing/2014/main" id="{BD3DEB45-DB27-4B70-8CB3-CE855E8B804D}"/>
+                <a16:creationId xmlns:a16="http://schemas.microsoft.com/office/drawing/2014/main" id="{CE432FEC-8372-4E6B-8A04-C26E58796487}"/>
               </a:ext>
             </a:extLst>
           </p:cNvPr>
@@ -6188,50 +6193,58 @@
           </a:p>
         </p:txBody>
       </p:sp>
-      <p:cxnSp>
-        <p:nvCxnSpPr>
-          <p:cNvPr id="34" name=""/>
-          <p:cNvCxnSpPr/>
-          <p:nvPr/>
-        </p:nvCxnSpPr>
-        <p:spPr>
-          <a:xfrm xmlns:a="http://schemas.openxmlformats.org/drawingml/2006/main">
-            <a:off x="2209800" y="3086100"/>
-            <a:ext cx="495300" cy="0"/>
-          </a:xfrm>
-          <a:prstGeom xmlns:a="http://schemas.openxmlformats.org/drawingml/2006/main" prst="straightConnector1">
-            <a:avLst/>
-          </a:prstGeom>
-          <a:ln xmlns:a="http://schemas.openxmlformats.org/drawingml/2006/main" w="19050">
-            <a:solidFill>
-              <a:srgbClr val="B8BCC4"/>
-            </a:solidFill>
-            <a:prstDash val="solid"/>
-          </a:ln>
-        </p:spPr>
-      </p:cxnSp>
-      <p:cxnSp>
-        <p:nvCxnSpPr>
-          <p:cNvPr id="35" name=""/>
-          <p:cNvCxnSpPr/>
-          <p:nvPr/>
-        </p:nvCxnSpPr>
-        <p:spPr>
-          <a:xfrm xmlns:a="http://schemas.openxmlformats.org/drawingml/2006/main">
-            <a:off x="4514850" y="3086100"/>
-            <a:ext cx="495300" cy="0"/>
-          </a:xfrm>
-          <a:prstGeom xmlns:a="http://schemas.openxmlformats.org/drawingml/2006/main" prst="straightConnector1">
-            <a:avLst/>
-          </a:prstGeom>
-          <a:ln xmlns:a="http://schemas.openxmlformats.org/drawingml/2006/main" w="19050">
-            <a:solidFill>
-              <a:srgbClr val="B8BCC4"/>
-            </a:solidFill>
-            <a:prstDash val="solid"/>
-          </a:ln>
-        </p:spPr>
-      </p:cxnSp>
+      <p:sp>
+        <p:nvSpPr>
+          <p:cNvPr id="5" name="">
+            <a:extLst xmlns:a="http://schemas.openxmlformats.org/drawingml/2006/main">
+              <a:ext uri="{FF2B5EF4-FFF2-40B4-BE49-F238E27FC236}">
+                <a16:creationId xmlns:a16="http://schemas.microsoft.com/office/drawing/2014/main" id="{F1568B00-A7AE-451E-97E9-2FD2CCE7B230}"/>
+              </a:ext>
+            </a:extLst>
+          </p:cNvPr>
+          <p:cNvSpPr>
+            <a:spLocks xmlns:a="http://schemas.openxmlformats.org/drawingml/2006/main" noGrp="1"/>
+          </p:cNvSpPr>
+          <p:nvPr/>
+        </p:nvSpPr>
+        <p:spPr>
+          <a:xfrm xmlns:a="http://schemas.openxmlformats.org/drawingml/2006/main">
+            <a:off x="400050" y="1428750"/>
+            <a:ext cx="11391900" cy="285750"/>
+          </a:xfrm>
+          <a:prstGeom xmlns:a="http://schemas.openxmlformats.org/drawingml/2006/main" prst="rect">
+            <a:avLst/>
+          </a:prstGeom>
+          <a:noFill xmlns:a="http://schemas.openxmlformats.org/drawingml/2006/main"/>
+          <a:ln xmlns:a="http://schemas.openxmlformats.org/drawingml/2006/main" w="0">
+            <a:noFill/>
+            <a:prstDash val="solid"/>
+          </a:ln>
+        </p:spPr>
+        <p:txBody>
+          <a:bodyPr xmlns:a="http://schemas.openxmlformats.org/drawingml/2006/main" anchor="t">
+            <a:normAutofit fontScale="94444"/>
+          </a:bodyPr>
+          <a:lstStyle xmlns:a="http://schemas.openxmlformats.org/drawingml/2006/main"/>
+          <a:p xmlns:a="http://schemas.openxmlformats.org/drawingml/2006/main">
+            <a:pPr algn="l">
+              <a:defRPr sz="1350" b="1">
+                <a:solidFill>
+                  <a:srgbClr val="5F6368"/>
+                </a:solidFill>
+              </a:defRPr>
+            </a:pPr>
+            <a:r>
+              <a:rPr sz="1350" b="1">
+                <a:solidFill>
+                  <a:srgbClr val="5F6368"/>
+                </a:solidFill>
+              </a:rPr>
+              <a:t>Proposed Tyler ADS location: 13387 North Highway 69, Tyler, Texas</a:t>
+            </a:r>
+          </a:p>
+        </p:txBody>
+      </p:sp>
       <p:cxnSp>
         <p:nvCxnSpPr>
           <p:cNvPr id="36" name=""/>
@@ -6240,7 +6253,7 @@
         </p:nvCxnSpPr>
         <p:spPr>
           <a:xfrm xmlns:a="http://schemas.openxmlformats.org/drawingml/2006/main">
-            <a:off x="6819900" y="3086100"/>
+            <a:off x="2209800" y="3086100"/>
             <a:ext cx="495300" cy="0"/>
           </a:xfrm>
           <a:prstGeom xmlns:a="http://schemas.openxmlformats.org/drawingml/2006/main" prst="straightConnector1">
@@ -6262,7 +6275,7 @@
         </p:nvCxnSpPr>
         <p:spPr>
           <a:xfrm xmlns:a="http://schemas.openxmlformats.org/drawingml/2006/main">
-            <a:off x="9124950" y="3086100"/>
+            <a:off x="4514850" y="3086100"/>
             <a:ext cx="495300" cy="0"/>
           </a:xfrm>
           <a:prstGeom xmlns:a="http://schemas.openxmlformats.org/drawingml/2006/main" prst="straightConnector1">
@@ -6276,12 +6289,56 @@
           </a:ln>
         </p:spPr>
       </p:cxnSp>
-      <p:sp>
-        <p:nvSpPr>
-          <p:cNvPr id="9" name="">
-            <a:extLst xmlns:a="http://schemas.openxmlformats.org/drawingml/2006/main">
-              <a:ext uri="{FF2B5EF4-FFF2-40B4-BE49-F238E27FC236}">
-                <a16:creationId xmlns:a16="http://schemas.microsoft.com/office/drawing/2014/main" id="{1132E1AD-ED79-4C50-ACFA-A31DEC4E1CE7}"/>
+      <p:cxnSp>
+        <p:nvCxnSpPr>
+          <p:cNvPr id="38" name=""/>
+          <p:cNvCxnSpPr/>
+          <p:nvPr/>
+        </p:nvCxnSpPr>
+        <p:spPr>
+          <a:xfrm xmlns:a="http://schemas.openxmlformats.org/drawingml/2006/main">
+            <a:off x="6819900" y="3086100"/>
+            <a:ext cx="495300" cy="0"/>
+          </a:xfrm>
+          <a:prstGeom xmlns:a="http://schemas.openxmlformats.org/drawingml/2006/main" prst="straightConnector1">
+            <a:avLst/>
+          </a:prstGeom>
+          <a:ln xmlns:a="http://schemas.openxmlformats.org/drawingml/2006/main" w="19050">
+            <a:solidFill>
+              <a:srgbClr val="B8BCC4"/>
+            </a:solidFill>
+            <a:prstDash val="solid"/>
+          </a:ln>
+        </p:spPr>
+      </p:cxnSp>
+      <p:cxnSp>
+        <p:nvCxnSpPr>
+          <p:cNvPr id="39" name=""/>
+          <p:cNvCxnSpPr/>
+          <p:nvPr/>
+        </p:nvCxnSpPr>
+        <p:spPr>
+          <a:xfrm xmlns:a="http://schemas.openxmlformats.org/drawingml/2006/main">
+            <a:off x="9124950" y="3086100"/>
+            <a:ext cx="495300" cy="0"/>
+          </a:xfrm>
+          <a:prstGeom xmlns:a="http://schemas.openxmlformats.org/drawingml/2006/main" prst="straightConnector1">
+            <a:avLst/>
+          </a:prstGeom>
+          <a:ln xmlns:a="http://schemas.openxmlformats.org/drawingml/2006/main" w="19050">
+            <a:solidFill>
+              <a:srgbClr val="B8BCC4"/>
+            </a:solidFill>
+            <a:prstDash val="solid"/>
+          </a:ln>
+        </p:spPr>
+      </p:cxnSp>
+      <p:sp>
+        <p:nvSpPr>
+          <p:cNvPr id="10" name="">
+            <a:extLst xmlns:a="http://schemas.openxmlformats.org/drawingml/2006/main">
+              <a:ext uri="{FF2B5EF4-FFF2-40B4-BE49-F238E27FC236}">
+                <a16:creationId xmlns:a16="http://schemas.microsoft.com/office/drawing/2014/main" id="{96471EFB-23D5-4BD0-B29C-D2271A5E97F3}"/>
               </a:ext>
             </a:extLst>
           </p:cNvPr>
@@ -6311,10 +6368,10 @@
       </p:sp>
       <p:sp>
         <p:nvSpPr>
-          <p:cNvPr id="10" name="">
-            <a:extLst xmlns:a="http://schemas.openxmlformats.org/drawingml/2006/main">
-              <a:ext uri="{FF2B5EF4-FFF2-40B4-BE49-F238E27FC236}">
-                <a16:creationId xmlns:a16="http://schemas.microsoft.com/office/drawing/2014/main" id="{53C9AF39-3612-46A2-857B-05ADB6313F20}"/>
+          <p:cNvPr id="11" name="">
+            <a:extLst xmlns:a="http://schemas.openxmlformats.org/drawingml/2006/main">
+              <a:ext uri="{FF2B5EF4-FFF2-40B4-BE49-F238E27FC236}">
+                <a16:creationId xmlns:a16="http://schemas.microsoft.com/office/drawing/2014/main" id="{ED75B902-033E-4923-9A8C-196920B011A2}"/>
               </a:ext>
             </a:extLst>
           </p:cNvPr>
@@ -6363,10 +6420,10 @@
       </p:sp>
       <p:sp>
         <p:nvSpPr>
-          <p:cNvPr id="11" name="">
-            <a:extLst xmlns:a="http://schemas.openxmlformats.org/drawingml/2006/main">
-              <a:ext uri="{FF2B5EF4-FFF2-40B4-BE49-F238E27FC236}">
-                <a16:creationId xmlns:a16="http://schemas.microsoft.com/office/drawing/2014/main" id="{89A18335-5DB1-4665-8284-27D775A24431}"/>
+          <p:cNvPr id="12" name="">
+            <a:extLst xmlns:a="http://schemas.openxmlformats.org/drawingml/2006/main">
+              <a:ext uri="{FF2B5EF4-FFF2-40B4-BE49-F238E27FC236}">
+                <a16:creationId xmlns:a16="http://schemas.microsoft.com/office/drawing/2014/main" id="{9D0A4424-4C84-499D-BBF4-F1A691B02706}"/>
               </a:ext>
             </a:extLst>
           </p:cNvPr>
@@ -6415,10 +6472,10 @@
       </p:sp>
       <p:sp>
         <p:nvSpPr>
-          <p:cNvPr id="12" name="">
-            <a:extLst xmlns:a="http://schemas.openxmlformats.org/drawingml/2006/main">
-              <a:ext uri="{FF2B5EF4-FFF2-40B4-BE49-F238E27FC236}">
-                <a16:creationId xmlns:a16="http://schemas.microsoft.com/office/drawing/2014/main" id="{3B34DFE3-5750-4A9E-8C21-7E30ADD98A16}"/>
+          <p:cNvPr id="13" name="">
+            <a:extLst xmlns:a="http://schemas.openxmlformats.org/drawingml/2006/main">
+              <a:ext uri="{FF2B5EF4-FFF2-40B4-BE49-F238E27FC236}">
+                <a16:creationId xmlns:a16="http://schemas.microsoft.com/office/drawing/2014/main" id="{F59F6D1C-F57E-4CB8-8E7D-E447BBAEF30F}"/>
               </a:ext>
             </a:extLst>
           </p:cNvPr>
@@ -6467,10 +6524,10 @@
       </p:sp>
       <p:sp>
         <p:nvSpPr>
-          <p:cNvPr id="13" name="">
-            <a:extLst xmlns:a="http://schemas.openxmlformats.org/drawingml/2006/main">
-              <a:ext uri="{FF2B5EF4-FFF2-40B4-BE49-F238E27FC236}">
-                <a16:creationId xmlns:a16="http://schemas.microsoft.com/office/drawing/2014/main" id="{0CFFE2A7-FDF8-47EC-8207-A10727151C57}"/>
+          <p:cNvPr id="14" name="">
+            <a:extLst xmlns:a="http://schemas.openxmlformats.org/drawingml/2006/main">
+              <a:ext uri="{FF2B5EF4-FFF2-40B4-BE49-F238E27FC236}">
+                <a16:creationId xmlns:a16="http://schemas.microsoft.com/office/drawing/2014/main" id="{8B32887E-34B6-4038-8547-96FFB35B2BD2}"/>
               </a:ext>
             </a:extLst>
           </p:cNvPr>
@@ -6500,10 +6557,10 @@
       </p:sp>
       <p:sp>
         <p:nvSpPr>
-          <p:cNvPr id="14" name="">
-            <a:extLst xmlns:a="http://schemas.openxmlformats.org/drawingml/2006/main">
-              <a:ext uri="{FF2B5EF4-FFF2-40B4-BE49-F238E27FC236}">
-                <a16:creationId xmlns:a16="http://schemas.microsoft.com/office/drawing/2014/main" id="{C2321238-E19E-4F8E-832F-491FE8C3A9E1}"/>
+          <p:cNvPr id="15" name="">
+            <a:extLst xmlns:a="http://schemas.openxmlformats.org/drawingml/2006/main">
+              <a:ext uri="{FF2B5EF4-FFF2-40B4-BE49-F238E27FC236}">
+                <a16:creationId xmlns:a16="http://schemas.microsoft.com/office/drawing/2014/main" id="{FEB935A8-29BB-490D-A447-53C3F63ED944}"/>
               </a:ext>
             </a:extLst>
           </p:cNvPr>
@@ -6552,10 +6609,10 @@
       </p:sp>
       <p:sp>
         <p:nvSpPr>
-          <p:cNvPr id="15" name="">
-            <a:extLst xmlns:a="http://schemas.openxmlformats.org/drawingml/2006/main">
-              <a:ext uri="{FF2B5EF4-FFF2-40B4-BE49-F238E27FC236}">
-                <a16:creationId xmlns:a16="http://schemas.microsoft.com/office/drawing/2014/main" id="{D64AA5F4-9496-4641-94D4-DB3EBC473E1E}"/>
+          <p:cNvPr id="16" name="">
+            <a:extLst xmlns:a="http://schemas.openxmlformats.org/drawingml/2006/main">
+              <a:ext uri="{FF2B5EF4-FFF2-40B4-BE49-F238E27FC236}">
+                <a16:creationId xmlns:a16="http://schemas.microsoft.com/office/drawing/2014/main" id="{1F17D79F-09E7-4E08-9D33-1247A527EE77}"/>
               </a:ext>
             </a:extLst>
           </p:cNvPr>
@@ -6604,10 +6661,10 @@
       </p:sp>
       <p:sp>
         <p:nvSpPr>
-          <p:cNvPr id="16" name="">
-            <a:extLst xmlns:a="http://schemas.openxmlformats.org/drawingml/2006/main">
-              <a:ext uri="{FF2B5EF4-FFF2-40B4-BE49-F238E27FC236}">
-                <a16:creationId xmlns:a16="http://schemas.microsoft.com/office/drawing/2014/main" id="{1CB95247-FF26-4684-824C-F8977AA7539D}"/>
+          <p:cNvPr id="17" name="">
+            <a:extLst xmlns:a="http://schemas.openxmlformats.org/drawingml/2006/main">
+              <a:ext uri="{FF2B5EF4-FFF2-40B4-BE49-F238E27FC236}">
+                <a16:creationId xmlns:a16="http://schemas.microsoft.com/office/drawing/2014/main" id="{76BBE4E2-8D81-4E9D-AB13-1376D27C3285}"/>
               </a:ext>
             </a:extLst>
           </p:cNvPr>
@@ -6656,10 +6713,10 @@
       </p:sp>
       <p:sp>
         <p:nvSpPr>
-          <p:cNvPr id="17" name="">
-            <a:extLst xmlns:a="http://schemas.openxmlformats.org/drawingml/2006/main">
-              <a:ext uri="{FF2B5EF4-FFF2-40B4-BE49-F238E27FC236}">
-                <a16:creationId xmlns:a16="http://schemas.microsoft.com/office/drawing/2014/main" id="{AB76A429-F6E7-45C8-AA86-81D8F9B49DA8}"/>
+          <p:cNvPr id="18" name="">
+            <a:extLst xmlns:a="http://schemas.openxmlformats.org/drawingml/2006/main">
+              <a:ext uri="{FF2B5EF4-FFF2-40B4-BE49-F238E27FC236}">
+                <a16:creationId xmlns:a16="http://schemas.microsoft.com/office/drawing/2014/main" id="{E75D2F29-4B8A-450A-877B-F4CFDCF04D47}"/>
               </a:ext>
             </a:extLst>
           </p:cNvPr>
@@ -6689,10 +6746,10 @@
       </p:sp>
       <p:sp>
         <p:nvSpPr>
-          <p:cNvPr id="18" name="">
-            <a:extLst xmlns:a="http://schemas.openxmlformats.org/drawingml/2006/main">
-              <a:ext uri="{FF2B5EF4-FFF2-40B4-BE49-F238E27FC236}">
-                <a16:creationId xmlns:a16="http://schemas.microsoft.com/office/drawing/2014/main" id="{B687A454-675E-47AD-8F20-C354BEA16098}"/>
+          <p:cNvPr id="19" name="">
+            <a:extLst xmlns:a="http://schemas.openxmlformats.org/drawingml/2006/main">
+              <a:ext uri="{FF2B5EF4-FFF2-40B4-BE49-F238E27FC236}">
+                <a16:creationId xmlns:a16="http://schemas.microsoft.com/office/drawing/2014/main" id="{03A17381-3446-4E83-A19E-7476863264FF}"/>
               </a:ext>
             </a:extLst>
           </p:cNvPr>
@@ -6741,10 +6798,10 @@
       </p:sp>
       <p:sp>
         <p:nvSpPr>
-          <p:cNvPr id="19" name="">
-            <a:extLst xmlns:a="http://schemas.openxmlformats.org/drawingml/2006/main">
-              <a:ext uri="{FF2B5EF4-FFF2-40B4-BE49-F238E27FC236}">
-                <a16:creationId xmlns:a16="http://schemas.microsoft.com/office/drawing/2014/main" id="{3081D249-8C52-460C-8275-5A13C0918E0B}"/>
+          <p:cNvPr id="20" name="">
+            <a:extLst xmlns:a="http://schemas.openxmlformats.org/drawingml/2006/main">
+              <a:ext uri="{FF2B5EF4-FFF2-40B4-BE49-F238E27FC236}">
+                <a16:creationId xmlns:a16="http://schemas.microsoft.com/office/drawing/2014/main" id="{C6AB7400-2785-4F7E-A30E-E2CB33640B96}"/>
               </a:ext>
             </a:extLst>
           </p:cNvPr>
@@ -6793,10 +6850,10 @@
       </p:sp>
       <p:sp>
         <p:nvSpPr>
-          <p:cNvPr id="20" name="">
-            <a:extLst xmlns:a="http://schemas.openxmlformats.org/drawingml/2006/main">
-              <a:ext uri="{FF2B5EF4-FFF2-40B4-BE49-F238E27FC236}">
-                <a16:creationId xmlns:a16="http://schemas.microsoft.com/office/drawing/2014/main" id="{C599567A-1A11-42DE-BBFC-2CC37AFF3D55}"/>
+          <p:cNvPr id="21" name="">
+            <a:extLst xmlns:a="http://schemas.openxmlformats.org/drawingml/2006/main">
+              <a:ext uri="{FF2B5EF4-FFF2-40B4-BE49-F238E27FC236}">
+                <a16:creationId xmlns:a16="http://schemas.microsoft.com/office/drawing/2014/main" id="{1BB70721-B549-4C56-B701-354A005532A9}"/>
               </a:ext>
             </a:extLst>
           </p:cNvPr>
@@ -6845,10 +6902,10 @@
       </p:sp>
       <p:sp>
         <p:nvSpPr>
-          <p:cNvPr id="21" name="">
-            <a:extLst xmlns:a="http://schemas.openxmlformats.org/drawingml/2006/main">
-              <a:ext uri="{FF2B5EF4-FFF2-40B4-BE49-F238E27FC236}">
-                <a16:creationId xmlns:a16="http://schemas.microsoft.com/office/drawing/2014/main" id="{F9B1AF1C-D99F-4DAE-A03F-98F7E44E127A}"/>
+          <p:cNvPr id="22" name="">
+            <a:extLst xmlns:a="http://schemas.openxmlformats.org/drawingml/2006/main">
+              <a:ext uri="{FF2B5EF4-FFF2-40B4-BE49-F238E27FC236}">
+                <a16:creationId xmlns:a16="http://schemas.microsoft.com/office/drawing/2014/main" id="{B09ED26A-651B-464D-AA5B-4FDA6CC07002}"/>
               </a:ext>
             </a:extLst>
           </p:cNvPr>
@@ -6878,10 +6935,10 @@
       </p:sp>
       <p:sp>
         <p:nvSpPr>
-          <p:cNvPr id="22" name="">
-            <a:extLst xmlns:a="http://schemas.openxmlformats.org/drawingml/2006/main">
-              <a:ext uri="{FF2B5EF4-FFF2-40B4-BE49-F238E27FC236}">
-                <a16:creationId xmlns:a16="http://schemas.microsoft.com/office/drawing/2014/main" id="{9D45415B-D000-4CF9-9639-2465834CD657}"/>
+          <p:cNvPr id="23" name="">
+            <a:extLst xmlns:a="http://schemas.openxmlformats.org/drawingml/2006/main">
+              <a:ext uri="{FF2B5EF4-FFF2-40B4-BE49-F238E27FC236}">
+                <a16:creationId xmlns:a16="http://schemas.microsoft.com/office/drawing/2014/main" id="{8CA6A872-D551-48FF-9564-C036F0C573BA}"/>
               </a:ext>
             </a:extLst>
           </p:cNvPr>
@@ -6930,10 +6987,10 @@
       </p:sp>
       <p:sp>
         <p:nvSpPr>
-          <p:cNvPr id="23" name="">
-            <a:extLst xmlns:a="http://schemas.openxmlformats.org/drawingml/2006/main">
-              <a:ext uri="{FF2B5EF4-FFF2-40B4-BE49-F238E27FC236}">
-                <a16:creationId xmlns:a16="http://schemas.microsoft.com/office/drawing/2014/main" id="{B8DCF456-2741-4FB9-AA9A-23A66DD7A23A}"/>
+          <p:cNvPr id="24" name="">
+            <a:extLst xmlns:a="http://schemas.openxmlformats.org/drawingml/2006/main">
+              <a:ext uri="{FF2B5EF4-FFF2-40B4-BE49-F238E27FC236}">
+                <a16:creationId xmlns:a16="http://schemas.microsoft.com/office/drawing/2014/main" id="{922A09B2-025D-425C-8A34-5E913DCAC4D7}"/>
               </a:ext>
             </a:extLst>
           </p:cNvPr>
@@ -6982,10 +7039,10 @@
       </p:sp>
       <p:sp>
         <p:nvSpPr>
-          <p:cNvPr id="24" name="">
-            <a:extLst xmlns:a="http://schemas.openxmlformats.org/drawingml/2006/main">
-              <a:ext uri="{FF2B5EF4-FFF2-40B4-BE49-F238E27FC236}">
-                <a16:creationId xmlns:a16="http://schemas.microsoft.com/office/drawing/2014/main" id="{73BA068D-031E-4689-A823-326E1F2B523E}"/>
+          <p:cNvPr id="25" name="">
+            <a:extLst xmlns:a="http://schemas.openxmlformats.org/drawingml/2006/main">
+              <a:ext uri="{FF2B5EF4-FFF2-40B4-BE49-F238E27FC236}">
+                <a16:creationId xmlns:a16="http://schemas.microsoft.com/office/drawing/2014/main" id="{1CC9A473-556C-4A1C-9BCF-1903FB1D4D50}"/>
               </a:ext>
             </a:extLst>
           </p:cNvPr>
@@ -7034,10 +7091,10 @@
       </p:sp>
       <p:sp>
         <p:nvSpPr>
-          <p:cNvPr id="25" name="">
-            <a:extLst xmlns:a="http://schemas.openxmlformats.org/drawingml/2006/main">
-              <a:ext uri="{FF2B5EF4-FFF2-40B4-BE49-F238E27FC236}">
-                <a16:creationId xmlns:a16="http://schemas.microsoft.com/office/drawing/2014/main" id="{66F6CE7B-7969-4FA5-8F02-F0B6C46D1719}"/>
+          <p:cNvPr id="26" name="">
+            <a:extLst xmlns:a="http://schemas.openxmlformats.org/drawingml/2006/main">
+              <a:ext uri="{FF2B5EF4-FFF2-40B4-BE49-F238E27FC236}">
+                <a16:creationId xmlns:a16="http://schemas.microsoft.com/office/drawing/2014/main" id="{AD0AD9ED-2DC8-4615-9A88-D19BBF8B02EF}"/>
               </a:ext>
             </a:extLst>
           </p:cNvPr>
@@ -7069,10 +7126,10 @@
       </p:sp>
       <p:sp>
         <p:nvSpPr>
-          <p:cNvPr id="26" name="">
-            <a:extLst xmlns:a="http://schemas.openxmlformats.org/drawingml/2006/main">
-              <a:ext uri="{FF2B5EF4-FFF2-40B4-BE49-F238E27FC236}">
-                <a16:creationId xmlns:a16="http://schemas.microsoft.com/office/drawing/2014/main" id="{5801AF6E-F4C5-46D7-9A3C-F44BD90C27D3}"/>
+          <p:cNvPr id="27" name="">
+            <a:extLst xmlns:a="http://schemas.openxmlformats.org/drawingml/2006/main">
+              <a:ext uri="{FF2B5EF4-FFF2-40B4-BE49-F238E27FC236}">
+                <a16:creationId xmlns:a16="http://schemas.microsoft.com/office/drawing/2014/main" id="{EFF33D00-9D46-4B4B-A118-51683FFAF8A3}"/>
               </a:ext>
             </a:extLst>
           </p:cNvPr>
@@ -7121,10 +7178,10 @@
       </p:sp>
       <p:sp>
         <p:nvSpPr>
-          <p:cNvPr id="27" name="">
-            <a:extLst xmlns:a="http://schemas.openxmlformats.org/drawingml/2006/main">
-              <a:ext uri="{FF2B5EF4-FFF2-40B4-BE49-F238E27FC236}">
-                <a16:creationId xmlns:a16="http://schemas.microsoft.com/office/drawing/2014/main" id="{4E1D918F-06D5-403E-831F-77050386BB77}"/>
+          <p:cNvPr id="28" name="">
+            <a:extLst xmlns:a="http://schemas.openxmlformats.org/drawingml/2006/main">
+              <a:ext uri="{FF2B5EF4-FFF2-40B4-BE49-F238E27FC236}">
+                <a16:creationId xmlns:a16="http://schemas.microsoft.com/office/drawing/2014/main" id="{004C1750-1095-434C-94EA-5C7AAA40D992}"/>
               </a:ext>
             </a:extLst>
           </p:cNvPr>
@@ -7173,10 +7230,10 @@
       </p:sp>
       <p:sp>
         <p:nvSpPr>
-          <p:cNvPr id="28" name="">
-            <a:extLst xmlns:a="http://schemas.openxmlformats.org/drawingml/2006/main">
-              <a:ext uri="{FF2B5EF4-FFF2-40B4-BE49-F238E27FC236}">
-                <a16:creationId xmlns:a16="http://schemas.microsoft.com/office/drawing/2014/main" id="{A44533B2-7AF7-4598-AC58-2E7E8D083D4D}"/>
+          <p:cNvPr id="29" name="">
+            <a:extLst xmlns:a="http://schemas.openxmlformats.org/drawingml/2006/main">
+              <a:ext uri="{FF2B5EF4-FFF2-40B4-BE49-F238E27FC236}">
+                <a16:creationId xmlns:a16="http://schemas.microsoft.com/office/drawing/2014/main" id="{490F806E-4444-4A0F-BEFE-66D98AFA8352}"/>
               </a:ext>
             </a:extLst>
           </p:cNvPr>
@@ -7225,10 +7282,10 @@
       </p:sp>
       <p:sp>
         <p:nvSpPr>
-          <p:cNvPr id="29" name="">
-            <a:extLst xmlns:a="http://schemas.openxmlformats.org/drawingml/2006/main">
-              <a:ext uri="{FF2B5EF4-FFF2-40B4-BE49-F238E27FC236}">
-                <a16:creationId xmlns:a16="http://schemas.microsoft.com/office/drawing/2014/main" id="{7DAE09DB-2FB7-47A9-AB83-42A73053ED1F}"/>
+          <p:cNvPr id="30" name="">
+            <a:extLst xmlns:a="http://schemas.openxmlformats.org/drawingml/2006/main">
+              <a:ext uri="{FF2B5EF4-FFF2-40B4-BE49-F238E27FC236}">
+                <a16:creationId xmlns:a16="http://schemas.microsoft.com/office/drawing/2014/main" id="{62A88784-C2A1-4301-8910-DF6334D58957}"/>
               </a:ext>
             </a:extLst>
           </p:cNvPr>
@@ -7278,7 +7335,7 @@
     </p:spTree>
     <p:extLst>
       <p:ext uri="{BB962C8B-B14F-4D97-AF65-F5344CB8AC3E}">
-        <p14:creationId xmlns:p14="http://schemas.microsoft.com/office/powerpoint/2010/main" val="673206878"/>
+        <p14:creationId xmlns:p14="http://schemas.microsoft.com/office/powerpoint/2010/main" val="1165845434"/>
       </p:ext>
     </p:extLst>
   </p:cSld>
@@ -7302,7 +7359,7 @@
           <p:cNvPr id="62" name="">
             <a:extLst xmlns:a="http://schemas.openxmlformats.org/drawingml/2006/main">
               <a:ext uri="{FF2B5EF4-FFF2-40B4-BE49-F238E27FC236}">
-                <a16:creationId xmlns:a16="http://schemas.microsoft.com/office/drawing/2014/main" id="{97F0891F-A920-4976-9F85-527922CBEF8A}"/>
+                <a16:creationId xmlns:a16="http://schemas.microsoft.com/office/drawing/2014/main" id="{FB4BF795-84B7-4040-AE86-B1799A477E07}"/>
               </a:ext>
             </a:extLst>
           </p:cNvPr>
@@ -7354,7 +7411,7 @@
           <p:cNvPr id="2" name="">
             <a:extLst xmlns:a="http://schemas.openxmlformats.org/drawingml/2006/main">
               <a:ext uri="{FF2B5EF4-FFF2-40B4-BE49-F238E27FC236}">
-                <a16:creationId xmlns:a16="http://schemas.microsoft.com/office/drawing/2014/main" id="{4F09F3E0-88F7-4F9A-B157-C40C6CFBA8DF}"/>
+                <a16:creationId xmlns:a16="http://schemas.microsoft.com/office/drawing/2014/main" id="{BA4A1AB8-F58D-4409-9FE4-A02539C0AC10}"/>
               </a:ext>
             </a:extLst>
           </p:cNvPr>
@@ -7428,7 +7485,7 @@
           <p:cNvPr id="4" name="">
             <a:extLst xmlns:a="http://schemas.openxmlformats.org/drawingml/2006/main">
               <a:ext uri="{FF2B5EF4-FFF2-40B4-BE49-F238E27FC236}">
-                <a16:creationId xmlns:a16="http://schemas.microsoft.com/office/drawing/2014/main" id="{1B11A544-F6C5-40A9-988C-44C11AD4B89A}"/>
+                <a16:creationId xmlns:a16="http://schemas.microsoft.com/office/drawing/2014/main" id="{43AD344C-C389-435A-B0E4-F4B88A76F1A7}"/>
               </a:ext>
             </a:extLst>
           </p:cNvPr>
@@ -7480,7 +7537,7 @@
           <p:cNvPr id="5" name="">
             <a:extLst xmlns:a="http://schemas.openxmlformats.org/drawingml/2006/main">
               <a:ext uri="{FF2B5EF4-FFF2-40B4-BE49-F238E27FC236}">
-                <a16:creationId xmlns:a16="http://schemas.microsoft.com/office/drawing/2014/main" id="{BC24A28F-90E0-4F78-B887-3331D58156A5}"/>
+                <a16:creationId xmlns:a16="http://schemas.microsoft.com/office/drawing/2014/main" id="{4F31BC63-8CE6-4411-8FB4-18686B84DAA4}"/>
               </a:ext>
             </a:extLst>
           </p:cNvPr>
@@ -7532,7 +7589,7 @@
           <p:cNvPr id="6" name="">
             <a:extLst xmlns:a="http://schemas.openxmlformats.org/drawingml/2006/main">
               <a:ext uri="{FF2B5EF4-FFF2-40B4-BE49-F238E27FC236}">
-                <a16:creationId xmlns:a16="http://schemas.microsoft.com/office/drawing/2014/main" id="{8F71C661-740B-4E1A-990B-2036A9096A0F}"/>
+                <a16:creationId xmlns:a16="http://schemas.microsoft.com/office/drawing/2014/main" id="{7896A000-C482-42DA-8FB7-9652C0742923}"/>
               </a:ext>
             </a:extLst>
           </p:cNvPr>
@@ -7584,7 +7641,7 @@
           <p:cNvPr id="7" name="">
             <a:extLst xmlns:a="http://schemas.openxmlformats.org/drawingml/2006/main">
               <a:ext uri="{FF2B5EF4-FFF2-40B4-BE49-F238E27FC236}">
-                <a16:creationId xmlns:a16="http://schemas.microsoft.com/office/drawing/2014/main" id="{9F35FF91-2FE4-464C-9196-606CFF9A762B}"/>
+                <a16:creationId xmlns:a16="http://schemas.microsoft.com/office/drawing/2014/main" id="{DFC913E4-9939-4969-A92C-BD2BBCD4CC97}"/>
               </a:ext>
             </a:extLst>
           </p:cNvPr>
@@ -7636,7 +7693,7 @@
           <p:cNvPr id="8" name="">
             <a:extLst xmlns:a="http://schemas.openxmlformats.org/drawingml/2006/main">
               <a:ext uri="{FF2B5EF4-FFF2-40B4-BE49-F238E27FC236}">
-                <a16:creationId xmlns:a16="http://schemas.microsoft.com/office/drawing/2014/main" id="{30A587C7-19AC-4E94-A59F-6AFD8A47F65B}"/>
+                <a16:creationId xmlns:a16="http://schemas.microsoft.com/office/drawing/2014/main" id="{75A78709-7C69-4C42-A34A-D4D2C792C11B}"/>
               </a:ext>
             </a:extLst>
           </p:cNvPr>
@@ -7688,7 +7745,7 @@
           <p:cNvPr id="9" name="">
             <a:extLst xmlns:a="http://schemas.openxmlformats.org/drawingml/2006/main">
               <a:ext uri="{FF2B5EF4-FFF2-40B4-BE49-F238E27FC236}">
-                <a16:creationId xmlns:a16="http://schemas.microsoft.com/office/drawing/2014/main" id="{8E3FE494-636E-4656-BCB0-115168CF3919}"/>
+                <a16:creationId xmlns:a16="http://schemas.microsoft.com/office/drawing/2014/main" id="{35F75AEA-4576-4A10-BE94-60B5CF4B3E6D}"/>
               </a:ext>
             </a:extLst>
           </p:cNvPr>
@@ -7740,7 +7797,7 @@
           <p:cNvPr id="10" name="">
             <a:extLst xmlns:a="http://schemas.openxmlformats.org/drawingml/2006/main">
               <a:ext uri="{FF2B5EF4-FFF2-40B4-BE49-F238E27FC236}">
-                <a16:creationId xmlns:a16="http://schemas.microsoft.com/office/drawing/2014/main" id="{68399967-F747-4C21-B706-F9B52C879B8A}"/>
+                <a16:creationId xmlns:a16="http://schemas.microsoft.com/office/drawing/2014/main" id="{A2F20D44-6E8A-4AE9-9E01-C4AB9C768289}"/>
               </a:ext>
             </a:extLst>
           </p:cNvPr>
@@ -7792,7 +7849,7 @@
           <p:cNvPr id="11" name="">
             <a:extLst xmlns:a="http://schemas.openxmlformats.org/drawingml/2006/main">
               <a:ext uri="{FF2B5EF4-FFF2-40B4-BE49-F238E27FC236}">
-                <a16:creationId xmlns:a16="http://schemas.microsoft.com/office/drawing/2014/main" id="{114F539C-C2B8-446B-A1D5-976A1315B033}"/>
+                <a16:creationId xmlns:a16="http://schemas.microsoft.com/office/drawing/2014/main" id="{388B7E56-68D1-4020-BE79-C60B614F8988}"/>
               </a:ext>
             </a:extLst>
           </p:cNvPr>
@@ -7825,7 +7882,7 @@
           <p:cNvPr id="12" name="">
             <a:extLst xmlns:a="http://schemas.openxmlformats.org/drawingml/2006/main">
               <a:ext uri="{FF2B5EF4-FFF2-40B4-BE49-F238E27FC236}">
-                <a16:creationId xmlns:a16="http://schemas.microsoft.com/office/drawing/2014/main" id="{59AE81C1-87C7-4FCA-981F-56919D87AF4B}"/>
+                <a16:creationId xmlns:a16="http://schemas.microsoft.com/office/drawing/2014/main" id="{1DEA746C-8E6F-4670-A2EB-4B21C8044E05}"/>
               </a:ext>
             </a:extLst>
           </p:cNvPr>
@@ -7877,7 +7934,7 @@
           <p:cNvPr id="13" name="">
             <a:extLst xmlns:a="http://schemas.openxmlformats.org/drawingml/2006/main">
               <a:ext uri="{FF2B5EF4-FFF2-40B4-BE49-F238E27FC236}">
-                <a16:creationId xmlns:a16="http://schemas.microsoft.com/office/drawing/2014/main" id="{B5D1EAC1-DAD2-42F2-806F-E7732317777B}"/>
+                <a16:creationId xmlns:a16="http://schemas.microsoft.com/office/drawing/2014/main" id="{28BACD7D-6A28-4BCB-A8B8-F59C49254ED9}"/>
               </a:ext>
             </a:extLst>
           </p:cNvPr>
@@ -7929,7 +7986,7 @@
           <p:cNvPr id="14" name="">
             <a:extLst xmlns:a="http://schemas.openxmlformats.org/drawingml/2006/main">
               <a:ext uri="{FF2B5EF4-FFF2-40B4-BE49-F238E27FC236}">
-                <a16:creationId xmlns:a16="http://schemas.microsoft.com/office/drawing/2014/main" id="{87B4815E-BE64-4BB0-825F-44F4EF4BC32B}"/>
+                <a16:creationId xmlns:a16="http://schemas.microsoft.com/office/drawing/2014/main" id="{7638EA1A-32BA-42B6-925E-1F1EC7773B20}"/>
               </a:ext>
             </a:extLst>
           </p:cNvPr>
@@ -7981,7 +8038,7 @@
           <p:cNvPr id="15" name="">
             <a:extLst xmlns:a="http://schemas.openxmlformats.org/drawingml/2006/main">
               <a:ext uri="{FF2B5EF4-FFF2-40B4-BE49-F238E27FC236}">
-                <a16:creationId xmlns:a16="http://schemas.microsoft.com/office/drawing/2014/main" id="{B22FDE88-DA08-4D1E-B8D7-3C17640D0E63}"/>
+                <a16:creationId xmlns:a16="http://schemas.microsoft.com/office/drawing/2014/main" id="{D14AA1D1-C612-4E7D-AF2F-0EF23B0512A5}"/>
               </a:ext>
             </a:extLst>
           </p:cNvPr>
@@ -8033,7 +8090,7 @@
           <p:cNvPr id="16" name="">
             <a:extLst xmlns:a="http://schemas.openxmlformats.org/drawingml/2006/main">
               <a:ext uri="{FF2B5EF4-FFF2-40B4-BE49-F238E27FC236}">
-                <a16:creationId xmlns:a16="http://schemas.microsoft.com/office/drawing/2014/main" id="{EFD1CD81-2F2A-49F0-83FE-0B6087E0895E}"/>
+                <a16:creationId xmlns:a16="http://schemas.microsoft.com/office/drawing/2014/main" id="{C7A01AD1-38A8-44E8-8AFD-B4333E2F1D65}"/>
               </a:ext>
             </a:extLst>
           </p:cNvPr>
@@ -8085,7 +8142,7 @@
           <p:cNvPr id="17" name="">
             <a:extLst xmlns:a="http://schemas.openxmlformats.org/drawingml/2006/main">
               <a:ext uri="{FF2B5EF4-FFF2-40B4-BE49-F238E27FC236}">
-                <a16:creationId xmlns:a16="http://schemas.microsoft.com/office/drawing/2014/main" id="{42195766-6AF9-438E-94A2-6F1138F64C41}"/>
+                <a16:creationId xmlns:a16="http://schemas.microsoft.com/office/drawing/2014/main" id="{1AE084FC-3BBE-4EBF-BF09-FEC78FC9FD39}"/>
               </a:ext>
             </a:extLst>
           </p:cNvPr>
@@ -8137,7 +8194,7 @@
           <p:cNvPr id="18" name="">
             <a:extLst xmlns:a="http://schemas.openxmlformats.org/drawingml/2006/main">
               <a:ext uri="{FF2B5EF4-FFF2-40B4-BE49-F238E27FC236}">
-                <a16:creationId xmlns:a16="http://schemas.microsoft.com/office/drawing/2014/main" id="{2259BEBA-638E-4BA2-A0E4-E5036C5B0C0A}"/>
+                <a16:creationId xmlns:a16="http://schemas.microsoft.com/office/drawing/2014/main" id="{F118CA3C-6611-4BAB-B2DF-E73C58EC1172}"/>
               </a:ext>
             </a:extLst>
           </p:cNvPr>
@@ -8170,7 +8227,7 @@
           <p:cNvPr id="19" name="">
             <a:extLst xmlns:a="http://schemas.openxmlformats.org/drawingml/2006/main">
               <a:ext uri="{FF2B5EF4-FFF2-40B4-BE49-F238E27FC236}">
-                <a16:creationId xmlns:a16="http://schemas.microsoft.com/office/drawing/2014/main" id="{77DDEC4E-A5A9-4D99-8599-48CAF4930A13}"/>
+                <a16:creationId xmlns:a16="http://schemas.microsoft.com/office/drawing/2014/main" id="{E18C2A60-E87A-4ACD-B022-63F68A112507}"/>
               </a:ext>
             </a:extLst>
           </p:cNvPr>
@@ -8222,7 +8279,7 @@
           <p:cNvPr id="20" name="">
             <a:extLst xmlns:a="http://schemas.openxmlformats.org/drawingml/2006/main">
               <a:ext uri="{FF2B5EF4-FFF2-40B4-BE49-F238E27FC236}">
-                <a16:creationId xmlns:a16="http://schemas.microsoft.com/office/drawing/2014/main" id="{CD9C9540-0F6C-408A-AC5C-50C7821C8BE7}"/>
+                <a16:creationId xmlns:a16="http://schemas.microsoft.com/office/drawing/2014/main" id="{343B8DB2-CD12-4796-9B67-ADB3E4FE6F8A}"/>
               </a:ext>
             </a:extLst>
           </p:cNvPr>
@@ -8274,7 +8331,7 @@
           <p:cNvPr id="21" name="">
             <a:extLst xmlns:a="http://schemas.openxmlformats.org/drawingml/2006/main">
               <a:ext uri="{FF2B5EF4-FFF2-40B4-BE49-F238E27FC236}">
-                <a16:creationId xmlns:a16="http://schemas.microsoft.com/office/drawing/2014/main" id="{A56679A3-5203-4AF1-AE3A-148352BBC077}"/>
+                <a16:creationId xmlns:a16="http://schemas.microsoft.com/office/drawing/2014/main" id="{8A5AE0C2-7D03-47EF-949C-1D2A8CAAFB53}"/>
               </a:ext>
             </a:extLst>
           </p:cNvPr>
@@ -8326,7 +8383,7 @@
           <p:cNvPr id="22" name="">
             <a:extLst xmlns:a="http://schemas.openxmlformats.org/drawingml/2006/main">
               <a:ext uri="{FF2B5EF4-FFF2-40B4-BE49-F238E27FC236}">
-                <a16:creationId xmlns:a16="http://schemas.microsoft.com/office/drawing/2014/main" id="{26262C31-2DF7-40C6-BA20-F07358CADBEE}"/>
+                <a16:creationId xmlns:a16="http://schemas.microsoft.com/office/drawing/2014/main" id="{67EC27EE-19F1-4939-B7F2-A63DF66B14DD}"/>
               </a:ext>
             </a:extLst>
           </p:cNvPr>
@@ -8378,7 +8435,7 @@
           <p:cNvPr id="23" name="">
             <a:extLst xmlns:a="http://schemas.openxmlformats.org/drawingml/2006/main">
               <a:ext uri="{FF2B5EF4-FFF2-40B4-BE49-F238E27FC236}">
-                <a16:creationId xmlns:a16="http://schemas.microsoft.com/office/drawing/2014/main" id="{5CB990EB-60EB-4209-BD33-C1991010F0E2}"/>
+                <a16:creationId xmlns:a16="http://schemas.microsoft.com/office/drawing/2014/main" id="{D387B74A-D5B8-4F6C-B84C-E2F9154A0D1C}"/>
               </a:ext>
             </a:extLst>
           </p:cNvPr>
@@ -8430,7 +8487,7 @@
           <p:cNvPr id="24" name="">
             <a:extLst xmlns:a="http://schemas.openxmlformats.org/drawingml/2006/main">
               <a:ext uri="{FF2B5EF4-FFF2-40B4-BE49-F238E27FC236}">
-                <a16:creationId xmlns:a16="http://schemas.microsoft.com/office/drawing/2014/main" id="{08B90A6C-157B-41E1-8345-04A8FAF0E132}"/>
+                <a16:creationId xmlns:a16="http://schemas.microsoft.com/office/drawing/2014/main" id="{C2E45C48-C108-482E-B1C5-2329D81987E8}"/>
               </a:ext>
             </a:extLst>
           </p:cNvPr>
@@ -8482,7 +8539,7 @@
           <p:cNvPr id="25" name="">
             <a:extLst xmlns:a="http://schemas.openxmlformats.org/drawingml/2006/main">
               <a:ext uri="{FF2B5EF4-FFF2-40B4-BE49-F238E27FC236}">
-                <a16:creationId xmlns:a16="http://schemas.microsoft.com/office/drawing/2014/main" id="{0C995AD8-D741-455B-8191-96B3DBED1E57}"/>
+                <a16:creationId xmlns:a16="http://schemas.microsoft.com/office/drawing/2014/main" id="{38A256D9-85EC-41CE-891F-0C61D34AE33B}"/>
               </a:ext>
             </a:extLst>
           </p:cNvPr>
@@ -8515,7 +8572,7 @@
           <p:cNvPr id="26" name="">
             <a:extLst xmlns:a="http://schemas.openxmlformats.org/drawingml/2006/main">
               <a:ext uri="{FF2B5EF4-FFF2-40B4-BE49-F238E27FC236}">
-                <a16:creationId xmlns:a16="http://schemas.microsoft.com/office/drawing/2014/main" id="{5B13E6E1-1713-4C2A-AB6A-640607572951}"/>
+                <a16:creationId xmlns:a16="http://schemas.microsoft.com/office/drawing/2014/main" id="{65AE63F0-FF84-49C1-8E4D-659FBE2FE5D4}"/>
               </a:ext>
             </a:extLst>
           </p:cNvPr>
@@ -8567,7 +8624,7 @@
           <p:cNvPr id="27" name="">
             <a:extLst xmlns:a="http://schemas.openxmlformats.org/drawingml/2006/main">
               <a:ext uri="{FF2B5EF4-FFF2-40B4-BE49-F238E27FC236}">
-                <a16:creationId xmlns:a16="http://schemas.microsoft.com/office/drawing/2014/main" id="{63C33DF0-DBB5-4430-8489-1302E911E158}"/>
+                <a16:creationId xmlns:a16="http://schemas.microsoft.com/office/drawing/2014/main" id="{7D649434-C21C-443C-AD63-03DC9EDE20D3}"/>
               </a:ext>
             </a:extLst>
           </p:cNvPr>
@@ -8619,7 +8676,7 @@
           <p:cNvPr id="28" name="">
             <a:extLst xmlns:a="http://schemas.openxmlformats.org/drawingml/2006/main">
               <a:ext uri="{FF2B5EF4-FFF2-40B4-BE49-F238E27FC236}">
-                <a16:creationId xmlns:a16="http://schemas.microsoft.com/office/drawing/2014/main" id="{E2F30452-11C5-4281-B204-D549CFDF548F}"/>
+                <a16:creationId xmlns:a16="http://schemas.microsoft.com/office/drawing/2014/main" id="{AE43A179-68B6-4D8D-B355-02BD1DE4B0EE}"/>
               </a:ext>
             </a:extLst>
           </p:cNvPr>
@@ -8671,7 +8728,7 @@
           <p:cNvPr id="29" name="">
             <a:extLst xmlns:a="http://schemas.openxmlformats.org/drawingml/2006/main">
               <a:ext uri="{FF2B5EF4-FFF2-40B4-BE49-F238E27FC236}">
-                <a16:creationId xmlns:a16="http://schemas.microsoft.com/office/drawing/2014/main" id="{334962EA-7C4E-41D5-A6E0-BED27285D907}"/>
+                <a16:creationId xmlns:a16="http://schemas.microsoft.com/office/drawing/2014/main" id="{C872A45B-EC4C-4D7B-9960-4A959B682BB9}"/>
               </a:ext>
             </a:extLst>
           </p:cNvPr>
@@ -8723,7 +8780,7 @@
           <p:cNvPr id="30" name="">
             <a:extLst xmlns:a="http://schemas.openxmlformats.org/drawingml/2006/main">
               <a:ext uri="{FF2B5EF4-FFF2-40B4-BE49-F238E27FC236}">
-                <a16:creationId xmlns:a16="http://schemas.microsoft.com/office/drawing/2014/main" id="{72B0217B-805E-45BD-90C8-F8C62C4D1943}"/>
+                <a16:creationId xmlns:a16="http://schemas.microsoft.com/office/drawing/2014/main" id="{40F8EFE4-5189-4E01-95D2-11D354F6EFDA}"/>
               </a:ext>
             </a:extLst>
           </p:cNvPr>
@@ -8775,7 +8832,7 @@
           <p:cNvPr id="31" name="">
             <a:extLst xmlns:a="http://schemas.openxmlformats.org/drawingml/2006/main">
               <a:ext uri="{FF2B5EF4-FFF2-40B4-BE49-F238E27FC236}">
-                <a16:creationId xmlns:a16="http://schemas.microsoft.com/office/drawing/2014/main" id="{2CC5E02E-9FB8-4CBB-BA08-4E9945DC5C04}"/>
+                <a16:creationId xmlns:a16="http://schemas.microsoft.com/office/drawing/2014/main" id="{00CF4FBB-67DC-4131-9BFA-0AA5C10AD419}"/>
               </a:ext>
             </a:extLst>
           </p:cNvPr>
@@ -8827,7 +8884,7 @@
           <p:cNvPr id="32" name="">
             <a:extLst xmlns:a="http://schemas.openxmlformats.org/drawingml/2006/main">
               <a:ext uri="{FF2B5EF4-FFF2-40B4-BE49-F238E27FC236}">
-                <a16:creationId xmlns:a16="http://schemas.microsoft.com/office/drawing/2014/main" id="{1ECDDA0D-975F-475C-B3A2-E89785C2A4CD}"/>
+                <a16:creationId xmlns:a16="http://schemas.microsoft.com/office/drawing/2014/main" id="{D3890359-8DD3-46F6-9E47-45B41D111917}"/>
               </a:ext>
             </a:extLst>
           </p:cNvPr>
@@ -8860,7 +8917,7 @@
           <p:cNvPr id="33" name="">
             <a:extLst xmlns:a="http://schemas.openxmlformats.org/drawingml/2006/main">
               <a:ext uri="{FF2B5EF4-FFF2-40B4-BE49-F238E27FC236}">
-                <a16:creationId xmlns:a16="http://schemas.microsoft.com/office/drawing/2014/main" id="{6909F5D4-F260-4908-A89A-B12DCA7AD675}"/>
+                <a16:creationId xmlns:a16="http://schemas.microsoft.com/office/drawing/2014/main" id="{74918FDB-CA4A-4F04-8F5B-F960654AD39C}"/>
               </a:ext>
             </a:extLst>
           </p:cNvPr>
@@ -8912,7 +8969,7 @@
           <p:cNvPr id="34" name="">
             <a:extLst xmlns:a="http://schemas.openxmlformats.org/drawingml/2006/main">
               <a:ext uri="{FF2B5EF4-FFF2-40B4-BE49-F238E27FC236}">
-                <a16:creationId xmlns:a16="http://schemas.microsoft.com/office/drawing/2014/main" id="{1B8D73BE-A5F9-40E7-94FC-81EFCEA6F4AE}"/>
+                <a16:creationId xmlns:a16="http://schemas.microsoft.com/office/drawing/2014/main" id="{3D831F01-2273-4390-B3EC-3C79E88E82A2}"/>
               </a:ext>
             </a:extLst>
           </p:cNvPr>
@@ -8964,7 +9021,7 @@
           <p:cNvPr id="35" name="">
             <a:extLst xmlns:a="http://schemas.openxmlformats.org/drawingml/2006/main">
               <a:ext uri="{FF2B5EF4-FFF2-40B4-BE49-F238E27FC236}">
-                <a16:creationId xmlns:a16="http://schemas.microsoft.com/office/drawing/2014/main" id="{CF738A2D-E7AE-4AA6-BFCC-9ABB9AE83B7F}"/>
+                <a16:creationId xmlns:a16="http://schemas.microsoft.com/office/drawing/2014/main" id="{1CDB54A3-85B5-4159-841E-11C2D3157582}"/>
               </a:ext>
             </a:extLst>
           </p:cNvPr>
@@ -9016,7 +9073,7 @@
           <p:cNvPr id="36" name="">
             <a:extLst xmlns:a="http://schemas.openxmlformats.org/drawingml/2006/main">
               <a:ext uri="{FF2B5EF4-FFF2-40B4-BE49-F238E27FC236}">
-                <a16:creationId xmlns:a16="http://schemas.microsoft.com/office/drawing/2014/main" id="{32C16931-DFED-4365-951F-DC258E07BD0C}"/>
+                <a16:creationId xmlns:a16="http://schemas.microsoft.com/office/drawing/2014/main" id="{C5D94B2B-0EF4-4876-B1E4-483C162045B1}"/>
               </a:ext>
             </a:extLst>
           </p:cNvPr>
@@ -9068,7 +9125,7 @@
           <p:cNvPr id="37" name="">
             <a:extLst xmlns:a="http://schemas.openxmlformats.org/drawingml/2006/main">
               <a:ext uri="{FF2B5EF4-FFF2-40B4-BE49-F238E27FC236}">
-                <a16:creationId xmlns:a16="http://schemas.microsoft.com/office/drawing/2014/main" id="{A53E753D-3767-47DB-AB83-0FB0205F2B6B}"/>
+                <a16:creationId xmlns:a16="http://schemas.microsoft.com/office/drawing/2014/main" id="{B9CEAC58-0BB5-4B86-BBC7-F4C5D5BBC8D8}"/>
               </a:ext>
             </a:extLst>
           </p:cNvPr>
@@ -9120,7 +9177,7 @@
           <p:cNvPr id="38" name="">
             <a:extLst xmlns:a="http://schemas.openxmlformats.org/drawingml/2006/main">
               <a:ext uri="{FF2B5EF4-FFF2-40B4-BE49-F238E27FC236}">
-                <a16:creationId xmlns:a16="http://schemas.microsoft.com/office/drawing/2014/main" id="{842E5E1C-92B0-4633-8C33-DDB147D22B1D}"/>
+                <a16:creationId xmlns:a16="http://schemas.microsoft.com/office/drawing/2014/main" id="{0EECA901-EBF4-4451-902F-AE6B18DAD2B0}"/>
               </a:ext>
             </a:extLst>
           </p:cNvPr>
@@ -9172,7 +9229,7 @@
           <p:cNvPr id="39" name="">
             <a:extLst xmlns:a="http://schemas.openxmlformats.org/drawingml/2006/main">
               <a:ext uri="{FF2B5EF4-FFF2-40B4-BE49-F238E27FC236}">
-                <a16:creationId xmlns:a16="http://schemas.microsoft.com/office/drawing/2014/main" id="{C96C0035-D17A-442C-A96B-A41AA2497952}"/>
+                <a16:creationId xmlns:a16="http://schemas.microsoft.com/office/drawing/2014/main" id="{E7809386-99F9-4D50-9EF7-FE2536913CA2}"/>
               </a:ext>
             </a:extLst>
           </p:cNvPr>
@@ -9205,7 +9262,7 @@
           <p:cNvPr id="40" name="">
             <a:extLst xmlns:a="http://schemas.openxmlformats.org/drawingml/2006/main">
               <a:ext uri="{FF2B5EF4-FFF2-40B4-BE49-F238E27FC236}">
-                <a16:creationId xmlns:a16="http://schemas.microsoft.com/office/drawing/2014/main" id="{65E352D6-9E21-4F3C-89A4-F693F6782902}"/>
+                <a16:creationId xmlns:a16="http://schemas.microsoft.com/office/drawing/2014/main" id="{4542B809-999C-4276-8893-BDAF6E4014C9}"/>
               </a:ext>
             </a:extLst>
           </p:cNvPr>
@@ -9257,7 +9314,7 @@
           <p:cNvPr id="41" name="">
             <a:extLst xmlns:a="http://schemas.openxmlformats.org/drawingml/2006/main">
               <a:ext uri="{FF2B5EF4-FFF2-40B4-BE49-F238E27FC236}">
-                <a16:creationId xmlns:a16="http://schemas.microsoft.com/office/drawing/2014/main" id="{1EE8F8D4-7EB2-4AEA-97E8-C495899C8637}"/>
+                <a16:creationId xmlns:a16="http://schemas.microsoft.com/office/drawing/2014/main" id="{F8A4E85C-A7D9-4DCD-B727-FCBF69583FA4}"/>
               </a:ext>
             </a:extLst>
           </p:cNvPr>
@@ -9309,7 +9366,7 @@
           <p:cNvPr id="42" name="">
             <a:extLst xmlns:a="http://schemas.openxmlformats.org/drawingml/2006/main">
               <a:ext uri="{FF2B5EF4-FFF2-40B4-BE49-F238E27FC236}">
-                <a16:creationId xmlns:a16="http://schemas.microsoft.com/office/drawing/2014/main" id="{A6829D2B-663E-417B-A91F-44CF9BBE2F8E}"/>
+                <a16:creationId xmlns:a16="http://schemas.microsoft.com/office/drawing/2014/main" id="{22BD0DEE-1E61-4350-AADF-073B02A38792}"/>
               </a:ext>
             </a:extLst>
           </p:cNvPr>
@@ -9361,7 +9418,7 @@
           <p:cNvPr id="43" name="">
             <a:extLst xmlns:a="http://schemas.openxmlformats.org/drawingml/2006/main">
               <a:ext uri="{FF2B5EF4-FFF2-40B4-BE49-F238E27FC236}">
-                <a16:creationId xmlns:a16="http://schemas.microsoft.com/office/drawing/2014/main" id="{62AEF814-A5DE-4D96-9DD8-E3D2544BDA8A}"/>
+                <a16:creationId xmlns:a16="http://schemas.microsoft.com/office/drawing/2014/main" id="{918483EC-B1E2-4B7D-857F-D4B61B0BF800}"/>
               </a:ext>
             </a:extLst>
           </p:cNvPr>
@@ -9413,7 +9470,7 @@
           <p:cNvPr id="44" name="">
             <a:extLst xmlns:a="http://schemas.openxmlformats.org/drawingml/2006/main">
               <a:ext uri="{FF2B5EF4-FFF2-40B4-BE49-F238E27FC236}">
-                <a16:creationId xmlns:a16="http://schemas.microsoft.com/office/drawing/2014/main" id="{CC80606A-C61B-4B54-9931-06FAC12EAA7F}"/>
+                <a16:creationId xmlns:a16="http://schemas.microsoft.com/office/drawing/2014/main" id="{F7C72D06-D023-4FF3-A499-BDECB1C8A7D4}"/>
               </a:ext>
             </a:extLst>
           </p:cNvPr>
@@ -9465,7 +9522,7 @@
           <p:cNvPr id="45" name="">
             <a:extLst xmlns:a="http://schemas.openxmlformats.org/drawingml/2006/main">
               <a:ext uri="{FF2B5EF4-FFF2-40B4-BE49-F238E27FC236}">
-                <a16:creationId xmlns:a16="http://schemas.microsoft.com/office/drawing/2014/main" id="{42B1B1E5-C96A-4EB4-9BF8-70EE6C9F230D}"/>
+                <a16:creationId xmlns:a16="http://schemas.microsoft.com/office/drawing/2014/main" id="{EB648596-47B9-4791-8B48-DE7C804EE18B}"/>
               </a:ext>
             </a:extLst>
           </p:cNvPr>
@@ -9517,7 +9574,7 @@
           <p:cNvPr id="46" name="">
             <a:extLst xmlns:a="http://schemas.openxmlformats.org/drawingml/2006/main">
               <a:ext uri="{FF2B5EF4-FFF2-40B4-BE49-F238E27FC236}">
-                <a16:creationId xmlns:a16="http://schemas.microsoft.com/office/drawing/2014/main" id="{6DB085D9-D1B8-4AE6-B499-4A6764CF1E16}"/>
+                <a16:creationId xmlns:a16="http://schemas.microsoft.com/office/drawing/2014/main" id="{A460F389-A93E-4A0C-8EB1-456587A4E24F}"/>
               </a:ext>
             </a:extLst>
           </p:cNvPr>
@@ -9550,7 +9607,7 @@
           <p:cNvPr id="47" name="">
             <a:extLst xmlns:a="http://schemas.openxmlformats.org/drawingml/2006/main">
               <a:ext uri="{FF2B5EF4-FFF2-40B4-BE49-F238E27FC236}">
-                <a16:creationId xmlns:a16="http://schemas.microsoft.com/office/drawing/2014/main" id="{63B62C60-6263-4EEB-A21F-CECE0A303861}"/>
+                <a16:creationId xmlns:a16="http://schemas.microsoft.com/office/drawing/2014/main" id="{05E275AD-6339-4DDE-859F-FDAAE313CFCD}"/>
               </a:ext>
             </a:extLst>
           </p:cNvPr>
@@ -9602,7 +9659,7 @@
           <p:cNvPr id="48" name="">
             <a:extLst xmlns:a="http://schemas.openxmlformats.org/drawingml/2006/main">
               <a:ext uri="{FF2B5EF4-FFF2-40B4-BE49-F238E27FC236}">
-                <a16:creationId xmlns:a16="http://schemas.microsoft.com/office/drawing/2014/main" id="{0EE2D19F-7A74-469B-863F-2DF0D7C3343E}"/>
+                <a16:creationId xmlns:a16="http://schemas.microsoft.com/office/drawing/2014/main" id="{6E518532-5A04-4413-A616-B8ECD01A2488}"/>
               </a:ext>
             </a:extLst>
           </p:cNvPr>
@@ -9654,7 +9711,7 @@
           <p:cNvPr id="49" name="">
             <a:extLst xmlns:a="http://schemas.openxmlformats.org/drawingml/2006/main">
               <a:ext uri="{FF2B5EF4-FFF2-40B4-BE49-F238E27FC236}">
-                <a16:creationId xmlns:a16="http://schemas.microsoft.com/office/drawing/2014/main" id="{7E2A946E-4E27-4F47-9DE0-27C59A0A443A}"/>
+                <a16:creationId xmlns:a16="http://schemas.microsoft.com/office/drawing/2014/main" id="{8AF02706-27DF-42D1-BD2D-9D985BB16BB2}"/>
               </a:ext>
             </a:extLst>
           </p:cNvPr>
@@ -9706,7 +9763,7 @@
           <p:cNvPr id="50" name="">
             <a:extLst xmlns:a="http://schemas.openxmlformats.org/drawingml/2006/main">
               <a:ext uri="{FF2B5EF4-FFF2-40B4-BE49-F238E27FC236}">
-                <a16:creationId xmlns:a16="http://schemas.microsoft.com/office/drawing/2014/main" id="{0C7E91A8-9DAF-4BF5-846B-A4A94D0EFEB7}"/>
+                <a16:creationId xmlns:a16="http://schemas.microsoft.com/office/drawing/2014/main" id="{4B692C1B-7FA7-4188-80A8-F004F211E7B3}"/>
               </a:ext>
             </a:extLst>
           </p:cNvPr>
@@ -9758,7 +9815,7 @@
           <p:cNvPr id="51" name="">
             <a:extLst xmlns:a="http://schemas.openxmlformats.org/drawingml/2006/main">
               <a:ext uri="{FF2B5EF4-FFF2-40B4-BE49-F238E27FC236}">
-                <a16:creationId xmlns:a16="http://schemas.microsoft.com/office/drawing/2014/main" id="{925237ED-FEAB-4ED6-8210-02F5847D50DD}"/>
+                <a16:creationId xmlns:a16="http://schemas.microsoft.com/office/drawing/2014/main" id="{5CC12024-91DA-408A-9502-6A18823621DA}"/>
               </a:ext>
             </a:extLst>
           </p:cNvPr>
@@ -9810,7 +9867,7 @@
           <p:cNvPr id="52" name="">
             <a:extLst xmlns:a="http://schemas.openxmlformats.org/drawingml/2006/main">
               <a:ext uri="{FF2B5EF4-FFF2-40B4-BE49-F238E27FC236}">
-                <a16:creationId xmlns:a16="http://schemas.microsoft.com/office/drawing/2014/main" id="{1D46A638-3AB1-4E3E-843A-31310DA73448}"/>
+                <a16:creationId xmlns:a16="http://schemas.microsoft.com/office/drawing/2014/main" id="{F223EFEF-CD66-4335-855F-45FF32E5D3CD}"/>
               </a:ext>
             </a:extLst>
           </p:cNvPr>
@@ -9862,7 +9919,7 @@
           <p:cNvPr id="53" name="">
             <a:extLst xmlns:a="http://schemas.openxmlformats.org/drawingml/2006/main">
               <a:ext uri="{FF2B5EF4-FFF2-40B4-BE49-F238E27FC236}">
-                <a16:creationId xmlns:a16="http://schemas.microsoft.com/office/drawing/2014/main" id="{EE8C49E0-1A33-435F-B012-4C4B4D45B6DB}"/>
+                <a16:creationId xmlns:a16="http://schemas.microsoft.com/office/drawing/2014/main" id="{174E9456-B787-423A-B78F-50927B3D9D9C}"/>
               </a:ext>
             </a:extLst>
           </p:cNvPr>
@@ -9895,7 +9952,7 @@
           <p:cNvPr id="54" name="">
             <a:extLst xmlns:a="http://schemas.openxmlformats.org/drawingml/2006/main">
               <a:ext uri="{FF2B5EF4-FFF2-40B4-BE49-F238E27FC236}">
-                <a16:creationId xmlns:a16="http://schemas.microsoft.com/office/drawing/2014/main" id="{610449A4-3D7E-41EC-B919-24363641328E}"/>
+                <a16:creationId xmlns:a16="http://schemas.microsoft.com/office/drawing/2014/main" id="{81130991-3C0F-4CD5-937B-5718FE670F2F}"/>
               </a:ext>
             </a:extLst>
           </p:cNvPr>
@@ -9947,7 +10004,7 @@
           <p:cNvPr id="55" name="">
             <a:extLst xmlns:a="http://schemas.openxmlformats.org/drawingml/2006/main">
               <a:ext uri="{FF2B5EF4-FFF2-40B4-BE49-F238E27FC236}">
-                <a16:creationId xmlns:a16="http://schemas.microsoft.com/office/drawing/2014/main" id="{7F9CF8D7-0468-40B5-BD6F-93529A37C293}"/>
+                <a16:creationId xmlns:a16="http://schemas.microsoft.com/office/drawing/2014/main" id="{82D75298-ACD7-49C4-A49A-39C4E5B7088B}"/>
               </a:ext>
             </a:extLst>
           </p:cNvPr>
@@ -9999,7 +10056,7 @@
           <p:cNvPr id="56" name="">
             <a:extLst xmlns:a="http://schemas.openxmlformats.org/drawingml/2006/main">
               <a:ext uri="{FF2B5EF4-FFF2-40B4-BE49-F238E27FC236}">
-                <a16:creationId xmlns:a16="http://schemas.microsoft.com/office/drawing/2014/main" id="{91139AD4-D469-47DB-A53F-5FC4D1605238}"/>
+                <a16:creationId xmlns:a16="http://schemas.microsoft.com/office/drawing/2014/main" id="{8B287840-61BD-49BD-A07C-2F647F05365E}"/>
               </a:ext>
             </a:extLst>
           </p:cNvPr>
@@ -10051,7 +10108,7 @@
           <p:cNvPr id="57" name="">
             <a:extLst xmlns:a="http://schemas.openxmlformats.org/drawingml/2006/main">
               <a:ext uri="{FF2B5EF4-FFF2-40B4-BE49-F238E27FC236}">
-                <a16:creationId xmlns:a16="http://schemas.microsoft.com/office/drawing/2014/main" id="{84E2FF4F-383C-4CFB-AA71-E3254866CBAF}"/>
+                <a16:creationId xmlns:a16="http://schemas.microsoft.com/office/drawing/2014/main" id="{9BBB23D6-EBC2-4DCE-86C3-1113F67F06FC}"/>
               </a:ext>
             </a:extLst>
           </p:cNvPr>
@@ -10103,7 +10160,7 @@
           <p:cNvPr id="58" name="">
             <a:extLst xmlns:a="http://schemas.openxmlformats.org/drawingml/2006/main">
               <a:ext uri="{FF2B5EF4-FFF2-40B4-BE49-F238E27FC236}">
-                <a16:creationId xmlns:a16="http://schemas.microsoft.com/office/drawing/2014/main" id="{197CAC1C-FC88-47BF-9B16-2297F758ADDE}"/>
+                <a16:creationId xmlns:a16="http://schemas.microsoft.com/office/drawing/2014/main" id="{63E0E2FB-D361-4C14-9F47-D7ABC316C4CF}"/>
               </a:ext>
             </a:extLst>
           </p:cNvPr>
@@ -10155,7 +10212,7 @@
           <p:cNvPr id="59" name="">
             <a:extLst xmlns:a="http://schemas.openxmlformats.org/drawingml/2006/main">
               <a:ext uri="{FF2B5EF4-FFF2-40B4-BE49-F238E27FC236}">
-                <a16:creationId xmlns:a16="http://schemas.microsoft.com/office/drawing/2014/main" id="{46FC6A61-2AAD-47A5-AE79-AE838342011B}"/>
+                <a16:creationId xmlns:a16="http://schemas.microsoft.com/office/drawing/2014/main" id="{0F0DD1F6-3208-4CF1-82D8-19AB04D1CA20}"/>
               </a:ext>
             </a:extLst>
           </p:cNvPr>
@@ -10207,7 +10264,7 @@
           <p:cNvPr id="60" name="">
             <a:extLst xmlns:a="http://schemas.openxmlformats.org/drawingml/2006/main">
               <a:ext uri="{FF2B5EF4-FFF2-40B4-BE49-F238E27FC236}">
-                <a16:creationId xmlns:a16="http://schemas.microsoft.com/office/drawing/2014/main" id="{AD795DEB-4287-49A7-89E3-10DCD0F71661}"/>
+                <a16:creationId xmlns:a16="http://schemas.microsoft.com/office/drawing/2014/main" id="{3A4D9EAB-9809-4C8F-9EBF-F17D99FA3F9C}"/>
               </a:ext>
             </a:extLst>
           </p:cNvPr>
@@ -10259,7 +10316,7 @@
           <p:cNvPr id="61" name="">
             <a:extLst xmlns:a="http://schemas.openxmlformats.org/drawingml/2006/main">
               <a:ext uri="{FF2B5EF4-FFF2-40B4-BE49-F238E27FC236}">
-                <a16:creationId xmlns:a16="http://schemas.microsoft.com/office/drawing/2014/main" id="{196101B6-3795-4E24-83BA-E2C9B1C3DCF9}"/>
+                <a16:creationId xmlns:a16="http://schemas.microsoft.com/office/drawing/2014/main" id="{B910C06D-8C7F-40BB-9CBF-1B2526196CE8}"/>
               </a:ext>
             </a:extLst>
           </p:cNvPr>
@@ -10309,7 +10366,7 @@
     </p:spTree>
     <p:extLst>
       <p:ext uri="{BB962C8B-B14F-4D97-AF65-F5344CB8AC3E}">
-        <p14:creationId xmlns:p14="http://schemas.microsoft.com/office/powerpoint/2010/main" val="393768162"/>
+        <p14:creationId xmlns:p14="http://schemas.microsoft.com/office/powerpoint/2010/main" val="1451115341"/>
       </p:ext>
     </p:extLst>
   </p:cSld>
@@ -10333,7 +10390,7 @@
           <p:cNvPr id="22" name="">
             <a:extLst xmlns:a="http://schemas.openxmlformats.org/drawingml/2006/main">
               <a:ext uri="{FF2B5EF4-FFF2-40B4-BE49-F238E27FC236}">
-                <a16:creationId xmlns:a16="http://schemas.microsoft.com/office/drawing/2014/main" id="{F2A75674-88E5-4B30-8B06-0026EDF801A2}"/>
+                <a16:creationId xmlns:a16="http://schemas.microsoft.com/office/drawing/2014/main" id="{60970E2E-8FD3-4536-9894-45D1C59D358B}"/>
               </a:ext>
             </a:extLst>
           </p:cNvPr>
@@ -10385,7 +10442,7 @@
           <p:cNvPr id="2" name="">
             <a:extLst xmlns:a="http://schemas.openxmlformats.org/drawingml/2006/main">
               <a:ext uri="{FF2B5EF4-FFF2-40B4-BE49-F238E27FC236}">
-                <a16:creationId xmlns:a16="http://schemas.microsoft.com/office/drawing/2014/main" id="{73CAF04E-09E7-4C37-8081-C77D9A6B5734}"/>
+                <a16:creationId xmlns:a16="http://schemas.microsoft.com/office/drawing/2014/main" id="{FA92A7E5-8D16-4BDB-B34A-278846DCEA36}"/>
               </a:ext>
             </a:extLst>
           </p:cNvPr>
@@ -10459,7 +10516,7 @@
           <p:cNvPr id="4" name="">
             <a:extLst xmlns:a="http://schemas.openxmlformats.org/drawingml/2006/main">
               <a:ext uri="{FF2B5EF4-FFF2-40B4-BE49-F238E27FC236}">
-                <a16:creationId xmlns:a16="http://schemas.microsoft.com/office/drawing/2014/main" id="{1A3B2589-C173-4FB3-978E-B12FA3CB2116}"/>
+                <a16:creationId xmlns:a16="http://schemas.microsoft.com/office/drawing/2014/main" id="{4F3E3804-45B0-44EF-9DBD-2FCF2499A475}"/>
               </a:ext>
             </a:extLst>
           </p:cNvPr>
@@ -10511,7 +10568,7 @@
           <p:cNvPr id="5" name="">
             <a:extLst xmlns:a="http://schemas.openxmlformats.org/drawingml/2006/main">
               <a:ext uri="{FF2B5EF4-FFF2-40B4-BE49-F238E27FC236}">
-                <a16:creationId xmlns:a16="http://schemas.microsoft.com/office/drawing/2014/main" id="{BF67C345-9C08-4DC9-B914-8511AC49389E}"/>
+                <a16:creationId xmlns:a16="http://schemas.microsoft.com/office/drawing/2014/main" id="{AA90C89B-C395-45DB-82C2-FD7620DB98EA}"/>
               </a:ext>
             </a:extLst>
           </p:cNvPr>
@@ -10563,7 +10620,7 @@
           <p:cNvPr id="6" name="">
             <a:extLst xmlns:a="http://schemas.openxmlformats.org/drawingml/2006/main">
               <a:ext uri="{FF2B5EF4-FFF2-40B4-BE49-F238E27FC236}">
-                <a16:creationId xmlns:a16="http://schemas.microsoft.com/office/drawing/2014/main" id="{FD63D747-A8AF-4102-932F-290696E39AF9}"/>
+                <a16:creationId xmlns:a16="http://schemas.microsoft.com/office/drawing/2014/main" id="{0B38CD3B-A93A-46F9-8F0B-6D8B3F712DED}"/>
               </a:ext>
             </a:extLst>
           </p:cNvPr>
@@ -10615,7 +10672,7 @@
           <p:cNvPr id="7" name="">
             <a:extLst xmlns:a="http://schemas.openxmlformats.org/drawingml/2006/main">
               <a:ext uri="{FF2B5EF4-FFF2-40B4-BE49-F238E27FC236}">
-                <a16:creationId xmlns:a16="http://schemas.microsoft.com/office/drawing/2014/main" id="{7170A484-444F-4EC3-9F4A-6A23663D9DB0}"/>
+                <a16:creationId xmlns:a16="http://schemas.microsoft.com/office/drawing/2014/main" id="{39F5A2E4-9491-4A8B-809E-D08EE286EC1C}"/>
               </a:ext>
             </a:extLst>
           </p:cNvPr>
@@ -10689,7 +10746,7 @@
           <p:cNvPr id="9" name="">
             <a:extLst xmlns:a="http://schemas.openxmlformats.org/drawingml/2006/main">
               <a:ext uri="{FF2B5EF4-FFF2-40B4-BE49-F238E27FC236}">
-                <a16:creationId xmlns:a16="http://schemas.microsoft.com/office/drawing/2014/main" id="{898F7434-AF75-4337-A0A4-B8D99C7C286A}"/>
+                <a16:creationId xmlns:a16="http://schemas.microsoft.com/office/drawing/2014/main" id="{A4E8E6F8-1E82-40B0-8EAB-2B3EED428FC2}"/>
               </a:ext>
             </a:extLst>
           </p:cNvPr>
@@ -10741,7 +10798,7 @@
           <p:cNvPr id="10" name="">
             <a:extLst xmlns:a="http://schemas.openxmlformats.org/drawingml/2006/main">
               <a:ext uri="{FF2B5EF4-FFF2-40B4-BE49-F238E27FC236}">
-                <a16:creationId xmlns:a16="http://schemas.microsoft.com/office/drawing/2014/main" id="{00521459-48F0-4209-B9CF-F0EC42CC1C21}"/>
+                <a16:creationId xmlns:a16="http://schemas.microsoft.com/office/drawing/2014/main" id="{B4B43627-C8A3-402B-84B7-CAB918880FF2}"/>
               </a:ext>
             </a:extLst>
           </p:cNvPr>
@@ -10793,7 +10850,7 @@
           <p:cNvPr id="11" name="">
             <a:extLst xmlns:a="http://schemas.openxmlformats.org/drawingml/2006/main">
               <a:ext uri="{FF2B5EF4-FFF2-40B4-BE49-F238E27FC236}">
-                <a16:creationId xmlns:a16="http://schemas.microsoft.com/office/drawing/2014/main" id="{5CA1609D-F634-4764-97B9-175775631DCD}"/>
+                <a16:creationId xmlns:a16="http://schemas.microsoft.com/office/drawing/2014/main" id="{FAE3DE49-002C-464C-A3DF-6318AEE175EC}"/>
               </a:ext>
             </a:extLst>
           </p:cNvPr>
@@ -10867,7 +10924,7 @@
           <p:cNvPr id="13" name="">
             <a:extLst xmlns:a="http://schemas.openxmlformats.org/drawingml/2006/main">
               <a:ext uri="{FF2B5EF4-FFF2-40B4-BE49-F238E27FC236}">
-                <a16:creationId xmlns:a16="http://schemas.microsoft.com/office/drawing/2014/main" id="{4036DAFE-D9D9-4691-946E-9219C131A728}"/>
+                <a16:creationId xmlns:a16="http://schemas.microsoft.com/office/drawing/2014/main" id="{F54F91D4-E348-468D-B923-AE271A076048}"/>
               </a:ext>
             </a:extLst>
           </p:cNvPr>
@@ -10919,7 +10976,7 @@
           <p:cNvPr id="14" name="">
             <a:extLst xmlns:a="http://schemas.openxmlformats.org/drawingml/2006/main">
               <a:ext uri="{FF2B5EF4-FFF2-40B4-BE49-F238E27FC236}">
-                <a16:creationId xmlns:a16="http://schemas.microsoft.com/office/drawing/2014/main" id="{C52414F7-F3F0-4D48-87D5-6FF0E82C6687}"/>
+                <a16:creationId xmlns:a16="http://schemas.microsoft.com/office/drawing/2014/main" id="{784D440C-246B-4707-A6CB-DBD8A9C2DE3B}"/>
               </a:ext>
             </a:extLst>
           </p:cNvPr>
@@ -10971,7 +11028,7 @@
           <p:cNvPr id="15" name="">
             <a:extLst xmlns:a="http://schemas.openxmlformats.org/drawingml/2006/main">
               <a:ext uri="{FF2B5EF4-FFF2-40B4-BE49-F238E27FC236}">
-                <a16:creationId xmlns:a16="http://schemas.microsoft.com/office/drawing/2014/main" id="{2CF117D9-58BA-4BF4-94D4-527382C03053}"/>
+                <a16:creationId xmlns:a16="http://schemas.microsoft.com/office/drawing/2014/main" id="{81577C87-CE0C-4D45-8D3D-4BAF11808E8D}"/>
               </a:ext>
             </a:extLst>
           </p:cNvPr>
@@ -11045,7 +11102,7 @@
           <p:cNvPr id="17" name="">
             <a:extLst xmlns:a="http://schemas.openxmlformats.org/drawingml/2006/main">
               <a:ext uri="{FF2B5EF4-FFF2-40B4-BE49-F238E27FC236}">
-                <a16:creationId xmlns:a16="http://schemas.microsoft.com/office/drawing/2014/main" id="{0AE75290-162F-401D-AE3B-D78BCF19F995}"/>
+                <a16:creationId xmlns:a16="http://schemas.microsoft.com/office/drawing/2014/main" id="{B24D1C58-317B-483C-BF87-6BC12836E6E1}"/>
               </a:ext>
             </a:extLst>
           </p:cNvPr>
@@ -11097,7 +11154,7 @@
           <p:cNvPr id="18" name="">
             <a:extLst xmlns:a="http://schemas.openxmlformats.org/drawingml/2006/main">
               <a:ext uri="{FF2B5EF4-FFF2-40B4-BE49-F238E27FC236}">
-                <a16:creationId xmlns:a16="http://schemas.microsoft.com/office/drawing/2014/main" id="{0004CAF9-3D7D-44E5-B5DF-17A8D0B7D8F0}"/>
+                <a16:creationId xmlns:a16="http://schemas.microsoft.com/office/drawing/2014/main" id="{1A3E3BA1-4691-45B3-BC5E-02CE5893C3FC}"/>
               </a:ext>
             </a:extLst>
           </p:cNvPr>
@@ -11149,7 +11206,7 @@
           <p:cNvPr id="19" name="">
             <a:extLst xmlns:a="http://schemas.openxmlformats.org/drawingml/2006/main">
               <a:ext uri="{FF2B5EF4-FFF2-40B4-BE49-F238E27FC236}">
-                <a16:creationId xmlns:a16="http://schemas.microsoft.com/office/drawing/2014/main" id="{C9D5A380-0353-4556-BE14-796C73224C2C}"/>
+                <a16:creationId xmlns:a16="http://schemas.microsoft.com/office/drawing/2014/main" id="{6D138489-1B4C-46CA-9EA0-7140FE80B902}"/>
               </a:ext>
             </a:extLst>
           </p:cNvPr>
@@ -11223,7 +11280,7 @@
           <p:cNvPr id="21" name="">
             <a:extLst xmlns:a="http://schemas.openxmlformats.org/drawingml/2006/main">
               <a:ext uri="{FF2B5EF4-FFF2-40B4-BE49-F238E27FC236}">
-                <a16:creationId xmlns:a16="http://schemas.microsoft.com/office/drawing/2014/main" id="{1F8238C3-C4D6-4D72-9D86-89B434BFDB89}"/>
+                <a16:creationId xmlns:a16="http://schemas.microsoft.com/office/drawing/2014/main" id="{DED1D88B-47F8-4C66-A421-2165B6367957}"/>
               </a:ext>
             </a:extLst>
           </p:cNvPr>
@@ -11273,7 +11330,7 @@
     </p:spTree>
     <p:extLst>
       <p:ext uri="{BB962C8B-B14F-4D97-AF65-F5344CB8AC3E}">
-        <p14:creationId xmlns:p14="http://schemas.microsoft.com/office/powerpoint/2010/main" val="55913848"/>
+        <p14:creationId xmlns:p14="http://schemas.microsoft.com/office/powerpoint/2010/main" val="996912720"/>
       </p:ext>
     </p:extLst>
   </p:cSld>
@@ -11297,7 +11354,7 @@
           <p:cNvPr id="25" name="">
             <a:extLst xmlns:a="http://schemas.openxmlformats.org/drawingml/2006/main">
               <a:ext uri="{FF2B5EF4-FFF2-40B4-BE49-F238E27FC236}">
-                <a16:creationId xmlns:a16="http://schemas.microsoft.com/office/drawing/2014/main" id="{3F58D8E2-396F-4917-A303-32FBEF995F58}"/>
+                <a16:creationId xmlns:a16="http://schemas.microsoft.com/office/drawing/2014/main" id="{2AF13D41-384B-44FC-8702-8035DA423DFF}"/>
               </a:ext>
             </a:extLst>
           </p:cNvPr>
@@ -11349,7 +11406,7 @@
           <p:cNvPr id="2" name="">
             <a:extLst xmlns:a="http://schemas.openxmlformats.org/drawingml/2006/main">
               <a:ext uri="{FF2B5EF4-FFF2-40B4-BE49-F238E27FC236}">
-                <a16:creationId xmlns:a16="http://schemas.microsoft.com/office/drawing/2014/main" id="{ECB42E57-0B87-46F4-AAF5-E088DF2EE7ED}"/>
+                <a16:creationId xmlns:a16="http://schemas.microsoft.com/office/drawing/2014/main" id="{17A8543B-5A86-4489-9F06-ED9A15068367}"/>
               </a:ext>
             </a:extLst>
           </p:cNvPr>
@@ -11423,7 +11480,7 @@
           <p:cNvPr id="4" name="">
             <a:extLst xmlns:a="http://schemas.openxmlformats.org/drawingml/2006/main">
               <a:ext uri="{FF2B5EF4-FFF2-40B4-BE49-F238E27FC236}">
-                <a16:creationId xmlns:a16="http://schemas.microsoft.com/office/drawing/2014/main" id="{C733F7DC-0FB0-4016-9823-736341998480}"/>
+                <a16:creationId xmlns:a16="http://schemas.microsoft.com/office/drawing/2014/main" id="{0F4AC5DF-14F0-4BC9-AAAB-61DC588A96A8}"/>
               </a:ext>
             </a:extLst>
           </p:cNvPr>
@@ -11475,7 +11532,7 @@
           <p:cNvPr id="5" name="">
             <a:extLst xmlns:a="http://schemas.openxmlformats.org/drawingml/2006/main">
               <a:ext uri="{FF2B5EF4-FFF2-40B4-BE49-F238E27FC236}">
-                <a16:creationId xmlns:a16="http://schemas.microsoft.com/office/drawing/2014/main" id="{2A325179-1398-4D89-9DD8-44A4DE96538F}"/>
+                <a16:creationId xmlns:a16="http://schemas.microsoft.com/office/drawing/2014/main" id="{AAFA1096-8B0C-4BBE-9E97-52B45C6F79CD}"/>
               </a:ext>
             </a:extLst>
           </p:cNvPr>
@@ -11508,7 +11565,7 @@
           <p:cNvPr id="6" name="">
             <a:extLst xmlns:a="http://schemas.openxmlformats.org/drawingml/2006/main">
               <a:ext uri="{FF2B5EF4-FFF2-40B4-BE49-F238E27FC236}">
-                <a16:creationId xmlns:a16="http://schemas.microsoft.com/office/drawing/2014/main" id="{B0D8D3C3-9BDC-4967-966E-64D4F8045245}"/>
+                <a16:creationId xmlns:a16="http://schemas.microsoft.com/office/drawing/2014/main" id="{E65473A9-2C37-41EE-9801-DC5B6ACE73E5}"/>
               </a:ext>
             </a:extLst>
           </p:cNvPr>
@@ -11560,7 +11617,7 @@
           <p:cNvPr id="7" name="">
             <a:extLst xmlns:a="http://schemas.openxmlformats.org/drawingml/2006/main">
               <a:ext uri="{FF2B5EF4-FFF2-40B4-BE49-F238E27FC236}">
-                <a16:creationId xmlns:a16="http://schemas.microsoft.com/office/drawing/2014/main" id="{449626B6-FB6A-4CF8-8A51-3CC910D55756}"/>
+                <a16:creationId xmlns:a16="http://schemas.microsoft.com/office/drawing/2014/main" id="{92D55B2B-B6AA-4B0A-B34D-F675AC04E1BB}"/>
               </a:ext>
             </a:extLst>
           </p:cNvPr>
@@ -11612,7 +11669,7 @@
           <p:cNvPr id="8" name="">
             <a:extLst xmlns:a="http://schemas.openxmlformats.org/drawingml/2006/main">
               <a:ext uri="{FF2B5EF4-FFF2-40B4-BE49-F238E27FC236}">
-                <a16:creationId xmlns:a16="http://schemas.microsoft.com/office/drawing/2014/main" id="{417E96EC-CEFD-4F8A-AA6B-9E92D05D32B0}"/>
+                <a16:creationId xmlns:a16="http://schemas.microsoft.com/office/drawing/2014/main" id="{ECEF3212-3F84-4774-9B7D-D8CEB0777D33}"/>
               </a:ext>
             </a:extLst>
           </p:cNvPr>
@@ -11645,7 +11702,7 @@
           <p:cNvPr id="9" name="">
             <a:extLst xmlns:a="http://schemas.openxmlformats.org/drawingml/2006/main">
               <a:ext uri="{FF2B5EF4-FFF2-40B4-BE49-F238E27FC236}">
-                <a16:creationId xmlns:a16="http://schemas.microsoft.com/office/drawing/2014/main" id="{F2AD7B4C-5F37-4174-932A-25D3FD4B4E4E}"/>
+                <a16:creationId xmlns:a16="http://schemas.microsoft.com/office/drawing/2014/main" id="{A6460FA5-227F-456A-8F66-E4884C8E9A5A}"/>
               </a:ext>
             </a:extLst>
           </p:cNvPr>
@@ -11697,7 +11754,7 @@
           <p:cNvPr id="10" name="">
             <a:extLst xmlns:a="http://schemas.openxmlformats.org/drawingml/2006/main">
               <a:ext uri="{FF2B5EF4-FFF2-40B4-BE49-F238E27FC236}">
-                <a16:creationId xmlns:a16="http://schemas.microsoft.com/office/drawing/2014/main" id="{90AFBE55-B19B-4A40-9C49-C0ABE440CD47}"/>
+                <a16:creationId xmlns:a16="http://schemas.microsoft.com/office/drawing/2014/main" id="{C7836AF5-6D66-4DEA-8AD8-FB243D63B13D}"/>
               </a:ext>
             </a:extLst>
           </p:cNvPr>
@@ -11749,7 +11806,7 @@
           <p:cNvPr id="11" name="">
             <a:extLst xmlns:a="http://schemas.openxmlformats.org/drawingml/2006/main">
               <a:ext uri="{FF2B5EF4-FFF2-40B4-BE49-F238E27FC236}">
-                <a16:creationId xmlns:a16="http://schemas.microsoft.com/office/drawing/2014/main" id="{1FA8085F-5F0D-4D51-B3EF-B32601F1C73E}"/>
+                <a16:creationId xmlns:a16="http://schemas.microsoft.com/office/drawing/2014/main" id="{DF308995-0829-40DF-9AB3-83A9EE8D6E8D}"/>
               </a:ext>
             </a:extLst>
           </p:cNvPr>
@@ -11782,7 +11839,7 @@
           <p:cNvPr id="12" name="">
             <a:extLst xmlns:a="http://schemas.openxmlformats.org/drawingml/2006/main">
               <a:ext uri="{FF2B5EF4-FFF2-40B4-BE49-F238E27FC236}">
-                <a16:creationId xmlns:a16="http://schemas.microsoft.com/office/drawing/2014/main" id="{7D6585EF-A9AF-46F1-A774-82FA75B5F594}"/>
+                <a16:creationId xmlns:a16="http://schemas.microsoft.com/office/drawing/2014/main" id="{999AB069-6380-468A-9964-F091C9E30E55}"/>
               </a:ext>
             </a:extLst>
           </p:cNvPr>
@@ -11834,7 +11891,7 @@
           <p:cNvPr id="13" name="">
             <a:extLst xmlns:a="http://schemas.openxmlformats.org/drawingml/2006/main">
               <a:ext uri="{FF2B5EF4-FFF2-40B4-BE49-F238E27FC236}">
-                <a16:creationId xmlns:a16="http://schemas.microsoft.com/office/drawing/2014/main" id="{AAA9116A-1CA3-4C5D-AA31-9BD425C3E527}"/>
+                <a16:creationId xmlns:a16="http://schemas.microsoft.com/office/drawing/2014/main" id="{DA6624F6-8E84-47D0-B898-1CF7CE109E27}"/>
               </a:ext>
             </a:extLst>
           </p:cNvPr>
@@ -11886,7 +11943,7 @@
           <p:cNvPr id="14" name="">
             <a:extLst xmlns:a="http://schemas.openxmlformats.org/drawingml/2006/main">
               <a:ext uri="{FF2B5EF4-FFF2-40B4-BE49-F238E27FC236}">
-                <a16:creationId xmlns:a16="http://schemas.microsoft.com/office/drawing/2014/main" id="{4D7713FC-1103-4BB8-949D-DD84CD1B0A57}"/>
+                <a16:creationId xmlns:a16="http://schemas.microsoft.com/office/drawing/2014/main" id="{66CE4DD6-19ED-4E83-B715-DBD2F8D78734}"/>
               </a:ext>
             </a:extLst>
           </p:cNvPr>
@@ -11919,7 +11976,7 @@
           <p:cNvPr id="15" name="">
             <a:extLst xmlns:a="http://schemas.openxmlformats.org/drawingml/2006/main">
               <a:ext uri="{FF2B5EF4-FFF2-40B4-BE49-F238E27FC236}">
-                <a16:creationId xmlns:a16="http://schemas.microsoft.com/office/drawing/2014/main" id="{33C7189E-9BC3-4105-A51B-13AC817CAB15}"/>
+                <a16:creationId xmlns:a16="http://schemas.microsoft.com/office/drawing/2014/main" id="{913D84E2-8D3B-4E6D-B9CE-37AD2E6EA89D}"/>
               </a:ext>
             </a:extLst>
           </p:cNvPr>
@@ -11971,7 +12028,7 @@
           <p:cNvPr id="16" name="">
             <a:extLst xmlns:a="http://schemas.openxmlformats.org/drawingml/2006/main">
               <a:ext uri="{FF2B5EF4-FFF2-40B4-BE49-F238E27FC236}">
-                <a16:creationId xmlns:a16="http://schemas.microsoft.com/office/drawing/2014/main" id="{3D55F48B-60BC-445C-A62D-8F715008389B}"/>
+                <a16:creationId xmlns:a16="http://schemas.microsoft.com/office/drawing/2014/main" id="{D8C8B8B2-687D-45B2-82FA-3A37EF3B50FF}"/>
               </a:ext>
             </a:extLst>
           </p:cNvPr>
@@ -12023,7 +12080,7 @@
           <p:cNvPr id="17" name="">
             <a:extLst xmlns:a="http://schemas.openxmlformats.org/drawingml/2006/main">
               <a:ext uri="{FF2B5EF4-FFF2-40B4-BE49-F238E27FC236}">
-                <a16:creationId xmlns:a16="http://schemas.microsoft.com/office/drawing/2014/main" id="{30FA22AD-F5B5-4E8C-AB9D-6E69FBBD424A}"/>
+                <a16:creationId xmlns:a16="http://schemas.microsoft.com/office/drawing/2014/main" id="{7B84DBB5-8763-4161-AABE-8A57F51760B2}"/>
               </a:ext>
             </a:extLst>
           </p:cNvPr>
@@ -12056,7 +12113,7 @@
           <p:cNvPr id="18" name="">
             <a:extLst xmlns:a="http://schemas.openxmlformats.org/drawingml/2006/main">
               <a:ext uri="{FF2B5EF4-FFF2-40B4-BE49-F238E27FC236}">
-                <a16:creationId xmlns:a16="http://schemas.microsoft.com/office/drawing/2014/main" id="{64160828-E384-41C6-BF9D-5A7BAAB2DF10}"/>
+                <a16:creationId xmlns:a16="http://schemas.microsoft.com/office/drawing/2014/main" id="{9EE1470E-21E8-4315-8B00-18214FAEBC0B}"/>
               </a:ext>
             </a:extLst>
           </p:cNvPr>
@@ -12108,7 +12165,7 @@
           <p:cNvPr id="19" name="">
             <a:extLst xmlns:a="http://schemas.openxmlformats.org/drawingml/2006/main">
               <a:ext uri="{FF2B5EF4-FFF2-40B4-BE49-F238E27FC236}">
-                <a16:creationId xmlns:a16="http://schemas.microsoft.com/office/drawing/2014/main" id="{72587B33-25D1-4330-98D2-64FCFE6E015B}"/>
+                <a16:creationId xmlns:a16="http://schemas.microsoft.com/office/drawing/2014/main" id="{09B7ACE9-510D-498D-9C91-8454E6698417}"/>
               </a:ext>
             </a:extLst>
           </p:cNvPr>
@@ -12160,7 +12217,7 @@
           <p:cNvPr id="20" name="">
             <a:extLst xmlns:a="http://schemas.openxmlformats.org/drawingml/2006/main">
               <a:ext uri="{FF2B5EF4-FFF2-40B4-BE49-F238E27FC236}">
-                <a16:creationId xmlns:a16="http://schemas.microsoft.com/office/drawing/2014/main" id="{9A4BF170-6C6B-416F-B585-C26B62EAA0DE}"/>
+                <a16:creationId xmlns:a16="http://schemas.microsoft.com/office/drawing/2014/main" id="{CC4EE7F2-190E-4432-8698-8DB3539F0967}"/>
               </a:ext>
             </a:extLst>
           </p:cNvPr>
@@ -12193,7 +12250,7 @@
           <p:cNvPr id="21" name="">
             <a:extLst xmlns:a="http://schemas.openxmlformats.org/drawingml/2006/main">
               <a:ext uri="{FF2B5EF4-FFF2-40B4-BE49-F238E27FC236}">
-                <a16:creationId xmlns:a16="http://schemas.microsoft.com/office/drawing/2014/main" id="{686102E9-0D16-48DD-B413-8491FE06DCFE}"/>
+                <a16:creationId xmlns:a16="http://schemas.microsoft.com/office/drawing/2014/main" id="{B79EC144-6E31-4C4B-8EC8-D360ADAEB9C8}"/>
               </a:ext>
             </a:extLst>
           </p:cNvPr>
@@ -12245,7 +12302,7 @@
           <p:cNvPr id="22" name="">
             <a:extLst xmlns:a="http://schemas.openxmlformats.org/drawingml/2006/main">
               <a:ext uri="{FF2B5EF4-FFF2-40B4-BE49-F238E27FC236}">
-                <a16:creationId xmlns:a16="http://schemas.microsoft.com/office/drawing/2014/main" id="{3764CBE5-6A9F-4476-9E60-1CEF045ACF84}"/>
+                <a16:creationId xmlns:a16="http://schemas.microsoft.com/office/drawing/2014/main" id="{2FCFDF18-BED8-42C4-BF06-B8AB1CFE1BBA}"/>
               </a:ext>
             </a:extLst>
           </p:cNvPr>
@@ -12297,7 +12354,7 @@
           <p:cNvPr id="23" name="">
             <a:extLst xmlns:a="http://schemas.openxmlformats.org/drawingml/2006/main">
               <a:ext uri="{FF2B5EF4-FFF2-40B4-BE49-F238E27FC236}">
-                <a16:creationId xmlns:a16="http://schemas.microsoft.com/office/drawing/2014/main" id="{2DA63EC5-4BFD-4005-8013-182748C7ACE5}"/>
+                <a16:creationId xmlns:a16="http://schemas.microsoft.com/office/drawing/2014/main" id="{2B16EE8A-0B1F-4398-84E1-775A3466CE55}"/>
               </a:ext>
             </a:extLst>
           </p:cNvPr>
@@ -12349,7 +12406,7 @@
           <p:cNvPr id="24" name="">
             <a:extLst xmlns:a="http://schemas.openxmlformats.org/drawingml/2006/main">
               <a:ext uri="{FF2B5EF4-FFF2-40B4-BE49-F238E27FC236}">
-                <a16:creationId xmlns:a16="http://schemas.microsoft.com/office/drawing/2014/main" id="{7436C303-FE65-4467-A049-F467BCB63866}"/>
+                <a16:creationId xmlns:a16="http://schemas.microsoft.com/office/drawing/2014/main" id="{C4A25C3E-92EE-4205-941B-370E8FDAFFF2}"/>
               </a:ext>
             </a:extLst>
           </p:cNvPr>
@@ -12399,7 +12456,7 @@
     </p:spTree>
     <p:extLst>
       <p:ext uri="{BB962C8B-B14F-4D97-AF65-F5344CB8AC3E}">
-        <p14:creationId xmlns:p14="http://schemas.microsoft.com/office/powerpoint/2010/main" val="1749167989"/>
+        <p14:creationId xmlns:p14="http://schemas.microsoft.com/office/powerpoint/2010/main" val="1339088727"/>
       </p:ext>
     </p:extLst>
   </p:cSld>
@@ -12423,7 +12480,7 @@
           <p:cNvPr id="4" name="">
             <a:extLst xmlns:a="http://schemas.openxmlformats.org/drawingml/2006/main">
               <a:ext uri="{FF2B5EF4-FFF2-40B4-BE49-F238E27FC236}">
-                <a16:creationId xmlns:a16="http://schemas.microsoft.com/office/drawing/2014/main" id="{ADD60F4D-DC37-41E8-AC8C-BE9C10606763}"/>
+                <a16:creationId xmlns:a16="http://schemas.microsoft.com/office/drawing/2014/main" id="{EC3212E8-C8E6-46A7-81E6-26D44180E59F}"/>
               </a:ext>
             </a:extLst>
           </p:cNvPr>
@@ -12475,7 +12532,7 @@
           <p:cNvPr id="2" name="">
             <a:extLst xmlns:a="http://schemas.openxmlformats.org/drawingml/2006/main">
               <a:ext uri="{FF2B5EF4-FFF2-40B4-BE49-F238E27FC236}">
-                <a16:creationId xmlns:a16="http://schemas.microsoft.com/office/drawing/2014/main" id="{D2EA3E37-91DF-450E-93E1-575EAD111444}"/>
+                <a16:creationId xmlns:a16="http://schemas.microsoft.com/office/drawing/2014/main" id="{BE1A83F6-8210-4F21-BCFF-AA19246964F8}"/>
               </a:ext>
             </a:extLst>
           </p:cNvPr>
@@ -12544,7 +12601,7 @@
           <p:cNvPr id="3" name="">
             <a:extLst xmlns:a="http://schemas.openxmlformats.org/drawingml/2006/main">
               <a:ext uri="{FF2B5EF4-FFF2-40B4-BE49-F238E27FC236}">
-                <a16:creationId xmlns:a16="http://schemas.microsoft.com/office/drawing/2014/main" id="{994CC157-841F-478B-9B3B-A335DDB8582A}"/>
+                <a16:creationId xmlns:a16="http://schemas.microsoft.com/office/drawing/2014/main" id="{B0A1A8DB-13F7-461E-8DD7-6EC7EA583E22}"/>
               </a:ext>
             </a:extLst>
           </p:cNvPr>
@@ -12594,7 +12651,7 @@
     </p:spTree>
     <p:extLst>
       <p:ext uri="{BB962C8B-B14F-4D97-AF65-F5344CB8AC3E}">
-        <p14:creationId xmlns:p14="http://schemas.microsoft.com/office/powerpoint/2010/main" val="209460147"/>
+        <p14:creationId xmlns:p14="http://schemas.microsoft.com/office/powerpoint/2010/main" val="1643726169"/>
       </p:ext>
     </p:extLst>
   </p:cSld>
@@ -12618,7 +12675,7 @@
           <p:cNvPr id="29" name="">
             <a:extLst xmlns:a="http://schemas.openxmlformats.org/drawingml/2006/main">
               <a:ext uri="{FF2B5EF4-FFF2-40B4-BE49-F238E27FC236}">
-                <a16:creationId xmlns:a16="http://schemas.microsoft.com/office/drawing/2014/main" id="{5F2F8E6F-BBF7-42FB-BA78-69F8466803C5}"/>
+                <a16:creationId xmlns:a16="http://schemas.microsoft.com/office/drawing/2014/main" id="{91C36205-8A87-425A-8A47-1EB2A43DD8D5}"/>
               </a:ext>
             </a:extLst>
           </p:cNvPr>
@@ -12670,7 +12727,7 @@
           <p:cNvPr id="2" name="">
             <a:extLst xmlns:a="http://schemas.openxmlformats.org/drawingml/2006/main">
               <a:ext uri="{FF2B5EF4-FFF2-40B4-BE49-F238E27FC236}">
-                <a16:creationId xmlns:a16="http://schemas.microsoft.com/office/drawing/2014/main" id="{D4E21DEB-C9B4-4B61-AD78-8DAC42D8E0F8}"/>
+                <a16:creationId xmlns:a16="http://schemas.microsoft.com/office/drawing/2014/main" id="{35A8DE09-1905-473A-877F-200C6A7419FC}"/>
               </a:ext>
             </a:extLst>
           </p:cNvPr>
@@ -12744,7 +12801,7 @@
           <p:cNvPr id="4" name="">
             <a:extLst xmlns:a="http://schemas.openxmlformats.org/drawingml/2006/main">
               <a:ext uri="{FF2B5EF4-FFF2-40B4-BE49-F238E27FC236}">
-                <a16:creationId xmlns:a16="http://schemas.microsoft.com/office/drawing/2014/main" id="{5B6132FD-85BD-401C-AC3E-60B87EDD66B8}"/>
+                <a16:creationId xmlns:a16="http://schemas.microsoft.com/office/drawing/2014/main" id="{93AA850E-90BA-452C-8A22-450F4112A201}"/>
               </a:ext>
             </a:extLst>
           </p:cNvPr>
@@ -12796,7 +12853,7 @@
           <p:cNvPr id="5" name="">
             <a:extLst xmlns:a="http://schemas.openxmlformats.org/drawingml/2006/main">
               <a:ext uri="{FF2B5EF4-FFF2-40B4-BE49-F238E27FC236}">
-                <a16:creationId xmlns:a16="http://schemas.microsoft.com/office/drawing/2014/main" id="{2D4222EE-B3BD-4134-8EFD-BAD86EFA8CE6}"/>
+                <a16:creationId xmlns:a16="http://schemas.microsoft.com/office/drawing/2014/main" id="{A7499C20-2EC7-4E26-912E-4241914006C6}"/>
               </a:ext>
             </a:extLst>
           </p:cNvPr>
@@ -12848,7 +12905,7 @@
           <p:cNvPr id="6" name="">
             <a:extLst xmlns:a="http://schemas.openxmlformats.org/drawingml/2006/main">
               <a:ext uri="{FF2B5EF4-FFF2-40B4-BE49-F238E27FC236}">
-                <a16:creationId xmlns:a16="http://schemas.microsoft.com/office/drawing/2014/main" id="{3667C42D-6CAC-4A43-8DE4-6504F77462E8}"/>
+                <a16:creationId xmlns:a16="http://schemas.microsoft.com/office/drawing/2014/main" id="{3220DBAF-3839-4513-A2E6-F4DCC70E9F5F}"/>
               </a:ext>
             </a:extLst>
           </p:cNvPr>
@@ -12922,7 +12979,7 @@
           <p:cNvPr id="8" name="">
             <a:extLst xmlns:a="http://schemas.openxmlformats.org/drawingml/2006/main">
               <a:ext uri="{FF2B5EF4-FFF2-40B4-BE49-F238E27FC236}">
-                <a16:creationId xmlns:a16="http://schemas.microsoft.com/office/drawing/2014/main" id="{9BCD67FF-263F-4A2D-97F1-2C98BD8E946E}"/>
+                <a16:creationId xmlns:a16="http://schemas.microsoft.com/office/drawing/2014/main" id="{007DE88F-DB64-4E04-A5DF-2BDC5AA9E03A}"/>
               </a:ext>
             </a:extLst>
           </p:cNvPr>
@@ -12974,7 +13031,7 @@
           <p:cNvPr id="9" name="">
             <a:extLst xmlns:a="http://schemas.openxmlformats.org/drawingml/2006/main">
               <a:ext uri="{FF2B5EF4-FFF2-40B4-BE49-F238E27FC236}">
-                <a16:creationId xmlns:a16="http://schemas.microsoft.com/office/drawing/2014/main" id="{11E4F25C-2FC3-4EDD-BD72-6CF642D2DA71}"/>
+                <a16:creationId xmlns:a16="http://schemas.microsoft.com/office/drawing/2014/main" id="{3F365B88-17C1-4B75-97AB-FEFF063ADBF0}"/>
               </a:ext>
             </a:extLst>
           </p:cNvPr>
@@ -13048,7 +13105,7 @@
           <p:cNvPr id="11" name="">
             <a:extLst xmlns:a="http://schemas.openxmlformats.org/drawingml/2006/main">
               <a:ext uri="{FF2B5EF4-FFF2-40B4-BE49-F238E27FC236}">
-                <a16:creationId xmlns:a16="http://schemas.microsoft.com/office/drawing/2014/main" id="{61112642-F04A-4624-B43E-3EFB627E762F}"/>
+                <a16:creationId xmlns:a16="http://schemas.microsoft.com/office/drawing/2014/main" id="{C0D75934-906B-4DD7-8203-D3A1354C2982}"/>
               </a:ext>
             </a:extLst>
           </p:cNvPr>
@@ -13100,7 +13157,7 @@
           <p:cNvPr id="12" name="">
             <a:extLst xmlns:a="http://schemas.openxmlformats.org/drawingml/2006/main">
               <a:ext uri="{FF2B5EF4-FFF2-40B4-BE49-F238E27FC236}">
-                <a16:creationId xmlns:a16="http://schemas.microsoft.com/office/drawing/2014/main" id="{D810A226-F2EB-4D12-B11E-06E41031B5AA}"/>
+                <a16:creationId xmlns:a16="http://schemas.microsoft.com/office/drawing/2014/main" id="{0216C918-3BE5-489F-A933-35DB70B7F2B4}"/>
               </a:ext>
             </a:extLst>
           </p:cNvPr>
@@ -13174,7 +13231,7 @@
           <p:cNvPr id="14" name="">
             <a:extLst xmlns:a="http://schemas.openxmlformats.org/drawingml/2006/main">
               <a:ext uri="{FF2B5EF4-FFF2-40B4-BE49-F238E27FC236}">
-                <a16:creationId xmlns:a16="http://schemas.microsoft.com/office/drawing/2014/main" id="{25889E46-A80A-4466-AB71-A2282B04DAE7}"/>
+                <a16:creationId xmlns:a16="http://schemas.microsoft.com/office/drawing/2014/main" id="{D6F6F421-3AA4-4675-98D1-15CC4CC1A5E4}"/>
               </a:ext>
             </a:extLst>
           </p:cNvPr>
@@ -13226,7 +13283,7 @@
           <p:cNvPr id="15" name="">
             <a:extLst xmlns:a="http://schemas.openxmlformats.org/drawingml/2006/main">
               <a:ext uri="{FF2B5EF4-FFF2-40B4-BE49-F238E27FC236}">
-                <a16:creationId xmlns:a16="http://schemas.microsoft.com/office/drawing/2014/main" id="{6D7BA15E-83C5-43B5-BC7C-A00B57452D5F}"/>
+                <a16:creationId xmlns:a16="http://schemas.microsoft.com/office/drawing/2014/main" id="{75D18599-2FBE-4CF4-BF69-1BD8B4BDC999}"/>
               </a:ext>
             </a:extLst>
           </p:cNvPr>
@@ -13300,7 +13357,7 @@
           <p:cNvPr id="17" name="">
             <a:extLst xmlns:a="http://schemas.openxmlformats.org/drawingml/2006/main">
               <a:ext uri="{FF2B5EF4-FFF2-40B4-BE49-F238E27FC236}">
-                <a16:creationId xmlns:a16="http://schemas.microsoft.com/office/drawing/2014/main" id="{5DD408CB-E77E-42D7-B20A-C15107FA00E3}"/>
+                <a16:creationId xmlns:a16="http://schemas.microsoft.com/office/drawing/2014/main" id="{70F6607F-2882-4586-992D-BED28B3D552B}"/>
               </a:ext>
             </a:extLst>
           </p:cNvPr>
@@ -13352,7 +13409,7 @@
           <p:cNvPr id="18" name="">
             <a:extLst xmlns:a="http://schemas.openxmlformats.org/drawingml/2006/main">
               <a:ext uri="{FF2B5EF4-FFF2-40B4-BE49-F238E27FC236}">
-                <a16:creationId xmlns:a16="http://schemas.microsoft.com/office/drawing/2014/main" id="{6A39C49D-3D3C-46DE-A675-41C676C9C032}"/>
+                <a16:creationId xmlns:a16="http://schemas.microsoft.com/office/drawing/2014/main" id="{4067C802-C866-4585-BD3D-ABF6ED8F69EE}"/>
               </a:ext>
             </a:extLst>
           </p:cNvPr>
@@ -13426,7 +13483,7 @@
           <p:cNvPr id="20" name="">
             <a:extLst xmlns:a="http://schemas.openxmlformats.org/drawingml/2006/main">
               <a:ext uri="{FF2B5EF4-FFF2-40B4-BE49-F238E27FC236}">
-                <a16:creationId xmlns:a16="http://schemas.microsoft.com/office/drawing/2014/main" id="{81B05A8E-2AFC-4F54-98E5-285D4C942A09}"/>
+                <a16:creationId xmlns:a16="http://schemas.microsoft.com/office/drawing/2014/main" id="{4F9A0470-FD7C-48D6-8112-463B6A435C49}"/>
               </a:ext>
             </a:extLst>
           </p:cNvPr>
@@ -13478,7 +13535,7 @@
           <p:cNvPr id="21" name="">
             <a:extLst xmlns:a="http://schemas.openxmlformats.org/drawingml/2006/main">
               <a:ext uri="{FF2B5EF4-FFF2-40B4-BE49-F238E27FC236}">
-                <a16:creationId xmlns:a16="http://schemas.microsoft.com/office/drawing/2014/main" id="{6782D545-D252-4B38-8E14-15A5BC055CA3}"/>
+                <a16:creationId xmlns:a16="http://schemas.microsoft.com/office/drawing/2014/main" id="{C1BE21C2-5C2A-43DF-A84A-0E4C061B5D29}"/>
               </a:ext>
             </a:extLst>
           </p:cNvPr>
@@ -13552,7 +13609,7 @@
           <p:cNvPr id="23" name="">
             <a:extLst xmlns:a="http://schemas.openxmlformats.org/drawingml/2006/main">
               <a:ext uri="{FF2B5EF4-FFF2-40B4-BE49-F238E27FC236}">
-                <a16:creationId xmlns:a16="http://schemas.microsoft.com/office/drawing/2014/main" id="{7A49C653-51EB-4241-B20B-52FAF2832A9D}"/>
+                <a16:creationId xmlns:a16="http://schemas.microsoft.com/office/drawing/2014/main" id="{DAABD804-0CE4-4F9C-BF70-599A0A19F368}"/>
               </a:ext>
             </a:extLst>
           </p:cNvPr>
@@ -13604,7 +13661,7 @@
           <p:cNvPr id="24" name="">
             <a:extLst xmlns:a="http://schemas.openxmlformats.org/drawingml/2006/main">
               <a:ext uri="{FF2B5EF4-FFF2-40B4-BE49-F238E27FC236}">
-                <a16:creationId xmlns:a16="http://schemas.microsoft.com/office/drawing/2014/main" id="{FFC948D2-42FB-43C7-865A-53634A2B8030}"/>
+                <a16:creationId xmlns:a16="http://schemas.microsoft.com/office/drawing/2014/main" id="{7DF92C03-EA37-4CF0-9DCB-B9906791CAB0}"/>
               </a:ext>
             </a:extLst>
           </p:cNvPr>
@@ -13678,7 +13735,7 @@
           <p:cNvPr id="26" name="">
             <a:extLst xmlns:a="http://schemas.openxmlformats.org/drawingml/2006/main">
               <a:ext uri="{FF2B5EF4-FFF2-40B4-BE49-F238E27FC236}">
-                <a16:creationId xmlns:a16="http://schemas.microsoft.com/office/drawing/2014/main" id="{1CA5E4FD-124F-4856-BA97-76FF602E87E2}"/>
+                <a16:creationId xmlns:a16="http://schemas.microsoft.com/office/drawing/2014/main" id="{32F73360-BBD5-4366-B14E-5195B01EAC13}"/>
               </a:ext>
             </a:extLst>
           </p:cNvPr>
@@ -13730,7 +13787,7 @@
           <p:cNvPr id="27" name="">
             <a:extLst xmlns:a="http://schemas.openxmlformats.org/drawingml/2006/main">
               <a:ext uri="{FF2B5EF4-FFF2-40B4-BE49-F238E27FC236}">
-                <a16:creationId xmlns:a16="http://schemas.microsoft.com/office/drawing/2014/main" id="{04847A34-FAEC-47DE-B0D9-9D53BF9E7B8A}"/>
+                <a16:creationId xmlns:a16="http://schemas.microsoft.com/office/drawing/2014/main" id="{4CFE5809-52DE-4972-9C14-6EF57D478CB1}"/>
               </a:ext>
             </a:extLst>
           </p:cNvPr>
@@ -13802,7 +13859,7 @@
     </p:spTree>
     <p:extLst>
       <p:ext uri="{BB962C8B-B14F-4D97-AF65-F5344CB8AC3E}">
-        <p14:creationId xmlns:p14="http://schemas.microsoft.com/office/powerpoint/2010/main" val="1730949125"/>
+        <p14:creationId xmlns:p14="http://schemas.microsoft.com/office/powerpoint/2010/main" val="418351213"/>
       </p:ext>
     </p:extLst>
   </p:cSld>
@@ -13826,7 +13883,7 @@
           <p:cNvPr id="65" name="">
             <a:extLst xmlns:a="http://schemas.openxmlformats.org/drawingml/2006/main">
               <a:ext uri="{FF2B5EF4-FFF2-40B4-BE49-F238E27FC236}">
-                <a16:creationId xmlns:a16="http://schemas.microsoft.com/office/drawing/2014/main" id="{F78786CB-4409-4573-9291-3386E2406CF7}"/>
+                <a16:creationId xmlns:a16="http://schemas.microsoft.com/office/drawing/2014/main" id="{ECF743F3-488F-4511-8FF1-3BD228ECB73A}"/>
               </a:ext>
             </a:extLst>
           </p:cNvPr>
@@ -13878,7 +13935,7 @@
           <p:cNvPr id="2" name="">
             <a:extLst xmlns:a="http://schemas.openxmlformats.org/drawingml/2006/main">
               <a:ext uri="{FF2B5EF4-FFF2-40B4-BE49-F238E27FC236}">
-                <a16:creationId xmlns:a16="http://schemas.microsoft.com/office/drawing/2014/main" id="{DE3EA018-A418-40D9-AC10-CDEB76D4EE91}"/>
+                <a16:creationId xmlns:a16="http://schemas.microsoft.com/office/drawing/2014/main" id="{1EE0A6A4-7C43-42DD-9A84-FAA80531752F}"/>
               </a:ext>
             </a:extLst>
           </p:cNvPr>
@@ -13952,7 +14009,7 @@
           <p:cNvPr id="4" name="">
             <a:extLst xmlns:a="http://schemas.openxmlformats.org/drawingml/2006/main">
               <a:ext uri="{FF2B5EF4-FFF2-40B4-BE49-F238E27FC236}">
-                <a16:creationId xmlns:a16="http://schemas.microsoft.com/office/drawing/2014/main" id="{CFB99EFF-1C7D-423D-B423-21B660A69628}"/>
+                <a16:creationId xmlns:a16="http://schemas.microsoft.com/office/drawing/2014/main" id="{09824D4D-CFC4-4E28-AA01-BBC6E498602B}"/>
               </a:ext>
             </a:extLst>
           </p:cNvPr>
@@ -14004,7 +14061,7 @@
           <p:cNvPr id="5" name="">
             <a:extLst xmlns:a="http://schemas.openxmlformats.org/drawingml/2006/main">
               <a:ext uri="{FF2B5EF4-FFF2-40B4-BE49-F238E27FC236}">
-                <a16:creationId xmlns:a16="http://schemas.microsoft.com/office/drawing/2014/main" id="{95047806-650D-4A14-9BF5-4BB9C54580B7}"/>
+                <a16:creationId xmlns:a16="http://schemas.microsoft.com/office/drawing/2014/main" id="{143DF5EF-A9BB-40B3-BB1B-CD3A33A4F39B}"/>
               </a:ext>
             </a:extLst>
           </p:cNvPr>
@@ -14056,7 +14113,7 @@
           <p:cNvPr id="6" name="">
             <a:extLst xmlns:a="http://schemas.openxmlformats.org/drawingml/2006/main">
               <a:ext uri="{FF2B5EF4-FFF2-40B4-BE49-F238E27FC236}">
-                <a16:creationId xmlns:a16="http://schemas.microsoft.com/office/drawing/2014/main" id="{BAF3FA0E-8EEC-40DD-B033-1096E72767B5}"/>
+                <a16:creationId xmlns:a16="http://schemas.microsoft.com/office/drawing/2014/main" id="{A654D56F-43CC-4E13-A8BB-429A70AB331D}"/>
               </a:ext>
             </a:extLst>
           </p:cNvPr>
@@ -14108,7 +14165,7 @@
           <p:cNvPr id="7" name="">
             <a:extLst xmlns:a="http://schemas.openxmlformats.org/drawingml/2006/main">
               <a:ext uri="{FF2B5EF4-FFF2-40B4-BE49-F238E27FC236}">
-                <a16:creationId xmlns:a16="http://schemas.microsoft.com/office/drawing/2014/main" id="{CC7CDDE5-8480-4873-A98B-F1ABC6DB78B6}"/>
+                <a16:creationId xmlns:a16="http://schemas.microsoft.com/office/drawing/2014/main" id="{402BB39B-CE60-49B4-A04E-09E1A47A665C}"/>
               </a:ext>
             </a:extLst>
           </p:cNvPr>
@@ -14160,7 +14217,7 @@
           <p:cNvPr id="8" name="">
             <a:extLst xmlns:a="http://schemas.openxmlformats.org/drawingml/2006/main">
               <a:ext uri="{FF2B5EF4-FFF2-40B4-BE49-F238E27FC236}">
-                <a16:creationId xmlns:a16="http://schemas.microsoft.com/office/drawing/2014/main" id="{D34C12EC-BCE7-40F4-B2E9-A2DD5913A834}"/>
+                <a16:creationId xmlns:a16="http://schemas.microsoft.com/office/drawing/2014/main" id="{0DE48405-E263-410C-8831-DEB656587B3E}"/>
               </a:ext>
             </a:extLst>
           </p:cNvPr>
@@ -14212,7 +14269,7 @@
           <p:cNvPr id="9" name="">
             <a:extLst xmlns:a="http://schemas.openxmlformats.org/drawingml/2006/main">
               <a:ext uri="{FF2B5EF4-FFF2-40B4-BE49-F238E27FC236}">
-                <a16:creationId xmlns:a16="http://schemas.microsoft.com/office/drawing/2014/main" id="{CD87BDCB-D691-46A4-9914-F2A9CFFAAC61}"/>
+                <a16:creationId xmlns:a16="http://schemas.microsoft.com/office/drawing/2014/main" id="{0D3B6CF4-C327-4ADE-8BC8-FCE3530C3FEC}"/>
               </a:ext>
             </a:extLst>
           </p:cNvPr>
@@ -14264,7 +14321,7 @@
           <p:cNvPr id="10" name="">
             <a:extLst xmlns:a="http://schemas.openxmlformats.org/drawingml/2006/main">
               <a:ext uri="{FF2B5EF4-FFF2-40B4-BE49-F238E27FC236}">
-                <a16:creationId xmlns:a16="http://schemas.microsoft.com/office/drawing/2014/main" id="{6CE84BA3-51BA-4A95-A166-DAA395904C07}"/>
+                <a16:creationId xmlns:a16="http://schemas.microsoft.com/office/drawing/2014/main" id="{0E76D326-EF05-4E03-BBFB-49E45E87A53B}"/>
               </a:ext>
             </a:extLst>
           </p:cNvPr>
@@ -14297,7 +14354,7 @@
           <p:cNvPr id="11" name="">
             <a:extLst xmlns:a="http://schemas.openxmlformats.org/drawingml/2006/main">
               <a:ext uri="{FF2B5EF4-FFF2-40B4-BE49-F238E27FC236}">
-                <a16:creationId xmlns:a16="http://schemas.microsoft.com/office/drawing/2014/main" id="{F26E3858-36CB-46EA-B39A-80F6225433F1}"/>
+                <a16:creationId xmlns:a16="http://schemas.microsoft.com/office/drawing/2014/main" id="{74B728CA-EB82-421B-A588-8FF5B980FBEB}"/>
               </a:ext>
             </a:extLst>
           </p:cNvPr>
@@ -14349,7 +14406,7 @@
           <p:cNvPr id="12" name="">
             <a:extLst xmlns:a="http://schemas.openxmlformats.org/drawingml/2006/main">
               <a:ext uri="{FF2B5EF4-FFF2-40B4-BE49-F238E27FC236}">
-                <a16:creationId xmlns:a16="http://schemas.microsoft.com/office/drawing/2014/main" id="{B141382E-4E6D-43DE-B0AA-1EAD579AD70A}"/>
+                <a16:creationId xmlns:a16="http://schemas.microsoft.com/office/drawing/2014/main" id="{B3881F1A-A86A-4041-8553-C3625FB0C50D}"/>
               </a:ext>
             </a:extLst>
           </p:cNvPr>
@@ -14401,7 +14458,7 @@
           <p:cNvPr id="13" name="">
             <a:extLst xmlns:a="http://schemas.openxmlformats.org/drawingml/2006/main">
               <a:ext uri="{FF2B5EF4-FFF2-40B4-BE49-F238E27FC236}">
-                <a16:creationId xmlns:a16="http://schemas.microsoft.com/office/drawing/2014/main" id="{379B4EC2-2CBB-480B-8619-9D4CF3CFF0BE}"/>
+                <a16:creationId xmlns:a16="http://schemas.microsoft.com/office/drawing/2014/main" id="{E3DFC223-08A1-429D-B889-F29A6A8F3F12}"/>
               </a:ext>
             </a:extLst>
           </p:cNvPr>
@@ -14453,7 +14510,7 @@
           <p:cNvPr id="14" name="">
             <a:extLst xmlns:a="http://schemas.openxmlformats.org/drawingml/2006/main">
               <a:ext uri="{FF2B5EF4-FFF2-40B4-BE49-F238E27FC236}">
-                <a16:creationId xmlns:a16="http://schemas.microsoft.com/office/drawing/2014/main" id="{D3929028-4766-43CC-9989-1C5ECE9601F7}"/>
+                <a16:creationId xmlns:a16="http://schemas.microsoft.com/office/drawing/2014/main" id="{635D148C-8297-4414-BBED-BAE2D3BF17E6}"/>
               </a:ext>
             </a:extLst>
           </p:cNvPr>
@@ -14505,7 +14562,7 @@
           <p:cNvPr id="15" name="">
             <a:extLst xmlns:a="http://schemas.openxmlformats.org/drawingml/2006/main">
               <a:ext uri="{FF2B5EF4-FFF2-40B4-BE49-F238E27FC236}">
-                <a16:creationId xmlns:a16="http://schemas.microsoft.com/office/drawing/2014/main" id="{88FCBED1-21EC-4BFE-A353-07D67262F6EF}"/>
+                <a16:creationId xmlns:a16="http://schemas.microsoft.com/office/drawing/2014/main" id="{B4FA97FD-6148-4781-97FC-4A603B3B0FD4}"/>
               </a:ext>
             </a:extLst>
           </p:cNvPr>
@@ -14557,7 +14614,7 @@
           <p:cNvPr id="16" name="">
             <a:extLst xmlns:a="http://schemas.openxmlformats.org/drawingml/2006/main">
               <a:ext uri="{FF2B5EF4-FFF2-40B4-BE49-F238E27FC236}">
-                <a16:creationId xmlns:a16="http://schemas.microsoft.com/office/drawing/2014/main" id="{F6CE1281-1630-4B70-AA4D-D5781DD6E9A2}"/>
+                <a16:creationId xmlns:a16="http://schemas.microsoft.com/office/drawing/2014/main" id="{CA01BD52-8FB3-46B8-BA57-181BFC9F04CA}"/>
               </a:ext>
             </a:extLst>
           </p:cNvPr>
@@ -14590,7 +14647,7 @@
           <p:cNvPr id="17" name="">
             <a:extLst xmlns:a="http://schemas.openxmlformats.org/drawingml/2006/main">
               <a:ext uri="{FF2B5EF4-FFF2-40B4-BE49-F238E27FC236}">
-                <a16:creationId xmlns:a16="http://schemas.microsoft.com/office/drawing/2014/main" id="{B65C0F2F-6972-4DDC-8A55-D0FAA59D0749}"/>
+                <a16:creationId xmlns:a16="http://schemas.microsoft.com/office/drawing/2014/main" id="{9A48C2C1-51BB-438B-9C07-FC24F650CC10}"/>
               </a:ext>
             </a:extLst>
           </p:cNvPr>
@@ -14642,7 +14699,7 @@
           <p:cNvPr id="18" name="">
             <a:extLst xmlns:a="http://schemas.openxmlformats.org/drawingml/2006/main">
               <a:ext uri="{FF2B5EF4-FFF2-40B4-BE49-F238E27FC236}">
-                <a16:creationId xmlns:a16="http://schemas.microsoft.com/office/drawing/2014/main" id="{78DBFB7E-D98C-48A2-A91D-2F1E29F5DC7A}"/>
+                <a16:creationId xmlns:a16="http://schemas.microsoft.com/office/drawing/2014/main" id="{8AC47A3B-9EC2-4A8F-A8F5-D8A5A9243C48}"/>
               </a:ext>
             </a:extLst>
           </p:cNvPr>
@@ -14694,7 +14751,7 @@
           <p:cNvPr id="19" name="">
             <a:extLst xmlns:a="http://schemas.openxmlformats.org/drawingml/2006/main">
               <a:ext uri="{FF2B5EF4-FFF2-40B4-BE49-F238E27FC236}">
-                <a16:creationId xmlns:a16="http://schemas.microsoft.com/office/drawing/2014/main" id="{F2DD9A7A-A025-46D1-A604-F63FA1CBC3C0}"/>
+                <a16:creationId xmlns:a16="http://schemas.microsoft.com/office/drawing/2014/main" id="{50530052-51BA-45E4-8DD6-CAE1956CA253}"/>
               </a:ext>
             </a:extLst>
           </p:cNvPr>
@@ -14746,7 +14803,7 @@
           <p:cNvPr id="20" name="">
             <a:extLst xmlns:a="http://schemas.openxmlformats.org/drawingml/2006/main">
               <a:ext uri="{FF2B5EF4-FFF2-40B4-BE49-F238E27FC236}">
-                <a16:creationId xmlns:a16="http://schemas.microsoft.com/office/drawing/2014/main" id="{7445B762-3FE8-4F66-888E-81A3CCD1E468}"/>
+                <a16:creationId xmlns:a16="http://schemas.microsoft.com/office/drawing/2014/main" id="{10FF0169-182D-4873-85D4-020209396B4D}"/>
               </a:ext>
             </a:extLst>
           </p:cNvPr>
@@ -14798,7 +14855,7 @@
           <p:cNvPr id="21" name="">
             <a:extLst xmlns:a="http://schemas.openxmlformats.org/drawingml/2006/main">
               <a:ext uri="{FF2B5EF4-FFF2-40B4-BE49-F238E27FC236}">
-                <a16:creationId xmlns:a16="http://schemas.microsoft.com/office/drawing/2014/main" id="{180C1763-CF0B-4B93-A246-D18E3BCF3B80}"/>
+                <a16:creationId xmlns:a16="http://schemas.microsoft.com/office/drawing/2014/main" id="{43783A02-5299-4F24-BBBD-787995565917}"/>
               </a:ext>
             </a:extLst>
           </p:cNvPr>
@@ -14850,7 +14907,7 @@
           <p:cNvPr id="22" name="">
             <a:extLst xmlns:a="http://schemas.openxmlformats.org/drawingml/2006/main">
               <a:ext uri="{FF2B5EF4-FFF2-40B4-BE49-F238E27FC236}">
-                <a16:creationId xmlns:a16="http://schemas.microsoft.com/office/drawing/2014/main" id="{58DE006A-18A7-499B-855E-37AA38EBF46A}"/>
+                <a16:creationId xmlns:a16="http://schemas.microsoft.com/office/drawing/2014/main" id="{04CD9699-8F9A-4581-87FC-D5159A884B3F}"/>
               </a:ext>
             </a:extLst>
           </p:cNvPr>
@@ -14883,7 +14940,7 @@
           <p:cNvPr id="23" name="">
             <a:extLst xmlns:a="http://schemas.openxmlformats.org/drawingml/2006/main">
               <a:ext uri="{FF2B5EF4-FFF2-40B4-BE49-F238E27FC236}">
-                <a16:creationId xmlns:a16="http://schemas.microsoft.com/office/drawing/2014/main" id="{13DABF17-3B79-452E-B351-3658C022E8D0}"/>
+                <a16:creationId xmlns:a16="http://schemas.microsoft.com/office/drawing/2014/main" id="{30A56F18-DC5D-444D-8E39-E8D15DD5D205}"/>
               </a:ext>
             </a:extLst>
           </p:cNvPr>
@@ -14935,7 +14992,7 @@
           <p:cNvPr id="24" name="">
             <a:extLst xmlns:a="http://schemas.openxmlformats.org/drawingml/2006/main">
               <a:ext uri="{FF2B5EF4-FFF2-40B4-BE49-F238E27FC236}">
-                <a16:creationId xmlns:a16="http://schemas.microsoft.com/office/drawing/2014/main" id="{A8D46B88-D954-4497-B263-76DE2B6D6C63}"/>
+                <a16:creationId xmlns:a16="http://schemas.microsoft.com/office/drawing/2014/main" id="{39B7EDFF-3052-4D4F-9FFF-FFA36D683044}"/>
               </a:ext>
             </a:extLst>
           </p:cNvPr>
@@ -14987,7 +15044,7 @@
           <p:cNvPr id="25" name="">
             <a:extLst xmlns:a="http://schemas.openxmlformats.org/drawingml/2006/main">
               <a:ext uri="{FF2B5EF4-FFF2-40B4-BE49-F238E27FC236}">
-                <a16:creationId xmlns:a16="http://schemas.microsoft.com/office/drawing/2014/main" id="{51387D44-04D3-4606-B239-00438899C83C}"/>
+                <a16:creationId xmlns:a16="http://schemas.microsoft.com/office/drawing/2014/main" id="{B13C7C0A-7B8D-42BA-ABB1-D099FCBCDBFF}"/>
               </a:ext>
             </a:extLst>
           </p:cNvPr>
@@ -15039,7 +15096,7 @@
           <p:cNvPr id="26" name="">
             <a:extLst xmlns:a="http://schemas.openxmlformats.org/drawingml/2006/main">
               <a:ext uri="{FF2B5EF4-FFF2-40B4-BE49-F238E27FC236}">
-                <a16:creationId xmlns:a16="http://schemas.microsoft.com/office/drawing/2014/main" id="{241746DB-7250-44C2-8468-28D88987F231}"/>
+                <a16:creationId xmlns:a16="http://schemas.microsoft.com/office/drawing/2014/main" id="{C8F39B0E-6E69-48B9-903D-BD1F3744A6C5}"/>
               </a:ext>
             </a:extLst>
           </p:cNvPr>
@@ -15091,7 +15148,7 @@
           <p:cNvPr id="27" name="">
             <a:extLst xmlns:a="http://schemas.openxmlformats.org/drawingml/2006/main">
               <a:ext uri="{FF2B5EF4-FFF2-40B4-BE49-F238E27FC236}">
-                <a16:creationId xmlns:a16="http://schemas.microsoft.com/office/drawing/2014/main" id="{83577B68-AB2F-475D-B692-C17B493787BB}"/>
+                <a16:creationId xmlns:a16="http://schemas.microsoft.com/office/drawing/2014/main" id="{676C1771-5F83-4896-97D5-A7C345BD334F}"/>
               </a:ext>
             </a:extLst>
           </p:cNvPr>
@@ -15143,7 +15200,7 @@
           <p:cNvPr id="28" name="">
             <a:extLst xmlns:a="http://schemas.openxmlformats.org/drawingml/2006/main">
               <a:ext uri="{FF2B5EF4-FFF2-40B4-BE49-F238E27FC236}">
-                <a16:creationId xmlns:a16="http://schemas.microsoft.com/office/drawing/2014/main" id="{8C8E3D28-4ED6-4E45-A29E-ACFA1D251492}"/>
+                <a16:creationId xmlns:a16="http://schemas.microsoft.com/office/drawing/2014/main" id="{E9760B06-A7F0-455A-AB79-1445A8AF31DE}"/>
               </a:ext>
             </a:extLst>
           </p:cNvPr>
@@ -15176,7 +15233,7 @@
           <p:cNvPr id="29" name="">
             <a:extLst xmlns:a="http://schemas.openxmlformats.org/drawingml/2006/main">
               <a:ext uri="{FF2B5EF4-FFF2-40B4-BE49-F238E27FC236}">
-                <a16:creationId xmlns:a16="http://schemas.microsoft.com/office/drawing/2014/main" id="{199CFFD3-9BB1-4FF5-93C9-832BC8FF318A}"/>
+                <a16:creationId xmlns:a16="http://schemas.microsoft.com/office/drawing/2014/main" id="{417BDF5F-5A67-49B9-B356-7BF563A1461A}"/>
               </a:ext>
             </a:extLst>
           </p:cNvPr>
@@ -15228,7 +15285,7 @@
           <p:cNvPr id="30" name="">
             <a:extLst xmlns:a="http://schemas.openxmlformats.org/drawingml/2006/main">
               <a:ext uri="{FF2B5EF4-FFF2-40B4-BE49-F238E27FC236}">
-                <a16:creationId xmlns:a16="http://schemas.microsoft.com/office/drawing/2014/main" id="{CCD54316-9197-4AFF-85E8-1C3713B19D51}"/>
+                <a16:creationId xmlns:a16="http://schemas.microsoft.com/office/drawing/2014/main" id="{512C13DB-D58C-45C3-9DFD-84BC21E1FCF7}"/>
               </a:ext>
             </a:extLst>
           </p:cNvPr>
@@ -15280,7 +15337,7 @@
           <p:cNvPr id="31" name="">
             <a:extLst xmlns:a="http://schemas.openxmlformats.org/drawingml/2006/main">
               <a:ext uri="{FF2B5EF4-FFF2-40B4-BE49-F238E27FC236}">
-                <a16:creationId xmlns:a16="http://schemas.microsoft.com/office/drawing/2014/main" id="{8004EEE7-C982-4F45-9656-AA723476D403}"/>
+                <a16:creationId xmlns:a16="http://schemas.microsoft.com/office/drawing/2014/main" id="{6F6DF581-29AF-4CFA-BD85-BD122D42F5EF}"/>
               </a:ext>
             </a:extLst>
           </p:cNvPr>
@@ -15332,7 +15389,7 @@
           <p:cNvPr id="32" name="">
             <a:extLst xmlns:a="http://schemas.openxmlformats.org/drawingml/2006/main">
               <a:ext uri="{FF2B5EF4-FFF2-40B4-BE49-F238E27FC236}">
-                <a16:creationId xmlns:a16="http://schemas.microsoft.com/office/drawing/2014/main" id="{62922F59-3FBA-4A10-9BF8-9862085DC62A}"/>
+                <a16:creationId xmlns:a16="http://schemas.microsoft.com/office/drawing/2014/main" id="{F27B7FB1-C9D6-4422-9F1F-3B05C69031EB}"/>
               </a:ext>
             </a:extLst>
           </p:cNvPr>
@@ -15384,7 +15441,7 @@
           <p:cNvPr id="33" name="">
             <a:extLst xmlns:a="http://schemas.openxmlformats.org/drawingml/2006/main">
               <a:ext uri="{FF2B5EF4-FFF2-40B4-BE49-F238E27FC236}">
-                <a16:creationId xmlns:a16="http://schemas.microsoft.com/office/drawing/2014/main" id="{B7432CB4-7811-4B04-80A4-B9899936B5A9}"/>
+                <a16:creationId xmlns:a16="http://schemas.microsoft.com/office/drawing/2014/main" id="{31CDDB9F-AE6B-467E-A24A-7A9EFEB19331}"/>
               </a:ext>
             </a:extLst>
           </p:cNvPr>
@@ -15436,7 +15493,7 @@
           <p:cNvPr id="34" name="">
             <a:extLst xmlns:a="http://schemas.openxmlformats.org/drawingml/2006/main">
               <a:ext uri="{FF2B5EF4-FFF2-40B4-BE49-F238E27FC236}">
-                <a16:creationId xmlns:a16="http://schemas.microsoft.com/office/drawing/2014/main" id="{1FA87D00-B2C1-4074-B590-FE0DE8BB9E38}"/>
+                <a16:creationId xmlns:a16="http://schemas.microsoft.com/office/drawing/2014/main" id="{82B210D5-E35E-4D89-8735-165FBCAFF0D9}"/>
               </a:ext>
             </a:extLst>
           </p:cNvPr>
@@ -15469,7 +15526,7 @@
           <p:cNvPr id="35" name="">
             <a:extLst xmlns:a="http://schemas.openxmlformats.org/drawingml/2006/main">
               <a:ext uri="{FF2B5EF4-FFF2-40B4-BE49-F238E27FC236}">
-                <a16:creationId xmlns:a16="http://schemas.microsoft.com/office/drawing/2014/main" id="{FB8F1700-F6E8-4F4E-BDF0-1A5B4B5B6322}"/>
+                <a16:creationId xmlns:a16="http://schemas.microsoft.com/office/drawing/2014/main" id="{F646ED5F-B512-4AA3-BFFC-D32782109A0A}"/>
               </a:ext>
             </a:extLst>
           </p:cNvPr>
@@ -15521,7 +15578,7 @@
           <p:cNvPr id="36" name="">
             <a:extLst xmlns:a="http://schemas.openxmlformats.org/drawingml/2006/main">
               <a:ext uri="{FF2B5EF4-FFF2-40B4-BE49-F238E27FC236}">
-                <a16:creationId xmlns:a16="http://schemas.microsoft.com/office/drawing/2014/main" id="{3D77449B-B858-4A88-A53F-ECF98EFDCB42}"/>
+                <a16:creationId xmlns:a16="http://schemas.microsoft.com/office/drawing/2014/main" id="{7587C635-D8AD-4F65-BFD5-4271ADE6AF04}"/>
               </a:ext>
             </a:extLst>
           </p:cNvPr>
@@ -15573,7 +15630,7 @@
           <p:cNvPr id="37" name="">
             <a:extLst xmlns:a="http://schemas.openxmlformats.org/drawingml/2006/main">
               <a:ext uri="{FF2B5EF4-FFF2-40B4-BE49-F238E27FC236}">
-                <a16:creationId xmlns:a16="http://schemas.microsoft.com/office/drawing/2014/main" id="{306D95F1-CF4C-47A4-B1AF-378C00F84ADB}"/>
+                <a16:creationId xmlns:a16="http://schemas.microsoft.com/office/drawing/2014/main" id="{25475E18-6A0D-46EB-B618-B02F869E9AE4}"/>
               </a:ext>
             </a:extLst>
           </p:cNvPr>
@@ -15625,7 +15682,7 @@
           <p:cNvPr id="38" name="">
             <a:extLst xmlns:a="http://schemas.openxmlformats.org/drawingml/2006/main">
               <a:ext uri="{FF2B5EF4-FFF2-40B4-BE49-F238E27FC236}">
-                <a16:creationId xmlns:a16="http://schemas.microsoft.com/office/drawing/2014/main" id="{84F029D7-B1CF-4E24-885F-BCC968CD9540}"/>
+                <a16:creationId xmlns:a16="http://schemas.microsoft.com/office/drawing/2014/main" id="{41EE7665-F878-480C-BCD3-709D12DF7C3E}"/>
               </a:ext>
             </a:extLst>
           </p:cNvPr>
@@ -15677,7 +15734,7 @@
           <p:cNvPr id="39" name="">
             <a:extLst xmlns:a="http://schemas.openxmlformats.org/drawingml/2006/main">
               <a:ext uri="{FF2B5EF4-FFF2-40B4-BE49-F238E27FC236}">
-                <a16:creationId xmlns:a16="http://schemas.microsoft.com/office/drawing/2014/main" id="{1898CF4C-5569-467D-BE95-694BA87E19EF}"/>
+                <a16:creationId xmlns:a16="http://schemas.microsoft.com/office/drawing/2014/main" id="{0092A4E7-D9A4-4FEE-861D-DD14CEBD6883}"/>
               </a:ext>
             </a:extLst>
           </p:cNvPr>
@@ -15729,7 +15786,7 @@
           <p:cNvPr id="40" name="">
             <a:extLst xmlns:a="http://schemas.openxmlformats.org/drawingml/2006/main">
               <a:ext uri="{FF2B5EF4-FFF2-40B4-BE49-F238E27FC236}">
-                <a16:creationId xmlns:a16="http://schemas.microsoft.com/office/drawing/2014/main" id="{BE4102E1-BD7C-4DF6-84A5-FC49CF625145}"/>
+                <a16:creationId xmlns:a16="http://schemas.microsoft.com/office/drawing/2014/main" id="{4357B1F7-F16C-4999-BE8B-F4A64326B216}"/>
               </a:ext>
             </a:extLst>
           </p:cNvPr>
@@ -15762,7 +15819,7 @@
           <p:cNvPr id="41" name="">
             <a:extLst xmlns:a="http://schemas.openxmlformats.org/drawingml/2006/main">
               <a:ext uri="{FF2B5EF4-FFF2-40B4-BE49-F238E27FC236}">
-                <a16:creationId xmlns:a16="http://schemas.microsoft.com/office/drawing/2014/main" id="{BEFFEF99-1C2E-45F3-B3DA-5B598E09A066}"/>
+                <a16:creationId xmlns:a16="http://schemas.microsoft.com/office/drawing/2014/main" id="{83F3FE40-0CBF-4EBD-82BD-6A779F848F3A}"/>
               </a:ext>
             </a:extLst>
           </p:cNvPr>
@@ -15814,7 +15871,7 @@
           <p:cNvPr id="42" name="">
             <a:extLst xmlns:a="http://schemas.openxmlformats.org/drawingml/2006/main">
               <a:ext uri="{FF2B5EF4-FFF2-40B4-BE49-F238E27FC236}">
-                <a16:creationId xmlns:a16="http://schemas.microsoft.com/office/drawing/2014/main" id="{6E6B7E1A-1666-4033-B7D1-1DB36D98FFEB}"/>
+                <a16:creationId xmlns:a16="http://schemas.microsoft.com/office/drawing/2014/main" id="{50083FDE-6722-4E01-A180-B4C1C9B0E845}"/>
               </a:ext>
             </a:extLst>
           </p:cNvPr>
@@ -15866,7 +15923,7 @@
           <p:cNvPr id="43" name="">
             <a:extLst xmlns:a="http://schemas.openxmlformats.org/drawingml/2006/main">
               <a:ext uri="{FF2B5EF4-FFF2-40B4-BE49-F238E27FC236}">
-                <a16:creationId xmlns:a16="http://schemas.microsoft.com/office/drawing/2014/main" id="{77BE2D55-DF56-4D66-8B74-D8BFF1069F17}"/>
+                <a16:creationId xmlns:a16="http://schemas.microsoft.com/office/drawing/2014/main" id="{B2076255-4E41-48FC-BD46-90AF6DDB2E37}"/>
               </a:ext>
             </a:extLst>
           </p:cNvPr>
@@ -15918,7 +15975,7 @@
           <p:cNvPr id="44" name="">
             <a:extLst xmlns:a="http://schemas.openxmlformats.org/drawingml/2006/main">
               <a:ext uri="{FF2B5EF4-FFF2-40B4-BE49-F238E27FC236}">
-                <a16:creationId xmlns:a16="http://schemas.microsoft.com/office/drawing/2014/main" id="{605F6BD7-2270-4EA6-BEAF-C0F1554E027A}"/>
+                <a16:creationId xmlns:a16="http://schemas.microsoft.com/office/drawing/2014/main" id="{E907DAA0-1865-43D4-AB9A-013C2CC64D1E}"/>
               </a:ext>
             </a:extLst>
           </p:cNvPr>
@@ -15970,7 +16027,7 @@
           <p:cNvPr id="45" name="">
             <a:extLst xmlns:a="http://schemas.openxmlformats.org/drawingml/2006/main">
               <a:ext uri="{FF2B5EF4-FFF2-40B4-BE49-F238E27FC236}">
-                <a16:creationId xmlns:a16="http://schemas.microsoft.com/office/drawing/2014/main" id="{C551B37F-BFDB-48BE-8E5C-9DC34A86345F}"/>
+                <a16:creationId xmlns:a16="http://schemas.microsoft.com/office/drawing/2014/main" id="{42ED271E-2E44-4A6F-9340-A64307659D05}"/>
               </a:ext>
             </a:extLst>
           </p:cNvPr>
@@ -16022,7 +16079,7 @@
           <p:cNvPr id="46" name="">
             <a:extLst xmlns:a="http://schemas.openxmlformats.org/drawingml/2006/main">
               <a:ext uri="{FF2B5EF4-FFF2-40B4-BE49-F238E27FC236}">
-                <a16:creationId xmlns:a16="http://schemas.microsoft.com/office/drawing/2014/main" id="{A282AED1-2122-4A8D-9083-2A1795018000}"/>
+                <a16:creationId xmlns:a16="http://schemas.microsoft.com/office/drawing/2014/main" id="{73FECA29-617C-4166-BA8C-FA9BED6271B6}"/>
               </a:ext>
             </a:extLst>
           </p:cNvPr>
@@ -16055,7 +16112,7 @@
           <p:cNvPr id="47" name="">
             <a:extLst xmlns:a="http://schemas.openxmlformats.org/drawingml/2006/main">
               <a:ext uri="{FF2B5EF4-FFF2-40B4-BE49-F238E27FC236}">
-                <a16:creationId xmlns:a16="http://schemas.microsoft.com/office/drawing/2014/main" id="{C6E3A26B-7E57-464A-86FD-CECDCBBD97DB}"/>
+                <a16:creationId xmlns:a16="http://schemas.microsoft.com/office/drawing/2014/main" id="{5514FC61-7CCE-44F5-8483-DFEF0E70C220}"/>
               </a:ext>
             </a:extLst>
           </p:cNvPr>
@@ -16107,7 +16164,7 @@
           <p:cNvPr id="48" name="">
             <a:extLst xmlns:a="http://schemas.openxmlformats.org/drawingml/2006/main">
               <a:ext uri="{FF2B5EF4-FFF2-40B4-BE49-F238E27FC236}">
-                <a16:creationId xmlns:a16="http://schemas.microsoft.com/office/drawing/2014/main" id="{2F140381-2B56-4105-B060-1A56D40A4122}"/>
+                <a16:creationId xmlns:a16="http://schemas.microsoft.com/office/drawing/2014/main" id="{591FDA56-7794-4697-92D2-BAF76E80229F}"/>
               </a:ext>
             </a:extLst>
           </p:cNvPr>
@@ -16159,7 +16216,7 @@
           <p:cNvPr id="49" name="">
             <a:extLst xmlns:a="http://schemas.openxmlformats.org/drawingml/2006/main">
               <a:ext uri="{FF2B5EF4-FFF2-40B4-BE49-F238E27FC236}">
-                <a16:creationId xmlns:a16="http://schemas.microsoft.com/office/drawing/2014/main" id="{8F624180-3160-47A8-A85C-C88325CC0AD9}"/>
+                <a16:creationId xmlns:a16="http://schemas.microsoft.com/office/drawing/2014/main" id="{0E3DD26A-DB4A-45F1-AE9F-2084DAEEF359}"/>
               </a:ext>
             </a:extLst>
           </p:cNvPr>
@@ -16211,7 +16268,7 @@
           <p:cNvPr id="50" name="">
             <a:extLst xmlns:a="http://schemas.openxmlformats.org/drawingml/2006/main">
               <a:ext uri="{FF2B5EF4-FFF2-40B4-BE49-F238E27FC236}">
-                <a16:creationId xmlns:a16="http://schemas.microsoft.com/office/drawing/2014/main" id="{DEEE54D4-FE90-491F-9107-2B1E89DC17F5}"/>
+                <a16:creationId xmlns:a16="http://schemas.microsoft.com/office/drawing/2014/main" id="{0247D2EC-E5DE-4CDC-84E2-47555CBA5878}"/>
               </a:ext>
             </a:extLst>
           </p:cNvPr>
@@ -16263,7 +16320,7 @@
           <p:cNvPr id="51" name="">
             <a:extLst xmlns:a="http://schemas.openxmlformats.org/drawingml/2006/main">
               <a:ext uri="{FF2B5EF4-FFF2-40B4-BE49-F238E27FC236}">
-                <a16:creationId xmlns:a16="http://schemas.microsoft.com/office/drawing/2014/main" id="{76ABBF67-6363-4DF6-9B22-E1AD34130128}"/>
+                <a16:creationId xmlns:a16="http://schemas.microsoft.com/office/drawing/2014/main" id="{27948E25-4702-420F-BDE2-A08188FB4C2A}"/>
               </a:ext>
             </a:extLst>
           </p:cNvPr>
@@ -16315,7 +16372,7 @@
           <p:cNvPr id="52" name="">
             <a:extLst xmlns:a="http://schemas.openxmlformats.org/drawingml/2006/main">
               <a:ext uri="{FF2B5EF4-FFF2-40B4-BE49-F238E27FC236}">
-                <a16:creationId xmlns:a16="http://schemas.microsoft.com/office/drawing/2014/main" id="{BF795828-B83D-4478-B801-EEF6431407F7}"/>
+                <a16:creationId xmlns:a16="http://schemas.microsoft.com/office/drawing/2014/main" id="{F57DDA4A-1B29-4D60-9D6A-6EB9DF154789}"/>
               </a:ext>
             </a:extLst>
           </p:cNvPr>
@@ -16348,7 +16405,7 @@
           <p:cNvPr id="53" name="">
             <a:extLst xmlns:a="http://schemas.openxmlformats.org/drawingml/2006/main">
               <a:ext uri="{FF2B5EF4-FFF2-40B4-BE49-F238E27FC236}">
-                <a16:creationId xmlns:a16="http://schemas.microsoft.com/office/drawing/2014/main" id="{28610D29-343C-44A5-AF3A-33C9FEA3BB4E}"/>
+                <a16:creationId xmlns:a16="http://schemas.microsoft.com/office/drawing/2014/main" id="{3D82D85F-8A23-4F69-9841-CC0CD08C2627}"/>
               </a:ext>
             </a:extLst>
           </p:cNvPr>
@@ -16400,7 +16457,7 @@
           <p:cNvPr id="54" name="">
             <a:extLst xmlns:a="http://schemas.openxmlformats.org/drawingml/2006/main">
               <a:ext uri="{FF2B5EF4-FFF2-40B4-BE49-F238E27FC236}">
-                <a16:creationId xmlns:a16="http://schemas.microsoft.com/office/drawing/2014/main" id="{42B330CF-BEB3-447A-9910-FB5902CEFA9B}"/>
+                <a16:creationId xmlns:a16="http://schemas.microsoft.com/office/drawing/2014/main" id="{9AD8ABE6-DCC1-4771-8252-F026BAE88898}"/>
               </a:ext>
             </a:extLst>
           </p:cNvPr>
@@ -16452,7 +16509,7 @@
           <p:cNvPr id="55" name="">
             <a:extLst xmlns:a="http://schemas.openxmlformats.org/drawingml/2006/main">
               <a:ext uri="{FF2B5EF4-FFF2-40B4-BE49-F238E27FC236}">
-                <a16:creationId xmlns:a16="http://schemas.microsoft.com/office/drawing/2014/main" id="{57038C65-B10A-4A41-9B5F-253B8B150AFD}"/>
+                <a16:creationId xmlns:a16="http://schemas.microsoft.com/office/drawing/2014/main" id="{97D2B6E7-230F-4209-B43E-445284A76DBB}"/>
               </a:ext>
             </a:extLst>
           </p:cNvPr>
@@ -16504,7 +16561,7 @@
           <p:cNvPr id="56" name="">
             <a:extLst xmlns:a="http://schemas.openxmlformats.org/drawingml/2006/main">
               <a:ext uri="{FF2B5EF4-FFF2-40B4-BE49-F238E27FC236}">
-                <a16:creationId xmlns:a16="http://schemas.microsoft.com/office/drawing/2014/main" id="{3518F701-B762-4080-A24D-646FA3110C87}"/>
+                <a16:creationId xmlns:a16="http://schemas.microsoft.com/office/drawing/2014/main" id="{90E8AB29-CD01-47EC-8320-A61C45FF2419}"/>
               </a:ext>
             </a:extLst>
           </p:cNvPr>
@@ -16556,7 +16613,7 @@
           <p:cNvPr id="57" name="">
             <a:extLst xmlns:a="http://schemas.openxmlformats.org/drawingml/2006/main">
               <a:ext uri="{FF2B5EF4-FFF2-40B4-BE49-F238E27FC236}">
-                <a16:creationId xmlns:a16="http://schemas.microsoft.com/office/drawing/2014/main" id="{5A543F59-B3CA-4220-A0FB-772567DC5BD6}"/>
+                <a16:creationId xmlns:a16="http://schemas.microsoft.com/office/drawing/2014/main" id="{EB956AFE-2ADF-47EB-9068-B7C7F308D727}"/>
               </a:ext>
             </a:extLst>
           </p:cNvPr>
@@ -16608,7 +16665,7 @@
           <p:cNvPr id="58" name="">
             <a:extLst xmlns:a="http://schemas.openxmlformats.org/drawingml/2006/main">
               <a:ext uri="{FF2B5EF4-FFF2-40B4-BE49-F238E27FC236}">
-                <a16:creationId xmlns:a16="http://schemas.microsoft.com/office/drawing/2014/main" id="{2BA0DDC3-7D38-417E-BA0E-7F64ED41DA6D}"/>
+                <a16:creationId xmlns:a16="http://schemas.microsoft.com/office/drawing/2014/main" id="{694C56F3-FD43-4093-8A69-A036384ED538}"/>
               </a:ext>
             </a:extLst>
           </p:cNvPr>
@@ -16641,7 +16698,7 @@
           <p:cNvPr id="59" name="">
             <a:extLst xmlns:a="http://schemas.openxmlformats.org/drawingml/2006/main">
               <a:ext uri="{FF2B5EF4-FFF2-40B4-BE49-F238E27FC236}">
-                <a16:creationId xmlns:a16="http://schemas.microsoft.com/office/drawing/2014/main" id="{6EDBECDB-CB28-4F4E-8711-FD510B7259E5}"/>
+                <a16:creationId xmlns:a16="http://schemas.microsoft.com/office/drawing/2014/main" id="{DA21B55B-1BDD-4B9A-80C7-6B6F99A993D6}"/>
               </a:ext>
             </a:extLst>
           </p:cNvPr>
@@ -16693,7 +16750,7 @@
           <p:cNvPr id="60" name="">
             <a:extLst xmlns:a="http://schemas.openxmlformats.org/drawingml/2006/main">
               <a:ext uri="{FF2B5EF4-FFF2-40B4-BE49-F238E27FC236}">
-                <a16:creationId xmlns:a16="http://schemas.microsoft.com/office/drawing/2014/main" id="{124DA68C-251E-48A5-AB12-F40127EAFA26}"/>
+                <a16:creationId xmlns:a16="http://schemas.microsoft.com/office/drawing/2014/main" id="{DC7B7E32-3A5C-4191-A1CE-6E64EAFB3EF8}"/>
               </a:ext>
             </a:extLst>
           </p:cNvPr>
@@ -16745,7 +16802,7 @@
           <p:cNvPr id="61" name="">
             <a:extLst xmlns:a="http://schemas.openxmlformats.org/drawingml/2006/main">
               <a:ext uri="{FF2B5EF4-FFF2-40B4-BE49-F238E27FC236}">
-                <a16:creationId xmlns:a16="http://schemas.microsoft.com/office/drawing/2014/main" id="{B01499F8-690F-4CBB-AC14-17B4510EFF1E}"/>
+                <a16:creationId xmlns:a16="http://schemas.microsoft.com/office/drawing/2014/main" id="{5BC6B950-7E59-4D38-B36E-481B75EF77EE}"/>
               </a:ext>
             </a:extLst>
           </p:cNvPr>
@@ -16797,7 +16854,7 @@
           <p:cNvPr id="62" name="">
             <a:extLst xmlns:a="http://schemas.openxmlformats.org/drawingml/2006/main">
               <a:ext uri="{FF2B5EF4-FFF2-40B4-BE49-F238E27FC236}">
-                <a16:creationId xmlns:a16="http://schemas.microsoft.com/office/drawing/2014/main" id="{8A841D70-A927-473C-8074-948476D3186C}"/>
+                <a16:creationId xmlns:a16="http://schemas.microsoft.com/office/drawing/2014/main" id="{F7A24A3D-5AA4-4344-81BB-C72D5DFD38B9}"/>
               </a:ext>
             </a:extLst>
           </p:cNvPr>
@@ -16849,7 +16906,7 @@
           <p:cNvPr id="63" name="">
             <a:extLst xmlns:a="http://schemas.openxmlformats.org/drawingml/2006/main">
               <a:ext uri="{FF2B5EF4-FFF2-40B4-BE49-F238E27FC236}">
-                <a16:creationId xmlns:a16="http://schemas.microsoft.com/office/drawing/2014/main" id="{0D57FA64-57BE-4DA7-9DAC-2EA6C26E1B2B}"/>
+                <a16:creationId xmlns:a16="http://schemas.microsoft.com/office/drawing/2014/main" id="{EA8DB198-CC45-40B8-A59A-7063698F02E7}"/>
               </a:ext>
             </a:extLst>
           </p:cNvPr>
@@ -16901,7 +16958,7 @@
           <p:cNvPr id="64" name="">
             <a:extLst xmlns:a="http://schemas.openxmlformats.org/drawingml/2006/main">
               <a:ext uri="{FF2B5EF4-FFF2-40B4-BE49-F238E27FC236}">
-                <a16:creationId xmlns:a16="http://schemas.microsoft.com/office/drawing/2014/main" id="{F3413BBF-20EE-4859-B655-4E34F75AF2DF}"/>
+                <a16:creationId xmlns:a16="http://schemas.microsoft.com/office/drawing/2014/main" id="{9E1E3C66-6031-416D-AC9C-5F6D285EC0B5}"/>
               </a:ext>
             </a:extLst>
           </p:cNvPr>
@@ -16951,7 +17008,7 @@
     </p:spTree>
     <p:extLst>
       <p:ext uri="{BB962C8B-B14F-4D97-AF65-F5344CB8AC3E}">
-        <p14:creationId xmlns:p14="http://schemas.microsoft.com/office/powerpoint/2010/main" val="1669266959"/>
+        <p14:creationId xmlns:p14="http://schemas.microsoft.com/office/powerpoint/2010/main" val="1883422993"/>
       </p:ext>
     </p:extLst>
   </p:cSld>
@@ -16975,7 +17032,7 @@
           <p:cNvPr id="23" name="">
             <a:extLst xmlns:a="http://schemas.openxmlformats.org/drawingml/2006/main">
               <a:ext uri="{FF2B5EF4-FFF2-40B4-BE49-F238E27FC236}">
-                <a16:creationId xmlns:a16="http://schemas.microsoft.com/office/drawing/2014/main" id="{D908CB0B-9A36-4DCB-BFA0-284DEA0B9B1F}"/>
+                <a16:creationId xmlns:a16="http://schemas.microsoft.com/office/drawing/2014/main" id="{4E38CD7A-A37A-43AF-B852-DE52ECD73CCE}"/>
               </a:ext>
             </a:extLst>
           </p:cNvPr>
@@ -17027,7 +17084,7 @@
           <p:cNvPr id="2" name="">
             <a:extLst xmlns:a="http://schemas.openxmlformats.org/drawingml/2006/main">
               <a:ext uri="{FF2B5EF4-FFF2-40B4-BE49-F238E27FC236}">
-                <a16:creationId xmlns:a16="http://schemas.microsoft.com/office/drawing/2014/main" id="{EA177037-B8B7-4D03-9B7E-4013683533F4}"/>
+                <a16:creationId xmlns:a16="http://schemas.microsoft.com/office/drawing/2014/main" id="{A0DF1FA8-2DFB-42E3-8192-180C6B110BEB}"/>
               </a:ext>
             </a:extLst>
           </p:cNvPr>
@@ -17101,7 +17158,7 @@
           <p:cNvPr id="4" name="">
             <a:extLst xmlns:a="http://schemas.openxmlformats.org/drawingml/2006/main">
               <a:ext uri="{FF2B5EF4-FFF2-40B4-BE49-F238E27FC236}">
-                <a16:creationId xmlns:a16="http://schemas.microsoft.com/office/drawing/2014/main" id="{DA1EBA14-EED4-4800-9713-3B7E57BBBCAC}"/>
+                <a16:creationId xmlns:a16="http://schemas.microsoft.com/office/drawing/2014/main" id="{01C7B67E-417B-453D-BEE0-E18FCC294897}"/>
               </a:ext>
             </a:extLst>
           </p:cNvPr>
@@ -17175,7 +17232,7 @@
           <p:cNvPr id="6" name="">
             <a:extLst xmlns:a="http://schemas.openxmlformats.org/drawingml/2006/main">
               <a:ext uri="{FF2B5EF4-FFF2-40B4-BE49-F238E27FC236}">
-                <a16:creationId xmlns:a16="http://schemas.microsoft.com/office/drawing/2014/main" id="{FEEAE493-CF41-4C4B-9360-284DD62F0855}"/>
+                <a16:creationId xmlns:a16="http://schemas.microsoft.com/office/drawing/2014/main" id="{CDEEC674-55E5-4D9D-B336-587044B8F0ED}"/>
               </a:ext>
             </a:extLst>
           </p:cNvPr>
@@ -17227,7 +17284,7 @@
           <p:cNvPr id="7" name="">
             <a:extLst xmlns:a="http://schemas.openxmlformats.org/drawingml/2006/main">
               <a:ext uri="{FF2B5EF4-FFF2-40B4-BE49-F238E27FC236}">
-                <a16:creationId xmlns:a16="http://schemas.microsoft.com/office/drawing/2014/main" id="{89C6FD44-08F3-4D35-87DA-177CFD12AF0C}"/>
+                <a16:creationId xmlns:a16="http://schemas.microsoft.com/office/drawing/2014/main" id="{43BE2EAA-03DD-470B-A74C-6832775914FC}"/>
               </a:ext>
             </a:extLst>
           </p:cNvPr>
@@ -17301,7 +17358,7 @@
           <p:cNvPr id="9" name="">
             <a:extLst xmlns:a="http://schemas.openxmlformats.org/drawingml/2006/main">
               <a:ext uri="{FF2B5EF4-FFF2-40B4-BE49-F238E27FC236}">
-                <a16:creationId xmlns:a16="http://schemas.microsoft.com/office/drawing/2014/main" id="{0265F937-8356-4AE9-B495-9BCEAA2825C9}"/>
+                <a16:creationId xmlns:a16="http://schemas.microsoft.com/office/drawing/2014/main" id="{F19BAD71-0EF8-4812-BBE6-89A6FBC65036}"/>
               </a:ext>
             </a:extLst>
           </p:cNvPr>
@@ -17353,7 +17410,7 @@
           <p:cNvPr id="10" name="">
             <a:extLst xmlns:a="http://schemas.openxmlformats.org/drawingml/2006/main">
               <a:ext uri="{FF2B5EF4-FFF2-40B4-BE49-F238E27FC236}">
-                <a16:creationId xmlns:a16="http://schemas.microsoft.com/office/drawing/2014/main" id="{75FD19F2-814F-464D-A236-9FE9857769DD}"/>
+                <a16:creationId xmlns:a16="http://schemas.microsoft.com/office/drawing/2014/main" id="{DFD3323D-3792-48A1-B8E1-BA44D6E26980}"/>
               </a:ext>
             </a:extLst>
           </p:cNvPr>
@@ -17427,7 +17484,7 @@
           <p:cNvPr id="12" name="">
             <a:extLst xmlns:a="http://schemas.openxmlformats.org/drawingml/2006/main">
               <a:ext uri="{FF2B5EF4-FFF2-40B4-BE49-F238E27FC236}">
-                <a16:creationId xmlns:a16="http://schemas.microsoft.com/office/drawing/2014/main" id="{F7CE5071-3823-4E23-A4DC-99FB2657D830}"/>
+                <a16:creationId xmlns:a16="http://schemas.microsoft.com/office/drawing/2014/main" id="{2C6662DB-7EE6-4BDE-898E-19502ABA7A30}"/>
               </a:ext>
             </a:extLst>
           </p:cNvPr>
@@ -17479,7 +17536,7 @@
           <p:cNvPr id="13" name="">
             <a:extLst xmlns:a="http://schemas.openxmlformats.org/drawingml/2006/main">
               <a:ext uri="{FF2B5EF4-FFF2-40B4-BE49-F238E27FC236}">
-                <a16:creationId xmlns:a16="http://schemas.microsoft.com/office/drawing/2014/main" id="{C819B289-0BB4-4D5A-8F34-2C93EBBFB75E}"/>
+                <a16:creationId xmlns:a16="http://schemas.microsoft.com/office/drawing/2014/main" id="{C29444C9-A4A8-46B0-84A1-6F411ACFF068}"/>
               </a:ext>
             </a:extLst>
           </p:cNvPr>
@@ -17553,7 +17610,7 @@
           <p:cNvPr id="15" name="">
             <a:extLst xmlns:a="http://schemas.openxmlformats.org/drawingml/2006/main">
               <a:ext uri="{FF2B5EF4-FFF2-40B4-BE49-F238E27FC236}">
-                <a16:creationId xmlns:a16="http://schemas.microsoft.com/office/drawing/2014/main" id="{4E266DEA-C984-42DA-952E-F2FC322599BC}"/>
+                <a16:creationId xmlns:a16="http://schemas.microsoft.com/office/drawing/2014/main" id="{C9495CF0-7613-4E6D-BD61-B7AB1E1CF135}"/>
               </a:ext>
             </a:extLst>
           </p:cNvPr>
@@ -17605,7 +17662,7 @@
           <p:cNvPr id="16" name="">
             <a:extLst xmlns:a="http://schemas.openxmlformats.org/drawingml/2006/main">
               <a:ext uri="{FF2B5EF4-FFF2-40B4-BE49-F238E27FC236}">
-                <a16:creationId xmlns:a16="http://schemas.microsoft.com/office/drawing/2014/main" id="{E9BAD291-C9BB-4575-8AB1-307EB7E8C4FF}"/>
+                <a16:creationId xmlns:a16="http://schemas.microsoft.com/office/drawing/2014/main" id="{BC63C051-B4E0-475E-841A-F353117E868F}"/>
               </a:ext>
             </a:extLst>
           </p:cNvPr>
@@ -17679,7 +17736,7 @@
           <p:cNvPr id="18" name="">
             <a:extLst xmlns:a="http://schemas.openxmlformats.org/drawingml/2006/main">
               <a:ext uri="{FF2B5EF4-FFF2-40B4-BE49-F238E27FC236}">
-                <a16:creationId xmlns:a16="http://schemas.microsoft.com/office/drawing/2014/main" id="{2FBBF3B9-3161-4396-AD60-9699987E9123}"/>
+                <a16:creationId xmlns:a16="http://schemas.microsoft.com/office/drawing/2014/main" id="{821BBF69-A35B-4A58-8E8A-750BD3633551}"/>
               </a:ext>
             </a:extLst>
           </p:cNvPr>
@@ -17731,7 +17788,7 @@
           <p:cNvPr id="19" name="">
             <a:extLst xmlns:a="http://schemas.openxmlformats.org/drawingml/2006/main">
               <a:ext uri="{FF2B5EF4-FFF2-40B4-BE49-F238E27FC236}">
-                <a16:creationId xmlns:a16="http://schemas.microsoft.com/office/drawing/2014/main" id="{80A95771-63CB-4D14-BD32-429B09F4F803}"/>
+                <a16:creationId xmlns:a16="http://schemas.microsoft.com/office/drawing/2014/main" id="{9A1C8C06-6EC1-44DD-8198-FB68F60E8559}"/>
               </a:ext>
             </a:extLst>
           </p:cNvPr>
@@ -17805,7 +17862,7 @@
           <p:cNvPr id="21" name="">
             <a:extLst xmlns:a="http://schemas.openxmlformats.org/drawingml/2006/main">
               <a:ext uri="{FF2B5EF4-FFF2-40B4-BE49-F238E27FC236}">
-                <a16:creationId xmlns:a16="http://schemas.microsoft.com/office/drawing/2014/main" id="{72EAC8E0-843B-44BA-B11E-4844DC42196D}"/>
+                <a16:creationId xmlns:a16="http://schemas.microsoft.com/office/drawing/2014/main" id="{B1244174-19EE-45C8-8C38-45DFE02F9D09}"/>
               </a:ext>
             </a:extLst>
           </p:cNvPr>
@@ -17857,7 +17914,7 @@
           <p:cNvPr id="22" name="">
             <a:extLst xmlns:a="http://schemas.openxmlformats.org/drawingml/2006/main">
               <a:ext uri="{FF2B5EF4-FFF2-40B4-BE49-F238E27FC236}">
-                <a16:creationId xmlns:a16="http://schemas.microsoft.com/office/drawing/2014/main" id="{03C09E70-24EA-4827-9B25-0339EAA1A536}"/>
+                <a16:creationId xmlns:a16="http://schemas.microsoft.com/office/drawing/2014/main" id="{02291E6B-E43C-4828-A012-B3E4B2230B2A}"/>
               </a:ext>
             </a:extLst>
           </p:cNvPr>
@@ -17907,7 +17964,7 @@
     </p:spTree>
     <p:extLst>
       <p:ext uri="{BB962C8B-B14F-4D97-AF65-F5344CB8AC3E}">
-        <p14:creationId xmlns:p14="http://schemas.microsoft.com/office/powerpoint/2010/main" val="1859334278"/>
+        <p14:creationId xmlns:p14="http://schemas.microsoft.com/office/powerpoint/2010/main" val="810214892"/>
       </p:ext>
     </p:extLst>
   </p:cSld>
@@ -17931,7 +17988,7 @@
           <p:cNvPr id="14" name="">
             <a:extLst xmlns:a="http://schemas.openxmlformats.org/drawingml/2006/main">
               <a:ext uri="{FF2B5EF4-FFF2-40B4-BE49-F238E27FC236}">
-                <a16:creationId xmlns:a16="http://schemas.microsoft.com/office/drawing/2014/main" id="{D7C4912A-2ECC-4CF4-A7EA-1BF5DA85FA2F}"/>
+                <a16:creationId xmlns:a16="http://schemas.microsoft.com/office/drawing/2014/main" id="{D75F8F2D-77C7-4915-8CB1-F7FBB68485A3}"/>
               </a:ext>
             </a:extLst>
           </p:cNvPr>
@@ -17983,7 +18040,7 @@
           <p:cNvPr id="2" name="">
             <a:extLst xmlns:a="http://schemas.openxmlformats.org/drawingml/2006/main">
               <a:ext uri="{FF2B5EF4-FFF2-40B4-BE49-F238E27FC236}">
-                <a16:creationId xmlns:a16="http://schemas.microsoft.com/office/drawing/2014/main" id="{B5B44B9D-518A-4D89-84B3-B3994D741FB9}"/>
+                <a16:creationId xmlns:a16="http://schemas.microsoft.com/office/drawing/2014/main" id="{C8609ED4-3359-4C98-A1FC-CD660DBC97D9}"/>
               </a:ext>
             </a:extLst>
           </p:cNvPr>
@@ -18057,7 +18114,7 @@
           <p:cNvPr id="4" name="">
             <a:extLst xmlns:a="http://schemas.openxmlformats.org/drawingml/2006/main">
               <a:ext uri="{FF2B5EF4-FFF2-40B4-BE49-F238E27FC236}">
-                <a16:creationId xmlns:a16="http://schemas.microsoft.com/office/drawing/2014/main" id="{259B2C20-3176-4F59-A488-2909A63A5087}"/>
+                <a16:creationId xmlns:a16="http://schemas.microsoft.com/office/drawing/2014/main" id="{69D90404-A19B-4CA6-9438-555CF7E46172}"/>
               </a:ext>
             </a:extLst>
           </p:cNvPr>
@@ -18109,7 +18166,7 @@
           <p:cNvPr id="5" name="">
             <a:extLst xmlns:a="http://schemas.openxmlformats.org/drawingml/2006/main">
               <a:ext uri="{FF2B5EF4-FFF2-40B4-BE49-F238E27FC236}">
-                <a16:creationId xmlns:a16="http://schemas.microsoft.com/office/drawing/2014/main" id="{80FCA295-FE02-41F5-875F-729E0F2C549C}"/>
+                <a16:creationId xmlns:a16="http://schemas.microsoft.com/office/drawing/2014/main" id="{37DABA36-2D94-4ACF-8F87-D468F3CA0387}"/>
               </a:ext>
             </a:extLst>
           </p:cNvPr>
@@ -18140,7 +18197,7 @@
           <p:cNvPr id="6" name="">
             <a:extLst xmlns:a="http://schemas.openxmlformats.org/drawingml/2006/main">
               <a:ext uri="{FF2B5EF4-FFF2-40B4-BE49-F238E27FC236}">
-                <a16:creationId xmlns:a16="http://schemas.microsoft.com/office/drawing/2014/main" id="{D32CE1DA-EE10-47D4-A4BC-95B28A8830D2}"/>
+                <a16:creationId xmlns:a16="http://schemas.microsoft.com/office/drawing/2014/main" id="{FF9973EB-71B5-495B-91FB-DB926C2E809B}"/>
               </a:ext>
             </a:extLst>
           </p:cNvPr>
@@ -18192,7 +18249,7 @@
           <p:cNvPr id="7" name="">
             <a:extLst xmlns:a="http://schemas.openxmlformats.org/drawingml/2006/main">
               <a:ext uri="{FF2B5EF4-FFF2-40B4-BE49-F238E27FC236}">
-                <a16:creationId xmlns:a16="http://schemas.microsoft.com/office/drawing/2014/main" id="{230E1DD4-795A-4A57-B1D6-C0C7F0BFECD1}"/>
+                <a16:creationId xmlns:a16="http://schemas.microsoft.com/office/drawing/2014/main" id="{DCB69AE4-3F09-40F8-86CC-FB9C0A34245B}"/>
               </a:ext>
             </a:extLst>
           </p:cNvPr>
@@ -18363,7 +18420,7 @@
           <p:cNvPr id="8" name="">
             <a:extLst xmlns:a="http://schemas.openxmlformats.org/drawingml/2006/main">
               <a:ext uri="{FF2B5EF4-FFF2-40B4-BE49-F238E27FC236}">
-                <a16:creationId xmlns:a16="http://schemas.microsoft.com/office/drawing/2014/main" id="{ED9DB8F5-99ED-4FDB-9CC0-6F88CF132ACC}"/>
+                <a16:creationId xmlns:a16="http://schemas.microsoft.com/office/drawing/2014/main" id="{8435E372-42A6-47D5-9A09-9F085FB78B9B}"/>
               </a:ext>
             </a:extLst>
           </p:cNvPr>
@@ -18394,7 +18451,7 @@
           <p:cNvPr id="9" name="">
             <a:extLst xmlns:a="http://schemas.openxmlformats.org/drawingml/2006/main">
               <a:ext uri="{FF2B5EF4-FFF2-40B4-BE49-F238E27FC236}">
-                <a16:creationId xmlns:a16="http://schemas.microsoft.com/office/drawing/2014/main" id="{1752D745-AB21-4304-83DF-0070DB713D33}"/>
+                <a16:creationId xmlns:a16="http://schemas.microsoft.com/office/drawing/2014/main" id="{39112A2F-C371-48A7-AF0B-25A33612F7B8}"/>
               </a:ext>
             </a:extLst>
           </p:cNvPr>
@@ -18446,7 +18503,7 @@
           <p:cNvPr id="10" name="">
             <a:extLst xmlns:a="http://schemas.openxmlformats.org/drawingml/2006/main">
               <a:ext uri="{FF2B5EF4-FFF2-40B4-BE49-F238E27FC236}">
-                <a16:creationId xmlns:a16="http://schemas.microsoft.com/office/drawing/2014/main" id="{33CD6D6B-345F-490F-A87A-2E6F151B02E8}"/>
+                <a16:creationId xmlns:a16="http://schemas.microsoft.com/office/drawing/2014/main" id="{E24238EA-94A0-44B0-8BAA-5562FABE072A}"/>
               </a:ext>
             </a:extLst>
           </p:cNvPr>
@@ -18617,7 +18674,7 @@
           <p:cNvPr id="11" name="">
             <a:extLst xmlns:a="http://schemas.openxmlformats.org/drawingml/2006/main">
               <a:ext uri="{FF2B5EF4-FFF2-40B4-BE49-F238E27FC236}">
-                <a16:creationId xmlns:a16="http://schemas.microsoft.com/office/drawing/2014/main" id="{5D4069CA-A5F0-4DDC-92F5-42EBE6807E23}"/>
+                <a16:creationId xmlns:a16="http://schemas.microsoft.com/office/drawing/2014/main" id="{3F63A4F5-D960-4F3B-8357-55B75E8D4434}"/>
               </a:ext>
             </a:extLst>
           </p:cNvPr>
@@ -18648,7 +18705,7 @@
           <p:cNvPr id="12" name="">
             <a:extLst xmlns:a="http://schemas.openxmlformats.org/drawingml/2006/main">
               <a:ext uri="{FF2B5EF4-FFF2-40B4-BE49-F238E27FC236}">
-                <a16:creationId xmlns:a16="http://schemas.microsoft.com/office/drawing/2014/main" id="{CEBAB116-EFBB-4E9A-9094-F8183BE53E11}"/>
+                <a16:creationId xmlns:a16="http://schemas.microsoft.com/office/drawing/2014/main" id="{79D685B0-725F-44E9-862D-E33F65A6C84F}"/>
               </a:ext>
             </a:extLst>
           </p:cNvPr>
@@ -18700,7 +18757,7 @@
           <p:cNvPr id="13" name="">
             <a:extLst xmlns:a="http://schemas.openxmlformats.org/drawingml/2006/main">
               <a:ext uri="{FF2B5EF4-FFF2-40B4-BE49-F238E27FC236}">
-                <a16:creationId xmlns:a16="http://schemas.microsoft.com/office/drawing/2014/main" id="{0CB4D6D4-3634-4E7A-8BE5-17E4DAC03411}"/>
+                <a16:creationId xmlns:a16="http://schemas.microsoft.com/office/drawing/2014/main" id="{7DE65D44-DE38-45DB-B423-532E764E0BAC}"/>
               </a:ext>
             </a:extLst>
           </p:cNvPr>
@@ -18869,7 +18926,7 @@
     </p:spTree>
     <p:extLst>
       <p:ext uri="{BB962C8B-B14F-4D97-AF65-F5344CB8AC3E}">
-        <p14:creationId xmlns:p14="http://schemas.microsoft.com/office/powerpoint/2010/main" val="1801579741"/>
+        <p14:creationId xmlns:p14="http://schemas.microsoft.com/office/powerpoint/2010/main" val="810147249"/>
       </p:ext>
     </p:extLst>
   </p:cSld>
@@ -18893,7 +18950,7 @@
           <p:cNvPr id="32" name="">
             <a:extLst xmlns:a="http://schemas.openxmlformats.org/drawingml/2006/main">
               <a:ext uri="{FF2B5EF4-FFF2-40B4-BE49-F238E27FC236}">
-                <a16:creationId xmlns:a16="http://schemas.microsoft.com/office/drawing/2014/main" id="{46169C04-C6CE-4A27-9E76-57D082320A11}"/>
+                <a16:creationId xmlns:a16="http://schemas.microsoft.com/office/drawing/2014/main" id="{074EE099-E5CA-42F7-90C8-5D6B1C644242}"/>
               </a:ext>
             </a:extLst>
           </p:cNvPr>
@@ -18945,7 +19002,7 @@
           <p:cNvPr id="2" name="">
             <a:extLst xmlns:a="http://schemas.openxmlformats.org/drawingml/2006/main">
               <a:ext uri="{FF2B5EF4-FFF2-40B4-BE49-F238E27FC236}">
-                <a16:creationId xmlns:a16="http://schemas.microsoft.com/office/drawing/2014/main" id="{921AF262-A9A2-4598-8DDC-89AE15FE2A23}"/>
+                <a16:creationId xmlns:a16="http://schemas.microsoft.com/office/drawing/2014/main" id="{0C0AF47A-8990-4D96-9FB6-3AE7AEAFCBB5}"/>
               </a:ext>
             </a:extLst>
           </p:cNvPr>
@@ -19019,7 +19076,7 @@
           <p:cNvPr id="4" name="">
             <a:extLst xmlns:a="http://schemas.openxmlformats.org/drawingml/2006/main">
               <a:ext uri="{FF2B5EF4-FFF2-40B4-BE49-F238E27FC236}">
-                <a16:creationId xmlns:a16="http://schemas.microsoft.com/office/drawing/2014/main" id="{7D32E68A-3C02-4905-9920-4C63A551C84A}"/>
+                <a16:creationId xmlns:a16="http://schemas.microsoft.com/office/drawing/2014/main" id="{38FEBC15-42C9-4064-85BE-1AD3E0BD6F81}"/>
               </a:ext>
             </a:extLst>
           </p:cNvPr>
@@ -19071,7 +19128,7 @@
           <p:cNvPr id="5" name="">
             <a:extLst xmlns:a="http://schemas.openxmlformats.org/drawingml/2006/main">
               <a:ext uri="{FF2B5EF4-FFF2-40B4-BE49-F238E27FC236}">
-                <a16:creationId xmlns:a16="http://schemas.microsoft.com/office/drawing/2014/main" id="{C09A20A3-375D-4944-8770-3CB70D994317}"/>
+                <a16:creationId xmlns:a16="http://schemas.microsoft.com/office/drawing/2014/main" id="{9BE3F3C1-E1F8-4DE5-9FC5-9AAFA710A454}"/>
               </a:ext>
             </a:extLst>
           </p:cNvPr>
@@ -19104,7 +19161,7 @@
           <p:cNvPr id="6" name="">
             <a:extLst xmlns:a="http://schemas.openxmlformats.org/drawingml/2006/main">
               <a:ext uri="{FF2B5EF4-FFF2-40B4-BE49-F238E27FC236}">
-                <a16:creationId xmlns:a16="http://schemas.microsoft.com/office/drawing/2014/main" id="{74BD7766-60F7-4F3E-99B8-9D64333F2BA1}"/>
+                <a16:creationId xmlns:a16="http://schemas.microsoft.com/office/drawing/2014/main" id="{0410B45D-7B6D-459F-A123-A2CE4407BBE9}"/>
               </a:ext>
             </a:extLst>
           </p:cNvPr>
@@ -19156,7 +19213,7 @@
           <p:cNvPr id="7" name="">
             <a:extLst xmlns:a="http://schemas.openxmlformats.org/drawingml/2006/main">
               <a:ext uri="{FF2B5EF4-FFF2-40B4-BE49-F238E27FC236}">
-                <a16:creationId xmlns:a16="http://schemas.microsoft.com/office/drawing/2014/main" id="{AE5F1A3A-37BF-47BE-AA08-80A6FE642ECE}"/>
+                <a16:creationId xmlns:a16="http://schemas.microsoft.com/office/drawing/2014/main" id="{F6687B5D-AEA3-47C4-A0B2-3DAC0B3A6468}"/>
               </a:ext>
             </a:extLst>
           </p:cNvPr>
@@ -19189,7 +19246,7 @@
           <p:cNvPr id="8" name="">
             <a:extLst xmlns:a="http://schemas.openxmlformats.org/drawingml/2006/main">
               <a:ext uri="{FF2B5EF4-FFF2-40B4-BE49-F238E27FC236}">
-                <a16:creationId xmlns:a16="http://schemas.microsoft.com/office/drawing/2014/main" id="{791D101E-BD6A-4BCC-9FA8-65B75682F1F2}"/>
+                <a16:creationId xmlns:a16="http://schemas.microsoft.com/office/drawing/2014/main" id="{6F0C715A-3F51-4AB2-8DC8-8669CC36814C}"/>
               </a:ext>
             </a:extLst>
           </p:cNvPr>
@@ -19241,7 +19298,7 @@
           <p:cNvPr id="9" name="">
             <a:extLst xmlns:a="http://schemas.openxmlformats.org/drawingml/2006/main">
               <a:ext uri="{FF2B5EF4-FFF2-40B4-BE49-F238E27FC236}">
-                <a16:creationId xmlns:a16="http://schemas.microsoft.com/office/drawing/2014/main" id="{1FE0C673-D54A-48B5-AAF0-E0170577CF75}"/>
+                <a16:creationId xmlns:a16="http://schemas.microsoft.com/office/drawing/2014/main" id="{2CA86339-7DA1-492B-9C34-CA852DF64559}"/>
               </a:ext>
             </a:extLst>
           </p:cNvPr>
@@ -19274,7 +19331,7 @@
           <p:cNvPr id="10" name="">
             <a:extLst xmlns:a="http://schemas.openxmlformats.org/drawingml/2006/main">
               <a:ext uri="{FF2B5EF4-FFF2-40B4-BE49-F238E27FC236}">
-                <a16:creationId xmlns:a16="http://schemas.microsoft.com/office/drawing/2014/main" id="{F8F853C6-249D-49BA-9C97-B26BF6D423BC}"/>
+                <a16:creationId xmlns:a16="http://schemas.microsoft.com/office/drawing/2014/main" id="{75B9D2C9-8775-44CC-B11E-AF5B1C66BAF2}"/>
               </a:ext>
             </a:extLst>
           </p:cNvPr>
@@ -19326,7 +19383,7 @@
           <p:cNvPr id="11" name="">
             <a:extLst xmlns:a="http://schemas.openxmlformats.org/drawingml/2006/main">
               <a:ext uri="{FF2B5EF4-FFF2-40B4-BE49-F238E27FC236}">
-                <a16:creationId xmlns:a16="http://schemas.microsoft.com/office/drawing/2014/main" id="{A08E8E80-1338-454F-96CD-E1A1F4875C2F}"/>
+                <a16:creationId xmlns:a16="http://schemas.microsoft.com/office/drawing/2014/main" id="{7A63426F-6271-4FAC-ABAE-71FA1FFA7615}"/>
               </a:ext>
             </a:extLst>
           </p:cNvPr>
@@ -19359,7 +19416,7 @@
           <p:cNvPr id="12" name="">
             <a:extLst xmlns:a="http://schemas.openxmlformats.org/drawingml/2006/main">
               <a:ext uri="{FF2B5EF4-FFF2-40B4-BE49-F238E27FC236}">
-                <a16:creationId xmlns:a16="http://schemas.microsoft.com/office/drawing/2014/main" id="{7D943941-552D-4FAA-8CBC-E2FBAE32AAFC}"/>
+                <a16:creationId xmlns:a16="http://schemas.microsoft.com/office/drawing/2014/main" id="{DA4DA3AD-CBAE-4BEE-B542-5405CDF5D18B}"/>
               </a:ext>
             </a:extLst>
           </p:cNvPr>
@@ -19411,7 +19468,7 @@
           <p:cNvPr id="13" name="">
             <a:extLst xmlns:a="http://schemas.openxmlformats.org/drawingml/2006/main">
               <a:ext uri="{FF2B5EF4-FFF2-40B4-BE49-F238E27FC236}">
-                <a16:creationId xmlns:a16="http://schemas.microsoft.com/office/drawing/2014/main" id="{47D63CA1-1416-4E94-A95A-2C1F2FF2802D}"/>
+                <a16:creationId xmlns:a16="http://schemas.microsoft.com/office/drawing/2014/main" id="{8F3AB688-7923-4DF7-B496-B932468395DB}"/>
               </a:ext>
             </a:extLst>
           </p:cNvPr>
@@ -19444,7 +19501,7 @@
           <p:cNvPr id="14" name="">
             <a:extLst xmlns:a="http://schemas.openxmlformats.org/drawingml/2006/main">
               <a:ext uri="{FF2B5EF4-FFF2-40B4-BE49-F238E27FC236}">
-                <a16:creationId xmlns:a16="http://schemas.microsoft.com/office/drawing/2014/main" id="{6B0BC468-B9E7-4904-85C0-C59C97950AF4}"/>
+                <a16:creationId xmlns:a16="http://schemas.microsoft.com/office/drawing/2014/main" id="{CEBDD17E-D513-4D8B-B20C-80E25B16B9A4}"/>
               </a:ext>
             </a:extLst>
           </p:cNvPr>
@@ -19496,7 +19553,7 @@
           <p:cNvPr id="15" name="">
             <a:extLst xmlns:a="http://schemas.openxmlformats.org/drawingml/2006/main">
               <a:ext uri="{FF2B5EF4-FFF2-40B4-BE49-F238E27FC236}">
-                <a16:creationId xmlns:a16="http://schemas.microsoft.com/office/drawing/2014/main" id="{07CAF315-0278-4B68-B9E6-703AF2E7EB87}"/>
+                <a16:creationId xmlns:a16="http://schemas.microsoft.com/office/drawing/2014/main" id="{3CC8B6E0-53B1-4109-9AC6-A4A7D415C80D}"/>
               </a:ext>
             </a:extLst>
           </p:cNvPr>
@@ -19529,7 +19586,7 @@
           <p:cNvPr id="16" name="">
             <a:extLst xmlns:a="http://schemas.openxmlformats.org/drawingml/2006/main">
               <a:ext uri="{FF2B5EF4-FFF2-40B4-BE49-F238E27FC236}">
-                <a16:creationId xmlns:a16="http://schemas.microsoft.com/office/drawing/2014/main" id="{DBDBCD0E-F40A-4C90-B918-6AEA35F7FD91}"/>
+                <a16:creationId xmlns:a16="http://schemas.microsoft.com/office/drawing/2014/main" id="{2D55E788-FC72-4B34-BC57-B68639C6631D}"/>
               </a:ext>
             </a:extLst>
           </p:cNvPr>
@@ -19581,7 +19638,7 @@
           <p:cNvPr id="17" name="">
             <a:extLst xmlns:a="http://schemas.openxmlformats.org/drawingml/2006/main">
               <a:ext uri="{FF2B5EF4-FFF2-40B4-BE49-F238E27FC236}">
-                <a16:creationId xmlns:a16="http://schemas.microsoft.com/office/drawing/2014/main" id="{FD576B02-C6E7-4CC2-8E13-3F8D431E2357}"/>
+                <a16:creationId xmlns:a16="http://schemas.microsoft.com/office/drawing/2014/main" id="{BE15FA0F-CE43-42B2-9DA2-F7E1B5B23A34}"/>
               </a:ext>
             </a:extLst>
           </p:cNvPr>
@@ -19614,7 +19671,7 @@
           <p:cNvPr id="18" name="">
             <a:extLst xmlns:a="http://schemas.openxmlformats.org/drawingml/2006/main">
               <a:ext uri="{FF2B5EF4-FFF2-40B4-BE49-F238E27FC236}">
-                <a16:creationId xmlns:a16="http://schemas.microsoft.com/office/drawing/2014/main" id="{2EC33C18-DB31-4788-A39B-A01C60F2B1B7}"/>
+                <a16:creationId xmlns:a16="http://schemas.microsoft.com/office/drawing/2014/main" id="{F6752E15-49B5-449E-A6A5-C4FFFE68F319}"/>
               </a:ext>
             </a:extLst>
           </p:cNvPr>
@@ -19666,7 +19723,7 @@
           <p:cNvPr id="19" name="">
             <a:extLst xmlns:a="http://schemas.openxmlformats.org/drawingml/2006/main">
               <a:ext uri="{FF2B5EF4-FFF2-40B4-BE49-F238E27FC236}">
-                <a16:creationId xmlns:a16="http://schemas.microsoft.com/office/drawing/2014/main" id="{A910A519-5E5E-4DFC-988E-1A19B5F37245}"/>
+                <a16:creationId xmlns:a16="http://schemas.microsoft.com/office/drawing/2014/main" id="{7732844E-4385-48D6-8148-178FC9E03D82}"/>
               </a:ext>
             </a:extLst>
           </p:cNvPr>
@@ -19699,7 +19756,7 @@
           <p:cNvPr id="20" name="">
             <a:extLst xmlns:a="http://schemas.openxmlformats.org/drawingml/2006/main">
               <a:ext uri="{FF2B5EF4-FFF2-40B4-BE49-F238E27FC236}">
-                <a16:creationId xmlns:a16="http://schemas.microsoft.com/office/drawing/2014/main" id="{EFDEF6AF-FAE2-4A17-9ECB-580E4F9865FE}"/>
+                <a16:creationId xmlns:a16="http://schemas.microsoft.com/office/drawing/2014/main" id="{8733F192-36B6-446D-850A-9FB7CFCF26C6}"/>
               </a:ext>
             </a:extLst>
           </p:cNvPr>
@@ -19751,7 +19808,7 @@
           <p:cNvPr id="21" name="">
             <a:extLst xmlns:a="http://schemas.openxmlformats.org/drawingml/2006/main">
               <a:ext uri="{FF2B5EF4-FFF2-40B4-BE49-F238E27FC236}">
-                <a16:creationId xmlns:a16="http://schemas.microsoft.com/office/drawing/2014/main" id="{57194783-C086-42FB-84A8-A3545657DEEE}"/>
+                <a16:creationId xmlns:a16="http://schemas.microsoft.com/office/drawing/2014/main" id="{CD38B7CD-8B47-46D7-8733-4E153D0A9F79}"/>
               </a:ext>
             </a:extLst>
           </p:cNvPr>
@@ -19784,7 +19841,7 @@
           <p:cNvPr id="22" name="">
             <a:extLst xmlns:a="http://schemas.openxmlformats.org/drawingml/2006/main">
               <a:ext uri="{FF2B5EF4-FFF2-40B4-BE49-F238E27FC236}">
-                <a16:creationId xmlns:a16="http://schemas.microsoft.com/office/drawing/2014/main" id="{D37BED0A-0C84-407A-97C1-CE8B394E8BBD}"/>
+                <a16:creationId xmlns:a16="http://schemas.microsoft.com/office/drawing/2014/main" id="{1696B3DC-A73D-456D-8292-8C4CAB96AB29}"/>
               </a:ext>
             </a:extLst>
           </p:cNvPr>
@@ -19836,7 +19893,7 @@
           <p:cNvPr id="23" name="">
             <a:extLst xmlns:a="http://schemas.openxmlformats.org/drawingml/2006/main">
               <a:ext uri="{FF2B5EF4-FFF2-40B4-BE49-F238E27FC236}">
-                <a16:creationId xmlns:a16="http://schemas.microsoft.com/office/drawing/2014/main" id="{5FDC8203-9299-4611-817D-536BE09BB0F7}"/>
+                <a16:creationId xmlns:a16="http://schemas.microsoft.com/office/drawing/2014/main" id="{45585F71-1791-4EB3-82C4-DD55041F59A6}"/>
               </a:ext>
             </a:extLst>
           </p:cNvPr>
@@ -19869,7 +19926,7 @@
           <p:cNvPr id="24" name="">
             <a:extLst xmlns:a="http://schemas.openxmlformats.org/drawingml/2006/main">
               <a:ext uri="{FF2B5EF4-FFF2-40B4-BE49-F238E27FC236}">
-                <a16:creationId xmlns:a16="http://schemas.microsoft.com/office/drawing/2014/main" id="{F9CCF074-BBAD-45A8-AFEF-EC187A7B9702}"/>
+                <a16:creationId xmlns:a16="http://schemas.microsoft.com/office/drawing/2014/main" id="{FF4C329B-25E9-4560-8A05-2F799F7AE78A}"/>
               </a:ext>
             </a:extLst>
           </p:cNvPr>
@@ -19921,7 +19978,7 @@
           <p:cNvPr id="25" name="">
             <a:extLst xmlns:a="http://schemas.openxmlformats.org/drawingml/2006/main">
               <a:ext uri="{FF2B5EF4-FFF2-40B4-BE49-F238E27FC236}">
-                <a16:creationId xmlns:a16="http://schemas.microsoft.com/office/drawing/2014/main" id="{BD66137C-642C-45F5-B9CA-21583861D0E6}"/>
+                <a16:creationId xmlns:a16="http://schemas.microsoft.com/office/drawing/2014/main" id="{3FC30A74-7D5D-438F-9945-DBA951BDDF93}"/>
               </a:ext>
             </a:extLst>
           </p:cNvPr>
@@ -19954,7 +20011,7 @@
           <p:cNvPr id="26" name="">
             <a:extLst xmlns:a="http://schemas.openxmlformats.org/drawingml/2006/main">
               <a:ext uri="{FF2B5EF4-FFF2-40B4-BE49-F238E27FC236}">
-                <a16:creationId xmlns:a16="http://schemas.microsoft.com/office/drawing/2014/main" id="{180E4F4E-C9BA-444A-BC27-B52DC42BEF98}"/>
+                <a16:creationId xmlns:a16="http://schemas.microsoft.com/office/drawing/2014/main" id="{08A5FD23-5C7A-4C92-ADC1-B0BBBE372956}"/>
               </a:ext>
             </a:extLst>
           </p:cNvPr>
@@ -20006,7 +20063,7 @@
           <p:cNvPr id="27" name="">
             <a:extLst xmlns:a="http://schemas.openxmlformats.org/drawingml/2006/main">
               <a:ext uri="{FF2B5EF4-FFF2-40B4-BE49-F238E27FC236}">
-                <a16:creationId xmlns:a16="http://schemas.microsoft.com/office/drawing/2014/main" id="{F3D76EB0-88ED-47BF-BC27-682B03AD4981}"/>
+                <a16:creationId xmlns:a16="http://schemas.microsoft.com/office/drawing/2014/main" id="{A68DF52E-0CA5-4392-83DC-0F5AAB9C5C14}"/>
               </a:ext>
             </a:extLst>
           </p:cNvPr>
@@ -20039,7 +20096,7 @@
           <p:cNvPr id="28" name="">
             <a:extLst xmlns:a="http://schemas.openxmlformats.org/drawingml/2006/main">
               <a:ext uri="{FF2B5EF4-FFF2-40B4-BE49-F238E27FC236}">
-                <a16:creationId xmlns:a16="http://schemas.microsoft.com/office/drawing/2014/main" id="{E961B21E-6A6E-4C63-B8D4-372555016452}"/>
+                <a16:creationId xmlns:a16="http://schemas.microsoft.com/office/drawing/2014/main" id="{6BC5B0E0-65D0-4AE8-B7C8-ED3D6387A381}"/>
               </a:ext>
             </a:extLst>
           </p:cNvPr>
@@ -20091,7 +20148,7 @@
           <p:cNvPr id="29" name="">
             <a:extLst xmlns:a="http://schemas.openxmlformats.org/drawingml/2006/main">
               <a:ext uri="{FF2B5EF4-FFF2-40B4-BE49-F238E27FC236}">
-                <a16:creationId xmlns:a16="http://schemas.microsoft.com/office/drawing/2014/main" id="{4EABC7D5-EF0C-4BA0-B735-35149E9049D6}"/>
+                <a16:creationId xmlns:a16="http://schemas.microsoft.com/office/drawing/2014/main" id="{0730488D-B188-4B14-AD0D-D06151BF71E3}"/>
               </a:ext>
             </a:extLst>
           </p:cNvPr>
@@ -20124,7 +20181,7 @@
           <p:cNvPr id="30" name="">
             <a:extLst xmlns:a="http://schemas.openxmlformats.org/drawingml/2006/main">
               <a:ext uri="{FF2B5EF4-FFF2-40B4-BE49-F238E27FC236}">
-                <a16:creationId xmlns:a16="http://schemas.microsoft.com/office/drawing/2014/main" id="{A8F01E44-7832-4AD5-981B-B5FE6ECCEC8A}"/>
+                <a16:creationId xmlns:a16="http://schemas.microsoft.com/office/drawing/2014/main" id="{0523C0A0-9E1F-484F-8087-9C7654BF784A}"/>
               </a:ext>
             </a:extLst>
           </p:cNvPr>
@@ -20176,7 +20233,7 @@
           <p:cNvPr id="31" name="">
             <a:extLst xmlns:a="http://schemas.openxmlformats.org/drawingml/2006/main">
               <a:ext uri="{FF2B5EF4-FFF2-40B4-BE49-F238E27FC236}">
-                <a16:creationId xmlns:a16="http://schemas.microsoft.com/office/drawing/2014/main" id="{3DEF2D4D-82B1-436B-BB98-1DF4968273C7}"/>
+                <a16:creationId xmlns:a16="http://schemas.microsoft.com/office/drawing/2014/main" id="{CBB35627-8660-47AA-ACBC-D68F17D1F213}"/>
               </a:ext>
             </a:extLst>
           </p:cNvPr>
@@ -20226,7 +20283,7 @@
     </p:spTree>
     <p:extLst>
       <p:ext uri="{BB962C8B-B14F-4D97-AF65-F5344CB8AC3E}">
-        <p14:creationId xmlns:p14="http://schemas.microsoft.com/office/powerpoint/2010/main" val="872217975"/>
+        <p14:creationId xmlns:p14="http://schemas.microsoft.com/office/powerpoint/2010/main" val="97648011"/>
       </p:ext>
     </p:extLst>
   </p:cSld>
@@ -20250,7 +20307,7 @@
           <p:cNvPr id="13" name="">
             <a:extLst xmlns:a="http://schemas.openxmlformats.org/drawingml/2006/main">
               <a:ext uri="{FF2B5EF4-FFF2-40B4-BE49-F238E27FC236}">
-                <a16:creationId xmlns:a16="http://schemas.microsoft.com/office/drawing/2014/main" id="{00AFDA32-66F8-49EC-973C-046088809276}"/>
+                <a16:creationId xmlns:a16="http://schemas.microsoft.com/office/drawing/2014/main" id="{0EB245B0-49E7-4659-8491-5E8793B54B90}"/>
               </a:ext>
             </a:extLst>
           </p:cNvPr>
@@ -20302,7 +20359,7 @@
           <p:cNvPr id="2" name="">
             <a:extLst xmlns:a="http://schemas.openxmlformats.org/drawingml/2006/main">
               <a:ext uri="{FF2B5EF4-FFF2-40B4-BE49-F238E27FC236}">
-                <a16:creationId xmlns:a16="http://schemas.microsoft.com/office/drawing/2014/main" id="{3D5F7A50-462A-4BD2-A132-D1B91EFD67BD}"/>
+                <a16:creationId xmlns:a16="http://schemas.microsoft.com/office/drawing/2014/main" id="{29685039-56CB-4FD2-B3E3-6B9A7CD63F65}"/>
               </a:ext>
             </a:extLst>
           </p:cNvPr>
@@ -20376,7 +20433,7 @@
           <p:cNvPr id="4" name="">
             <a:extLst xmlns:a="http://schemas.openxmlformats.org/drawingml/2006/main">
               <a:ext uri="{FF2B5EF4-FFF2-40B4-BE49-F238E27FC236}">
-                <a16:creationId xmlns:a16="http://schemas.microsoft.com/office/drawing/2014/main" id="{49B7D9E1-0825-464F-9BBE-09AD359B1658}"/>
+                <a16:creationId xmlns:a16="http://schemas.microsoft.com/office/drawing/2014/main" id="{D2A3BE74-2DAD-4985-B9FF-DD858E052F24}"/>
               </a:ext>
             </a:extLst>
           </p:cNvPr>
@@ -20428,7 +20485,7 @@
           <p:cNvPr id="5" name="">
             <a:extLst xmlns:a="http://schemas.openxmlformats.org/drawingml/2006/main">
               <a:ext uri="{FF2B5EF4-FFF2-40B4-BE49-F238E27FC236}">
-                <a16:creationId xmlns:a16="http://schemas.microsoft.com/office/drawing/2014/main" id="{59238ABE-FD9E-4B05-AB39-307A2E1ABA92}"/>
+                <a16:creationId xmlns:a16="http://schemas.microsoft.com/office/drawing/2014/main" id="{7374DDCA-EE08-4A40-AF16-DC7A8F0D37C5}"/>
               </a:ext>
             </a:extLst>
           </p:cNvPr>
@@ -20459,7 +20516,7 @@
           <p:cNvPr id="6" name="">
             <a:extLst xmlns:a="http://schemas.openxmlformats.org/drawingml/2006/main">
               <a:ext uri="{FF2B5EF4-FFF2-40B4-BE49-F238E27FC236}">
-                <a16:creationId xmlns:a16="http://schemas.microsoft.com/office/drawing/2014/main" id="{78BB3F28-30D6-456B-8B01-C3E4756C2AF0}"/>
+                <a16:creationId xmlns:a16="http://schemas.microsoft.com/office/drawing/2014/main" id="{91CBA2CB-F65D-4343-90DB-9F3F5A543DAA}"/>
               </a:ext>
             </a:extLst>
           </p:cNvPr>
@@ -20511,7 +20568,7 @@
           <p:cNvPr id="7" name="">
             <a:extLst xmlns:a="http://schemas.openxmlformats.org/drawingml/2006/main">
               <a:ext uri="{FF2B5EF4-FFF2-40B4-BE49-F238E27FC236}">
-                <a16:creationId xmlns:a16="http://schemas.microsoft.com/office/drawing/2014/main" id="{A1FF94C6-ECCF-4753-ADD9-2394A6361384}"/>
+                <a16:creationId xmlns:a16="http://schemas.microsoft.com/office/drawing/2014/main" id="{582297D7-D88A-4CC4-91FA-73FD80D7380E}"/>
               </a:ext>
             </a:extLst>
           </p:cNvPr>
@@ -20614,7 +20671,7 @@
           <p:cNvPr id="8" name="">
             <a:extLst xmlns:a="http://schemas.openxmlformats.org/drawingml/2006/main">
               <a:ext uri="{FF2B5EF4-FFF2-40B4-BE49-F238E27FC236}">
-                <a16:creationId xmlns:a16="http://schemas.microsoft.com/office/drawing/2014/main" id="{14A6A796-FD1F-4A84-8835-815F078081F1}"/>
+                <a16:creationId xmlns:a16="http://schemas.microsoft.com/office/drawing/2014/main" id="{4146409E-CFE4-484B-A1FC-A22A2AC4757F}"/>
               </a:ext>
             </a:extLst>
           </p:cNvPr>
@@ -20645,7 +20702,7 @@
           <p:cNvPr id="9" name="">
             <a:extLst xmlns:a="http://schemas.openxmlformats.org/drawingml/2006/main">
               <a:ext uri="{FF2B5EF4-FFF2-40B4-BE49-F238E27FC236}">
-                <a16:creationId xmlns:a16="http://schemas.microsoft.com/office/drawing/2014/main" id="{66BA8A70-2A62-44BB-AA89-289A564D1A4A}"/>
+                <a16:creationId xmlns:a16="http://schemas.microsoft.com/office/drawing/2014/main" id="{E5125BD5-7317-4BE2-BCBA-2518F9E0238E}"/>
               </a:ext>
             </a:extLst>
           </p:cNvPr>
@@ -20697,7 +20754,7 @@
           <p:cNvPr id="10" name="">
             <a:extLst xmlns:a="http://schemas.openxmlformats.org/drawingml/2006/main">
               <a:ext uri="{FF2B5EF4-FFF2-40B4-BE49-F238E27FC236}">
-                <a16:creationId xmlns:a16="http://schemas.microsoft.com/office/drawing/2014/main" id="{B6988FAC-1CC4-43F2-B19A-FE13E2969941}"/>
+                <a16:creationId xmlns:a16="http://schemas.microsoft.com/office/drawing/2014/main" id="{DCCE872B-71BB-4E8D-B40B-0893F3D815B4}"/>
               </a:ext>
             </a:extLst>
           </p:cNvPr>
@@ -20800,7 +20857,7 @@
           <p:cNvPr id="11" name="">
             <a:extLst xmlns:a="http://schemas.openxmlformats.org/drawingml/2006/main">
               <a:ext uri="{FF2B5EF4-FFF2-40B4-BE49-F238E27FC236}">
-                <a16:creationId xmlns:a16="http://schemas.microsoft.com/office/drawing/2014/main" id="{AFDDE9B8-0744-4B5A-8AB7-98ADC2438F50}"/>
+                <a16:creationId xmlns:a16="http://schemas.microsoft.com/office/drawing/2014/main" id="{53DA17AC-4F87-46FE-A848-76D620AA8E14}"/>
               </a:ext>
             </a:extLst>
           </p:cNvPr>
@@ -20852,7 +20909,7 @@
           <p:cNvPr id="12" name="">
             <a:extLst xmlns:a="http://schemas.openxmlformats.org/drawingml/2006/main">
               <a:ext uri="{FF2B5EF4-FFF2-40B4-BE49-F238E27FC236}">
-                <a16:creationId xmlns:a16="http://schemas.microsoft.com/office/drawing/2014/main" id="{70E6C588-F7DF-487B-95C6-34E43002A198}"/>
+                <a16:creationId xmlns:a16="http://schemas.microsoft.com/office/drawing/2014/main" id="{C606DD96-2116-401E-9562-9034AD2DEE20}"/>
               </a:ext>
             </a:extLst>
           </p:cNvPr>
@@ -20902,7 +20959,7 @@
     </p:spTree>
     <p:extLst>
       <p:ext uri="{BB962C8B-B14F-4D97-AF65-F5344CB8AC3E}">
-        <p14:creationId xmlns:p14="http://schemas.microsoft.com/office/powerpoint/2010/main" val="1748340124"/>
+        <p14:creationId xmlns:p14="http://schemas.microsoft.com/office/powerpoint/2010/main" val="685266661"/>
       </p:ext>
     </p:extLst>
   </p:cSld>
@@ -20926,7 +20983,7 @@
           <p:cNvPr id="14" name="">
             <a:extLst xmlns:a="http://schemas.openxmlformats.org/drawingml/2006/main">
               <a:ext uri="{FF2B5EF4-FFF2-40B4-BE49-F238E27FC236}">
-                <a16:creationId xmlns:a16="http://schemas.microsoft.com/office/drawing/2014/main" id="{8E5D3E99-D3F8-4582-BD53-1D292914469F}"/>
+                <a16:creationId xmlns:a16="http://schemas.microsoft.com/office/drawing/2014/main" id="{70929134-BC26-4568-BED8-ACD65C680D87}"/>
               </a:ext>
             </a:extLst>
           </p:cNvPr>
@@ -20978,7 +21035,7 @@
           <p:cNvPr id="2" name="">
             <a:extLst xmlns:a="http://schemas.openxmlformats.org/drawingml/2006/main">
               <a:ext uri="{FF2B5EF4-FFF2-40B4-BE49-F238E27FC236}">
-                <a16:creationId xmlns:a16="http://schemas.microsoft.com/office/drawing/2014/main" id="{AC15E145-4B47-44BC-A131-32F8D692A702}"/>
+                <a16:creationId xmlns:a16="http://schemas.microsoft.com/office/drawing/2014/main" id="{0305C354-335B-46B9-9D8A-40B0130AF00C}"/>
               </a:ext>
             </a:extLst>
           </p:cNvPr>
@@ -21052,7 +21109,7 @@
           <p:cNvPr id="4" name="">
             <a:extLst xmlns:a="http://schemas.openxmlformats.org/drawingml/2006/main">
               <a:ext uri="{FF2B5EF4-FFF2-40B4-BE49-F238E27FC236}">
-                <a16:creationId xmlns:a16="http://schemas.microsoft.com/office/drawing/2014/main" id="{4553EF36-7C02-4AEF-8EF2-153103C11BF7}"/>
+                <a16:creationId xmlns:a16="http://schemas.microsoft.com/office/drawing/2014/main" id="{835452AD-EA32-4766-8354-76FF2332C742}"/>
               </a:ext>
             </a:extLst>
           </p:cNvPr>
@@ -21104,7 +21161,7 @@
           <p:cNvPr id="5" name="">
             <a:extLst xmlns:a="http://schemas.openxmlformats.org/drawingml/2006/main">
               <a:ext uri="{FF2B5EF4-FFF2-40B4-BE49-F238E27FC236}">
-                <a16:creationId xmlns:a16="http://schemas.microsoft.com/office/drawing/2014/main" id="{ED1EE729-36D6-48D9-9001-3562263D967E}"/>
+                <a16:creationId xmlns:a16="http://schemas.microsoft.com/office/drawing/2014/main" id="{2C25BB07-F209-4B11-B1E5-C1153D9AF01E}"/>
               </a:ext>
             </a:extLst>
           </p:cNvPr>
@@ -21135,7 +21192,7 @@
           <p:cNvPr id="6" name="">
             <a:extLst xmlns:a="http://schemas.openxmlformats.org/drawingml/2006/main">
               <a:ext uri="{FF2B5EF4-FFF2-40B4-BE49-F238E27FC236}">
-                <a16:creationId xmlns:a16="http://schemas.microsoft.com/office/drawing/2014/main" id="{1F5E706E-4A31-4010-A59D-70E0DD4762D5}"/>
+                <a16:creationId xmlns:a16="http://schemas.microsoft.com/office/drawing/2014/main" id="{41456B6B-66F3-48FA-A138-D0A9768DDB4D}"/>
               </a:ext>
             </a:extLst>
           </p:cNvPr>
@@ -21187,7 +21244,7 @@
           <p:cNvPr id="7" name="">
             <a:extLst xmlns:a="http://schemas.openxmlformats.org/drawingml/2006/main">
               <a:ext uri="{FF2B5EF4-FFF2-40B4-BE49-F238E27FC236}">
-                <a16:creationId xmlns:a16="http://schemas.microsoft.com/office/drawing/2014/main" id="{115E863C-40B0-4871-BDB0-92FEB0A8998C}"/>
+                <a16:creationId xmlns:a16="http://schemas.microsoft.com/office/drawing/2014/main" id="{1D83DB9F-99A2-4C8E-BD4E-00881BE89807}"/>
               </a:ext>
             </a:extLst>
           </p:cNvPr>
@@ -21305,7 +21362,7 @@
           <p:cNvPr id="8" name="">
             <a:extLst xmlns:a="http://schemas.openxmlformats.org/drawingml/2006/main">
               <a:ext uri="{FF2B5EF4-FFF2-40B4-BE49-F238E27FC236}">
-                <a16:creationId xmlns:a16="http://schemas.microsoft.com/office/drawing/2014/main" id="{65CD4C45-0908-407F-96A8-5EDB57E6C34D}"/>
+                <a16:creationId xmlns:a16="http://schemas.microsoft.com/office/drawing/2014/main" id="{37820942-7621-472A-998D-21F24D890C68}"/>
               </a:ext>
             </a:extLst>
           </p:cNvPr>
@@ -21336,7 +21393,7 @@
           <p:cNvPr id="9" name="">
             <a:extLst xmlns:a="http://schemas.openxmlformats.org/drawingml/2006/main">
               <a:ext uri="{FF2B5EF4-FFF2-40B4-BE49-F238E27FC236}">
-                <a16:creationId xmlns:a16="http://schemas.microsoft.com/office/drawing/2014/main" id="{CA4A1390-F322-4F5D-9D2D-8865E41AF370}"/>
+                <a16:creationId xmlns:a16="http://schemas.microsoft.com/office/drawing/2014/main" id="{BC49E097-285E-4FC9-A2AB-814D3164DECC}"/>
               </a:ext>
             </a:extLst>
           </p:cNvPr>
@@ -21388,7 +21445,7 @@
           <p:cNvPr id="10" name="">
             <a:extLst xmlns:a="http://schemas.openxmlformats.org/drawingml/2006/main">
               <a:ext uri="{FF2B5EF4-FFF2-40B4-BE49-F238E27FC236}">
-                <a16:creationId xmlns:a16="http://schemas.microsoft.com/office/drawing/2014/main" id="{0943FCFD-769D-46C1-B9ED-A6BF8CCC5EDA}"/>
+                <a16:creationId xmlns:a16="http://schemas.microsoft.com/office/drawing/2014/main" id="{52E1ACC4-A3C6-434D-9B09-78A0203FC731}"/>
               </a:ext>
             </a:extLst>
           </p:cNvPr>
@@ -21506,7 +21563,7 @@
           <p:cNvPr id="11" name="">
             <a:extLst xmlns:a="http://schemas.openxmlformats.org/drawingml/2006/main">
               <a:ext uri="{FF2B5EF4-FFF2-40B4-BE49-F238E27FC236}">
-                <a16:creationId xmlns:a16="http://schemas.microsoft.com/office/drawing/2014/main" id="{E97A282A-6BE7-4FC6-8CD7-58B004F75A81}"/>
+                <a16:creationId xmlns:a16="http://schemas.microsoft.com/office/drawing/2014/main" id="{9EB20039-997B-4B2A-BEB0-AD5DAAECB8C3}"/>
               </a:ext>
             </a:extLst>
           </p:cNvPr>
@@ -21537,7 +21594,7 @@
           <p:cNvPr id="12" name="">
             <a:extLst xmlns:a="http://schemas.openxmlformats.org/drawingml/2006/main">
               <a:ext uri="{FF2B5EF4-FFF2-40B4-BE49-F238E27FC236}">
-                <a16:creationId xmlns:a16="http://schemas.microsoft.com/office/drawing/2014/main" id="{7E09A9ED-DA23-4AD7-89E7-F8AB1D04C56C}"/>
+                <a16:creationId xmlns:a16="http://schemas.microsoft.com/office/drawing/2014/main" id="{2FD1D835-6B8D-45EB-970F-2FF90B39BE61}"/>
               </a:ext>
             </a:extLst>
           </p:cNvPr>
@@ -21589,7 +21646,7 @@
           <p:cNvPr id="13" name="">
             <a:extLst xmlns:a="http://schemas.openxmlformats.org/drawingml/2006/main">
               <a:ext uri="{FF2B5EF4-FFF2-40B4-BE49-F238E27FC236}">
-                <a16:creationId xmlns:a16="http://schemas.microsoft.com/office/drawing/2014/main" id="{62B2DC5D-D4C4-49C1-99A5-6AFFA2E1DE06}"/>
+                <a16:creationId xmlns:a16="http://schemas.microsoft.com/office/drawing/2014/main" id="{7BD5D909-DE4D-4C2F-828E-34FB56FA159D}"/>
               </a:ext>
             </a:extLst>
           </p:cNvPr>
@@ -21683,7 +21740,7 @@
     </p:spTree>
     <p:extLst>
       <p:ext uri="{BB962C8B-B14F-4D97-AF65-F5344CB8AC3E}">
-        <p14:creationId xmlns:p14="http://schemas.microsoft.com/office/powerpoint/2010/main" val="1178794624"/>
+        <p14:creationId xmlns:p14="http://schemas.microsoft.com/office/powerpoint/2010/main" val="1952934617"/>
       </p:ext>
     </p:extLst>
   </p:cSld>
@@ -21707,7 +21764,7 @@
           <p:cNvPr id="22" name="">
             <a:extLst xmlns:a="http://schemas.openxmlformats.org/drawingml/2006/main">
               <a:ext uri="{FF2B5EF4-FFF2-40B4-BE49-F238E27FC236}">
-                <a16:creationId xmlns:a16="http://schemas.microsoft.com/office/drawing/2014/main" id="{661BE9FA-2FDD-4F08-8589-6D776277855A}"/>
+                <a16:creationId xmlns:a16="http://schemas.microsoft.com/office/drawing/2014/main" id="{4904C5BD-2FDC-4940-9EEC-7A107950DFC2}"/>
               </a:ext>
             </a:extLst>
           </p:cNvPr>
@@ -21759,7 +21816,7 @@
           <p:cNvPr id="2" name="">
             <a:extLst xmlns:a="http://schemas.openxmlformats.org/drawingml/2006/main">
               <a:ext uri="{FF2B5EF4-FFF2-40B4-BE49-F238E27FC236}">
-                <a16:creationId xmlns:a16="http://schemas.microsoft.com/office/drawing/2014/main" id="{A084A455-AAD1-47C6-8463-D92C70227DC4}"/>
+                <a16:creationId xmlns:a16="http://schemas.microsoft.com/office/drawing/2014/main" id="{38DA8948-5C94-4879-A001-A07CE9B79B2E}"/>
               </a:ext>
             </a:extLst>
           </p:cNvPr>
@@ -21833,7 +21890,7 @@
           <p:cNvPr id="4" name="">
             <a:extLst xmlns:a="http://schemas.openxmlformats.org/drawingml/2006/main">
               <a:ext uri="{FF2B5EF4-FFF2-40B4-BE49-F238E27FC236}">
-                <a16:creationId xmlns:a16="http://schemas.microsoft.com/office/drawing/2014/main" id="{04690392-4DD8-4516-A4DB-59F11B4268D3}"/>
+                <a16:creationId xmlns:a16="http://schemas.microsoft.com/office/drawing/2014/main" id="{1D1A8D73-9AC0-4A9C-8FA1-3A19B70F625B}"/>
               </a:ext>
             </a:extLst>
           </p:cNvPr>
@@ -21951,7 +22008,7 @@
           <p:cNvPr id="8" name="">
             <a:extLst xmlns:a="http://schemas.openxmlformats.org/drawingml/2006/main">
               <a:ext uri="{FF2B5EF4-FFF2-40B4-BE49-F238E27FC236}">
-                <a16:creationId xmlns:a16="http://schemas.microsoft.com/office/drawing/2014/main" id="{9F84D148-8367-4300-A9BA-209304926093}"/>
+                <a16:creationId xmlns:a16="http://schemas.microsoft.com/office/drawing/2014/main" id="{19C63CBE-E05C-421A-A79D-E68A944B6B19}"/>
               </a:ext>
             </a:extLst>
           </p:cNvPr>
@@ -21986,7 +22043,7 @@
           <p:cNvPr id="9" name="">
             <a:extLst xmlns:a="http://schemas.openxmlformats.org/drawingml/2006/main">
               <a:ext uri="{FF2B5EF4-FFF2-40B4-BE49-F238E27FC236}">
-                <a16:creationId xmlns:a16="http://schemas.microsoft.com/office/drawing/2014/main" id="{3D0D7960-40DC-4DD6-8F2B-65DCE3641027}"/>
+                <a16:creationId xmlns:a16="http://schemas.microsoft.com/office/drawing/2014/main" id="{D711FE9C-DCA2-4640-88C9-DA4E3CA28324}"/>
               </a:ext>
             </a:extLst>
           </p:cNvPr>
@@ -22038,7 +22095,7 @@
           <p:cNvPr id="10" name="">
             <a:extLst xmlns:a="http://schemas.openxmlformats.org/drawingml/2006/main">
               <a:ext uri="{FF2B5EF4-FFF2-40B4-BE49-F238E27FC236}">
-                <a16:creationId xmlns:a16="http://schemas.microsoft.com/office/drawing/2014/main" id="{96EEFCA9-8D68-4F27-BAEA-B34FCD39D48C}"/>
+                <a16:creationId xmlns:a16="http://schemas.microsoft.com/office/drawing/2014/main" id="{94FD055C-1988-4844-BB0F-09400BC0A5EF}"/>
               </a:ext>
             </a:extLst>
           </p:cNvPr>
@@ -22107,7 +22164,7 @@
           <p:cNvPr id="11" name="">
             <a:extLst xmlns:a="http://schemas.openxmlformats.org/drawingml/2006/main">
               <a:ext uri="{FF2B5EF4-FFF2-40B4-BE49-F238E27FC236}">
-                <a16:creationId xmlns:a16="http://schemas.microsoft.com/office/drawing/2014/main" id="{E63BAC5C-9EB1-4C5D-A0C4-21A323DF72AE}"/>
+                <a16:creationId xmlns:a16="http://schemas.microsoft.com/office/drawing/2014/main" id="{E7975202-1C13-43BA-BF89-4DBB428A4FBC}"/>
               </a:ext>
             </a:extLst>
           </p:cNvPr>
@@ -22142,7 +22199,7 @@
           <p:cNvPr id="12" name="">
             <a:extLst xmlns:a="http://schemas.openxmlformats.org/drawingml/2006/main">
               <a:ext uri="{FF2B5EF4-FFF2-40B4-BE49-F238E27FC236}">
-                <a16:creationId xmlns:a16="http://schemas.microsoft.com/office/drawing/2014/main" id="{B3896EEE-452F-49AE-92AF-99D41905E30E}"/>
+                <a16:creationId xmlns:a16="http://schemas.microsoft.com/office/drawing/2014/main" id="{12A9365F-C7A2-4F39-8F27-C62D9BC5BF35}"/>
               </a:ext>
             </a:extLst>
           </p:cNvPr>
@@ -22194,7 +22251,7 @@
           <p:cNvPr id="13" name="">
             <a:extLst xmlns:a="http://schemas.openxmlformats.org/drawingml/2006/main">
               <a:ext uri="{FF2B5EF4-FFF2-40B4-BE49-F238E27FC236}">
-                <a16:creationId xmlns:a16="http://schemas.microsoft.com/office/drawing/2014/main" id="{472FC6E0-3AED-466C-8E38-2728E7CA0232}"/>
+                <a16:creationId xmlns:a16="http://schemas.microsoft.com/office/drawing/2014/main" id="{189C8960-DAB0-4318-AE76-DA24B2E4A48B}"/>
               </a:ext>
             </a:extLst>
           </p:cNvPr>
@@ -22263,7 +22320,7 @@
           <p:cNvPr id="14" name="">
             <a:extLst xmlns:a="http://schemas.openxmlformats.org/drawingml/2006/main">
               <a:ext uri="{FF2B5EF4-FFF2-40B4-BE49-F238E27FC236}">
-                <a16:creationId xmlns:a16="http://schemas.microsoft.com/office/drawing/2014/main" id="{0B83605A-06A4-4E82-8E4E-322E696339DB}"/>
+                <a16:creationId xmlns:a16="http://schemas.microsoft.com/office/drawing/2014/main" id="{AE44E8A0-EDEC-4F1B-B07E-423635BF22CD}"/>
               </a:ext>
             </a:extLst>
           </p:cNvPr>
@@ -22298,7 +22355,7 @@
           <p:cNvPr id="15" name="">
             <a:extLst xmlns:a="http://schemas.openxmlformats.org/drawingml/2006/main">
               <a:ext uri="{FF2B5EF4-FFF2-40B4-BE49-F238E27FC236}">
-                <a16:creationId xmlns:a16="http://schemas.microsoft.com/office/drawing/2014/main" id="{1B744E66-B488-4CB5-8963-F14D2EBF4652}"/>
+                <a16:creationId xmlns:a16="http://schemas.microsoft.com/office/drawing/2014/main" id="{25A49BAF-B46C-4278-B8D0-D8C657E0205C}"/>
               </a:ext>
             </a:extLst>
           </p:cNvPr>
@@ -22350,7 +22407,7 @@
           <p:cNvPr id="16" name="">
             <a:extLst xmlns:a="http://schemas.openxmlformats.org/drawingml/2006/main">
               <a:ext uri="{FF2B5EF4-FFF2-40B4-BE49-F238E27FC236}">
-                <a16:creationId xmlns:a16="http://schemas.microsoft.com/office/drawing/2014/main" id="{65A0DCD7-485B-4CA2-8ABC-0BCFD49AA00A}"/>
+                <a16:creationId xmlns:a16="http://schemas.microsoft.com/office/drawing/2014/main" id="{28390CCB-7DE8-4309-B265-4F244B98C719}"/>
               </a:ext>
             </a:extLst>
           </p:cNvPr>
@@ -22419,7 +22476,7 @@
           <p:cNvPr id="17" name="">
             <a:extLst xmlns:a="http://schemas.openxmlformats.org/drawingml/2006/main">
               <a:ext uri="{FF2B5EF4-FFF2-40B4-BE49-F238E27FC236}">
-                <a16:creationId xmlns:a16="http://schemas.microsoft.com/office/drawing/2014/main" id="{93DAF8F2-C778-476E-8C4A-AB2EB0F4CCFF}"/>
+                <a16:creationId xmlns:a16="http://schemas.microsoft.com/office/drawing/2014/main" id="{B97C6322-17F9-4669-AFC3-4AF7483CE598}"/>
               </a:ext>
             </a:extLst>
           </p:cNvPr>
@@ -22454,7 +22511,7 @@
           <p:cNvPr id="18" name="">
             <a:extLst xmlns:a="http://schemas.openxmlformats.org/drawingml/2006/main">
               <a:ext uri="{FF2B5EF4-FFF2-40B4-BE49-F238E27FC236}">
-                <a16:creationId xmlns:a16="http://schemas.microsoft.com/office/drawing/2014/main" id="{C27E8774-5CCD-4E02-AC45-E064A2DEA69F}"/>
+                <a16:creationId xmlns:a16="http://schemas.microsoft.com/office/drawing/2014/main" id="{0966AC1B-0006-49AC-AB70-865122CB2F0E}"/>
               </a:ext>
             </a:extLst>
           </p:cNvPr>
@@ -22506,7 +22563,7 @@
           <p:cNvPr id="19" name="">
             <a:extLst xmlns:a="http://schemas.openxmlformats.org/drawingml/2006/main">
               <a:ext uri="{FF2B5EF4-FFF2-40B4-BE49-F238E27FC236}">
-                <a16:creationId xmlns:a16="http://schemas.microsoft.com/office/drawing/2014/main" id="{19ABC370-84C8-497F-971E-5D6D4C2E3008}"/>
+                <a16:creationId xmlns:a16="http://schemas.microsoft.com/office/drawing/2014/main" id="{88C34A6D-863F-415D-80DD-209830D4015C}"/>
               </a:ext>
             </a:extLst>
           </p:cNvPr>
@@ -22575,7 +22632,7 @@
           <p:cNvPr id="20" name="">
             <a:extLst xmlns:a="http://schemas.openxmlformats.org/drawingml/2006/main">
               <a:ext uri="{FF2B5EF4-FFF2-40B4-BE49-F238E27FC236}">
-                <a16:creationId xmlns:a16="http://schemas.microsoft.com/office/drawing/2014/main" id="{392ADE37-5263-4DB2-94ED-B883AC49C390}"/>
+                <a16:creationId xmlns:a16="http://schemas.microsoft.com/office/drawing/2014/main" id="{0D2D038C-2DA1-4F50-989A-844FFAA07E16}"/>
               </a:ext>
             </a:extLst>
           </p:cNvPr>
@@ -22627,7 +22684,7 @@
           <p:cNvPr id="21" name="">
             <a:extLst xmlns:a="http://schemas.openxmlformats.org/drawingml/2006/main">
               <a:ext uri="{FF2B5EF4-FFF2-40B4-BE49-F238E27FC236}">
-                <a16:creationId xmlns:a16="http://schemas.microsoft.com/office/drawing/2014/main" id="{B48D0522-C4DF-497B-A78B-E72C6561272A}"/>
+                <a16:creationId xmlns:a16="http://schemas.microsoft.com/office/drawing/2014/main" id="{BD12673B-EB3D-405F-A157-34973236CD55}"/>
               </a:ext>
             </a:extLst>
           </p:cNvPr>
@@ -22677,7 +22734,7 @@
     </p:spTree>
     <p:extLst>
       <p:ext uri="{BB962C8B-B14F-4D97-AF65-F5344CB8AC3E}">
-        <p14:creationId xmlns:p14="http://schemas.microsoft.com/office/powerpoint/2010/main" val="1995058096"/>
+        <p14:creationId xmlns:p14="http://schemas.microsoft.com/office/powerpoint/2010/main" val="327508382"/>
       </p:ext>
     </p:extLst>
   </p:cSld>
@@ -22701,7 +22758,7 @@
           <p:cNvPr id="14" name="">
             <a:extLst xmlns:a="http://schemas.openxmlformats.org/drawingml/2006/main">
               <a:ext uri="{FF2B5EF4-FFF2-40B4-BE49-F238E27FC236}">
-                <a16:creationId xmlns:a16="http://schemas.microsoft.com/office/drawing/2014/main" id="{A2A181D7-25E1-4E71-9FAC-4983FF72601C}"/>
+                <a16:creationId xmlns:a16="http://schemas.microsoft.com/office/drawing/2014/main" id="{A1389301-30E4-4A48-A844-596BB5E9C04D}"/>
               </a:ext>
             </a:extLst>
           </p:cNvPr>
@@ -22753,7 +22810,7 @@
           <p:cNvPr id="2" name="">
             <a:extLst xmlns:a="http://schemas.openxmlformats.org/drawingml/2006/main">
               <a:ext uri="{FF2B5EF4-FFF2-40B4-BE49-F238E27FC236}">
-                <a16:creationId xmlns:a16="http://schemas.microsoft.com/office/drawing/2014/main" id="{80774CAA-4798-4E80-B776-159CA0CC5D70}"/>
+                <a16:creationId xmlns:a16="http://schemas.microsoft.com/office/drawing/2014/main" id="{0C7AAC24-907A-45E7-9858-48EEBB93214A}"/>
               </a:ext>
             </a:extLst>
           </p:cNvPr>
@@ -22827,7 +22884,7 @@
           <p:cNvPr id="4" name="">
             <a:extLst xmlns:a="http://schemas.openxmlformats.org/drawingml/2006/main">
               <a:ext uri="{FF2B5EF4-FFF2-40B4-BE49-F238E27FC236}">
-                <a16:creationId xmlns:a16="http://schemas.microsoft.com/office/drawing/2014/main" id="{A4244B38-E89E-4651-9CD0-442EA6583D79}"/>
+                <a16:creationId xmlns:a16="http://schemas.microsoft.com/office/drawing/2014/main" id="{8A3C201B-3F7A-4319-9F85-A981164E5EB0}"/>
               </a:ext>
             </a:extLst>
           </p:cNvPr>
@@ -22879,7 +22936,7 @@
           <p:cNvPr id="5" name="">
             <a:extLst xmlns:a="http://schemas.openxmlformats.org/drawingml/2006/main">
               <a:ext uri="{FF2B5EF4-FFF2-40B4-BE49-F238E27FC236}">
-                <a16:creationId xmlns:a16="http://schemas.microsoft.com/office/drawing/2014/main" id="{23ACBE10-D78B-4F8A-BB99-63D345773D5C}"/>
+                <a16:creationId xmlns:a16="http://schemas.microsoft.com/office/drawing/2014/main" id="{B4EBDACA-B8D2-40DD-AD97-77059C594321}"/>
               </a:ext>
             </a:extLst>
           </p:cNvPr>
@@ -22910,7 +22967,7 @@
           <p:cNvPr id="6" name="">
             <a:extLst xmlns:a="http://schemas.openxmlformats.org/drawingml/2006/main">
               <a:ext uri="{FF2B5EF4-FFF2-40B4-BE49-F238E27FC236}">
-                <a16:creationId xmlns:a16="http://schemas.microsoft.com/office/drawing/2014/main" id="{5673B7FA-8B06-4CF9-B16A-0328D6AA3023}"/>
+                <a16:creationId xmlns:a16="http://schemas.microsoft.com/office/drawing/2014/main" id="{451D522A-2550-47A7-8EAA-7D0B9B6C7583}"/>
               </a:ext>
             </a:extLst>
           </p:cNvPr>
@@ -22962,7 +23019,7 @@
           <p:cNvPr id="7" name="">
             <a:extLst xmlns:a="http://schemas.openxmlformats.org/drawingml/2006/main">
               <a:ext uri="{FF2B5EF4-FFF2-40B4-BE49-F238E27FC236}">
-                <a16:creationId xmlns:a16="http://schemas.microsoft.com/office/drawing/2014/main" id="{7A022EE3-FABD-4DFC-B57E-B4B8DEFE0005}"/>
+                <a16:creationId xmlns:a16="http://schemas.microsoft.com/office/drawing/2014/main" id="{6BB7961B-C918-4A59-ADD5-E54D1F8ACB0B}"/>
               </a:ext>
             </a:extLst>
           </p:cNvPr>
@@ -23058,7 +23115,7 @@
           <p:cNvPr id="8" name="">
             <a:extLst xmlns:a="http://schemas.openxmlformats.org/drawingml/2006/main">
               <a:ext uri="{FF2B5EF4-FFF2-40B4-BE49-F238E27FC236}">
-                <a16:creationId xmlns:a16="http://schemas.microsoft.com/office/drawing/2014/main" id="{E8B1FE84-B858-47C5-80FE-D33ED941A2AA}"/>
+                <a16:creationId xmlns:a16="http://schemas.microsoft.com/office/drawing/2014/main" id="{6AEFA617-E10A-4D11-9DA5-C7F257EAF241}"/>
               </a:ext>
             </a:extLst>
           </p:cNvPr>
@@ -23089,7 +23146,7 @@
           <p:cNvPr id="9" name="">
             <a:extLst xmlns:a="http://schemas.openxmlformats.org/drawingml/2006/main">
               <a:ext uri="{FF2B5EF4-FFF2-40B4-BE49-F238E27FC236}">
-                <a16:creationId xmlns:a16="http://schemas.microsoft.com/office/drawing/2014/main" id="{0FF5158A-637D-4B9A-9A2F-44CF325A9FA8}"/>
+                <a16:creationId xmlns:a16="http://schemas.microsoft.com/office/drawing/2014/main" id="{050A8052-B8D9-4B4F-8351-E12D1DF3D3BF}"/>
               </a:ext>
             </a:extLst>
           </p:cNvPr>
@@ -23141,7 +23198,7 @@
           <p:cNvPr id="10" name="">
             <a:extLst xmlns:a="http://schemas.openxmlformats.org/drawingml/2006/main">
               <a:ext uri="{FF2B5EF4-FFF2-40B4-BE49-F238E27FC236}">
-                <a16:creationId xmlns:a16="http://schemas.microsoft.com/office/drawing/2014/main" id="{AB0EC173-C98D-4580-B678-E336C3EE5704}"/>
+                <a16:creationId xmlns:a16="http://schemas.microsoft.com/office/drawing/2014/main" id="{F897789F-0266-4CB1-AB08-E8440BE0C78F}"/>
               </a:ext>
             </a:extLst>
           </p:cNvPr>
@@ -23259,7 +23316,7 @@
           <p:cNvPr id="11" name="">
             <a:extLst xmlns:a="http://schemas.openxmlformats.org/drawingml/2006/main">
               <a:ext uri="{FF2B5EF4-FFF2-40B4-BE49-F238E27FC236}">
-                <a16:creationId xmlns:a16="http://schemas.microsoft.com/office/drawing/2014/main" id="{F0B90EFC-BD55-4F68-9643-2A9F9A57EEBC}"/>
+                <a16:creationId xmlns:a16="http://schemas.microsoft.com/office/drawing/2014/main" id="{82A21E67-E536-47F9-AE0C-0A1CD4904FB6}"/>
               </a:ext>
             </a:extLst>
           </p:cNvPr>
@@ -23290,7 +23347,7 @@
           <p:cNvPr id="12" name="">
             <a:extLst xmlns:a="http://schemas.openxmlformats.org/drawingml/2006/main">
               <a:ext uri="{FF2B5EF4-FFF2-40B4-BE49-F238E27FC236}">
-                <a16:creationId xmlns:a16="http://schemas.microsoft.com/office/drawing/2014/main" id="{95279A76-CFAD-406E-A773-A5BBC0461B4D}"/>
+                <a16:creationId xmlns:a16="http://schemas.microsoft.com/office/drawing/2014/main" id="{E2708A29-C821-4E3F-A6FD-FF245CC56B34}"/>
               </a:ext>
             </a:extLst>
           </p:cNvPr>
@@ -23342,7 +23399,7 @@
           <p:cNvPr id="13" name="">
             <a:extLst xmlns:a="http://schemas.openxmlformats.org/drawingml/2006/main">
               <a:ext uri="{FF2B5EF4-FFF2-40B4-BE49-F238E27FC236}">
-                <a16:creationId xmlns:a16="http://schemas.microsoft.com/office/drawing/2014/main" id="{640167A9-676F-4B55-825E-CD2007727CC7}"/>
+                <a16:creationId xmlns:a16="http://schemas.microsoft.com/office/drawing/2014/main" id="{C53F61AB-3C83-4137-B716-E4F1D2780263}"/>
               </a:ext>
             </a:extLst>
           </p:cNvPr>
@@ -23470,7 +23527,7 @@
     </p:spTree>
     <p:extLst>
       <p:ext uri="{BB962C8B-B14F-4D97-AF65-F5344CB8AC3E}">
-        <p14:creationId xmlns:p14="http://schemas.microsoft.com/office/powerpoint/2010/main" val="950246671"/>
+        <p14:creationId xmlns:p14="http://schemas.microsoft.com/office/powerpoint/2010/main" val="1390542441"/>
       </p:ext>
     </p:extLst>
   </p:cSld>
@@ -23494,7 +23551,7 @@
           <p:cNvPr id="25" name="">
             <a:extLst xmlns:a="http://schemas.openxmlformats.org/drawingml/2006/main">
               <a:ext uri="{FF2B5EF4-FFF2-40B4-BE49-F238E27FC236}">
-                <a16:creationId xmlns:a16="http://schemas.microsoft.com/office/drawing/2014/main" id="{6DCA566E-8892-4C2D-8B21-12691685E1A2}"/>
+                <a16:creationId xmlns:a16="http://schemas.microsoft.com/office/drawing/2014/main" id="{86D27951-060D-44F4-B494-18A576F0580D}"/>
               </a:ext>
             </a:extLst>
           </p:cNvPr>
@@ -23546,7 +23603,7 @@
           <p:cNvPr id="2" name="">
             <a:extLst xmlns:a="http://schemas.openxmlformats.org/drawingml/2006/main">
               <a:ext uri="{FF2B5EF4-FFF2-40B4-BE49-F238E27FC236}">
-                <a16:creationId xmlns:a16="http://schemas.microsoft.com/office/drawing/2014/main" id="{122A7CAF-67B7-4887-B1F0-FFF26B15F414}"/>
+                <a16:creationId xmlns:a16="http://schemas.microsoft.com/office/drawing/2014/main" id="{86C5C930-DDB3-4BFA-8FF1-1A20EBC6960B}"/>
               </a:ext>
             </a:extLst>
           </p:cNvPr>
@@ -23620,7 +23677,7 @@
           <p:cNvPr id="4" name="">
             <a:extLst xmlns:a="http://schemas.openxmlformats.org/drawingml/2006/main">
               <a:ext uri="{FF2B5EF4-FFF2-40B4-BE49-F238E27FC236}">
-                <a16:creationId xmlns:a16="http://schemas.microsoft.com/office/drawing/2014/main" id="{FC6E23E9-34CE-4A3B-AA3E-DCD166A68C04}"/>
+                <a16:creationId xmlns:a16="http://schemas.microsoft.com/office/drawing/2014/main" id="{8AA817E1-5128-4905-A74F-2286D94EC4C8}"/>
               </a:ext>
             </a:extLst>
           </p:cNvPr>
@@ -23672,7 +23729,7 @@
           <p:cNvPr id="5" name="">
             <a:extLst xmlns:a="http://schemas.openxmlformats.org/drawingml/2006/main">
               <a:ext uri="{FF2B5EF4-FFF2-40B4-BE49-F238E27FC236}">
-                <a16:creationId xmlns:a16="http://schemas.microsoft.com/office/drawing/2014/main" id="{E3C2EBF2-1918-402A-B23D-F529F89578E9}"/>
+                <a16:creationId xmlns:a16="http://schemas.microsoft.com/office/drawing/2014/main" id="{F70DEDDD-F97A-4F4F-B974-9C826DC2121C}"/>
               </a:ext>
             </a:extLst>
           </p:cNvPr>
@@ -23724,7 +23781,7 @@
           <p:cNvPr id="6" name="">
             <a:extLst xmlns:a="http://schemas.openxmlformats.org/drawingml/2006/main">
               <a:ext uri="{FF2B5EF4-FFF2-40B4-BE49-F238E27FC236}">
-                <a16:creationId xmlns:a16="http://schemas.microsoft.com/office/drawing/2014/main" id="{CA27611C-C117-4989-89E4-ADB2804EBCAF}"/>
+                <a16:creationId xmlns:a16="http://schemas.microsoft.com/office/drawing/2014/main" id="{E6FDCFB6-2DA9-43FB-B345-B5CC673A1978}"/>
               </a:ext>
             </a:extLst>
           </p:cNvPr>
@@ -23776,7 +23833,7 @@
           <p:cNvPr id="7" name="">
             <a:extLst xmlns:a="http://schemas.openxmlformats.org/drawingml/2006/main">
               <a:ext uri="{FF2B5EF4-FFF2-40B4-BE49-F238E27FC236}">
-                <a16:creationId xmlns:a16="http://schemas.microsoft.com/office/drawing/2014/main" id="{1D7ACD45-64BF-46F2-B639-BE54A9246972}"/>
+                <a16:creationId xmlns:a16="http://schemas.microsoft.com/office/drawing/2014/main" id="{0C486195-70FB-41FD-9AB2-F41FD4444790}"/>
               </a:ext>
             </a:extLst>
           </p:cNvPr>
@@ -23850,7 +23907,7 @@
           <p:cNvPr id="9" name="">
             <a:extLst xmlns:a="http://schemas.openxmlformats.org/drawingml/2006/main">
               <a:ext uri="{FF2B5EF4-FFF2-40B4-BE49-F238E27FC236}">
-                <a16:creationId xmlns:a16="http://schemas.microsoft.com/office/drawing/2014/main" id="{674B5782-6F07-4669-A678-5860C396AF65}"/>
+                <a16:creationId xmlns:a16="http://schemas.microsoft.com/office/drawing/2014/main" id="{E48E71DE-B76F-4122-A91B-D00CF2D3079E}"/>
               </a:ext>
             </a:extLst>
           </p:cNvPr>
@@ -23902,7 +23959,7 @@
           <p:cNvPr id="10" name="">
             <a:extLst xmlns:a="http://schemas.openxmlformats.org/drawingml/2006/main">
               <a:ext uri="{FF2B5EF4-FFF2-40B4-BE49-F238E27FC236}">
-                <a16:creationId xmlns:a16="http://schemas.microsoft.com/office/drawing/2014/main" id="{1A206285-6AFD-45C5-8624-784E46671DC8}"/>
+                <a16:creationId xmlns:a16="http://schemas.microsoft.com/office/drawing/2014/main" id="{C5D15BC1-1B96-411E-BD2E-0D0796610144}"/>
               </a:ext>
             </a:extLst>
           </p:cNvPr>
@@ -23954,7 +24011,7 @@
           <p:cNvPr id="11" name="">
             <a:extLst xmlns:a="http://schemas.openxmlformats.org/drawingml/2006/main">
               <a:ext uri="{FF2B5EF4-FFF2-40B4-BE49-F238E27FC236}">
-                <a16:creationId xmlns:a16="http://schemas.microsoft.com/office/drawing/2014/main" id="{9044391F-C5FA-4323-B73F-D30A8A2064C0}"/>
+                <a16:creationId xmlns:a16="http://schemas.microsoft.com/office/drawing/2014/main" id="{8D031492-2FC3-4208-9625-96EEB79C879E}"/>
               </a:ext>
             </a:extLst>
           </p:cNvPr>
@@ -24028,7 +24085,7 @@
           <p:cNvPr id="13" name="">
             <a:extLst xmlns:a="http://schemas.openxmlformats.org/drawingml/2006/main">
               <a:ext uri="{FF2B5EF4-FFF2-40B4-BE49-F238E27FC236}">
-                <a16:creationId xmlns:a16="http://schemas.microsoft.com/office/drawing/2014/main" id="{3D85A865-5E5C-401A-A178-D3A4DBDCC2EC}"/>
+                <a16:creationId xmlns:a16="http://schemas.microsoft.com/office/drawing/2014/main" id="{86D51B42-6664-433B-A0A9-F5E3D1B68E4E}"/>
               </a:ext>
             </a:extLst>
           </p:cNvPr>
@@ -24080,7 +24137,7 @@
           <p:cNvPr id="14" name="">
             <a:extLst xmlns:a="http://schemas.openxmlformats.org/drawingml/2006/main">
               <a:ext uri="{FF2B5EF4-FFF2-40B4-BE49-F238E27FC236}">
-                <a16:creationId xmlns:a16="http://schemas.microsoft.com/office/drawing/2014/main" id="{DBE05958-CB7F-43DC-AA4E-9B7A42071F7E}"/>
+                <a16:creationId xmlns:a16="http://schemas.microsoft.com/office/drawing/2014/main" id="{09DD7948-B784-4DF3-92BC-C3BFD2B604B2}"/>
               </a:ext>
             </a:extLst>
           </p:cNvPr>
@@ -24132,7 +24189,7 @@
           <p:cNvPr id="15" name="">
             <a:extLst xmlns:a="http://schemas.openxmlformats.org/drawingml/2006/main">
               <a:ext uri="{FF2B5EF4-FFF2-40B4-BE49-F238E27FC236}">
-                <a16:creationId xmlns:a16="http://schemas.microsoft.com/office/drawing/2014/main" id="{6D7F84C1-BD45-478B-B851-D702B3517D97}"/>
+                <a16:creationId xmlns:a16="http://schemas.microsoft.com/office/drawing/2014/main" id="{4C4E7EFB-DF78-4E39-A06A-253FEB908E2A}"/>
               </a:ext>
             </a:extLst>
           </p:cNvPr>
@@ -24206,7 +24263,7 @@
           <p:cNvPr id="17" name="">
             <a:extLst xmlns:a="http://schemas.openxmlformats.org/drawingml/2006/main">
               <a:ext uri="{FF2B5EF4-FFF2-40B4-BE49-F238E27FC236}">
-                <a16:creationId xmlns:a16="http://schemas.microsoft.com/office/drawing/2014/main" id="{9A4CC42B-50B1-4DB2-A94D-1B8CBFD098C5}"/>
+                <a16:creationId xmlns:a16="http://schemas.microsoft.com/office/drawing/2014/main" id="{5B020BF8-4FAC-4A5C-9524-EACDE5674047}"/>
               </a:ext>
             </a:extLst>
           </p:cNvPr>
@@ -24258,7 +24315,7 @@
           <p:cNvPr id="18" name="">
             <a:extLst xmlns:a="http://schemas.openxmlformats.org/drawingml/2006/main">
               <a:ext uri="{FF2B5EF4-FFF2-40B4-BE49-F238E27FC236}">
-                <a16:creationId xmlns:a16="http://schemas.microsoft.com/office/drawing/2014/main" id="{FFEB54EB-A313-4791-BC74-F9078896EDCF}"/>
+                <a16:creationId xmlns:a16="http://schemas.microsoft.com/office/drawing/2014/main" id="{91D9AF9F-3EDD-4BEB-843B-0AF46993FD42}"/>
               </a:ext>
             </a:extLst>
           </p:cNvPr>
@@ -24310,7 +24367,7 @@
           <p:cNvPr id="19" name="">
             <a:extLst xmlns:a="http://schemas.openxmlformats.org/drawingml/2006/main">
               <a:ext uri="{FF2B5EF4-FFF2-40B4-BE49-F238E27FC236}">
-                <a16:creationId xmlns:a16="http://schemas.microsoft.com/office/drawing/2014/main" id="{5B3041F6-875D-47C7-8276-D11897C4671A}"/>
+                <a16:creationId xmlns:a16="http://schemas.microsoft.com/office/drawing/2014/main" id="{56DDC39E-D69E-4397-9378-3AE469E183F2}"/>
               </a:ext>
             </a:extLst>
           </p:cNvPr>
@@ -24384,7 +24441,7 @@
           <p:cNvPr id="21" name="">
             <a:extLst xmlns:a="http://schemas.openxmlformats.org/drawingml/2006/main">
               <a:ext uri="{FF2B5EF4-FFF2-40B4-BE49-F238E27FC236}">
-                <a16:creationId xmlns:a16="http://schemas.microsoft.com/office/drawing/2014/main" id="{5EB7ABC6-309F-4073-83E6-A43F7446EFDD}"/>
+                <a16:creationId xmlns:a16="http://schemas.microsoft.com/office/drawing/2014/main" id="{9EE2BFEA-2638-4CD9-84A5-5729C1029211}"/>
               </a:ext>
             </a:extLst>
           </p:cNvPr>
@@ -24436,7 +24493,7 @@
           <p:cNvPr id="22" name="">
             <a:extLst xmlns:a="http://schemas.openxmlformats.org/drawingml/2006/main">
               <a:ext uri="{FF2B5EF4-FFF2-40B4-BE49-F238E27FC236}">
-                <a16:creationId xmlns:a16="http://schemas.microsoft.com/office/drawing/2014/main" id="{B6DC99C5-BF53-4E2A-91CC-37808831279D}"/>
+                <a16:creationId xmlns:a16="http://schemas.microsoft.com/office/drawing/2014/main" id="{C49B5B17-31A0-4CF7-8B8F-7394841F026F}"/>
               </a:ext>
             </a:extLst>
           </p:cNvPr>
@@ -24488,7 +24545,7 @@
           <p:cNvPr id="23" name="">
             <a:extLst xmlns:a="http://schemas.openxmlformats.org/drawingml/2006/main">
               <a:ext uri="{FF2B5EF4-FFF2-40B4-BE49-F238E27FC236}">
-                <a16:creationId xmlns:a16="http://schemas.microsoft.com/office/drawing/2014/main" id="{EA9D0A79-1986-4EE6-8539-64B148466D36}"/>
+                <a16:creationId xmlns:a16="http://schemas.microsoft.com/office/drawing/2014/main" id="{C5128EE3-D8F6-4359-9C1D-1E4A57B637CB}"/>
               </a:ext>
             </a:extLst>
           </p:cNvPr>
@@ -24560,7 +24617,7 @@
     </p:spTree>
     <p:extLst>
       <p:ext uri="{BB962C8B-B14F-4D97-AF65-F5344CB8AC3E}">
-        <p14:creationId xmlns:p14="http://schemas.microsoft.com/office/powerpoint/2010/main" val="1417363251"/>
+        <p14:creationId xmlns:p14="http://schemas.microsoft.com/office/powerpoint/2010/main" val="1079968001"/>
       </p:ext>
     </p:extLst>
   </p:cSld>
@@ -24584,7 +24641,7 @@
           <p:cNvPr id="13" name="">
             <a:extLst xmlns:a="http://schemas.openxmlformats.org/drawingml/2006/main">
               <a:ext uri="{FF2B5EF4-FFF2-40B4-BE49-F238E27FC236}">
-                <a16:creationId xmlns:a16="http://schemas.microsoft.com/office/drawing/2014/main" id="{66B67A16-E26F-40AE-8BA1-76523CAECD8A}"/>
+                <a16:creationId xmlns:a16="http://schemas.microsoft.com/office/drawing/2014/main" id="{FDAC32F3-5ECF-4896-8F4E-CE8A82DBFFFE}"/>
               </a:ext>
             </a:extLst>
           </p:cNvPr>
@@ -24636,7 +24693,7 @@
           <p:cNvPr id="2" name="">
             <a:extLst xmlns:a="http://schemas.openxmlformats.org/drawingml/2006/main">
               <a:ext uri="{FF2B5EF4-FFF2-40B4-BE49-F238E27FC236}">
-                <a16:creationId xmlns:a16="http://schemas.microsoft.com/office/drawing/2014/main" id="{DFCE0685-5277-401B-BE5A-2D3A3AFDF1DD}"/>
+                <a16:creationId xmlns:a16="http://schemas.microsoft.com/office/drawing/2014/main" id="{C39BCB88-CEA1-4F80-A9C1-95E0A0FBB1E8}"/>
               </a:ext>
             </a:extLst>
           </p:cNvPr>
@@ -24710,7 +24767,7 @@
           <p:cNvPr id="4" name="">
             <a:extLst xmlns:a="http://schemas.openxmlformats.org/drawingml/2006/main">
               <a:ext uri="{FF2B5EF4-FFF2-40B4-BE49-F238E27FC236}">
-                <a16:creationId xmlns:a16="http://schemas.microsoft.com/office/drawing/2014/main" id="{C1563CD9-EAAE-4180-BA2F-92877F2871AD}"/>
+                <a16:creationId xmlns:a16="http://schemas.microsoft.com/office/drawing/2014/main" id="{7E95B289-DEBE-4485-9321-5F41D725DCC0}"/>
               </a:ext>
             </a:extLst>
           </p:cNvPr>
@@ -24762,7 +24819,7 @@
           <p:cNvPr id="5" name="">
             <a:extLst xmlns:a="http://schemas.openxmlformats.org/drawingml/2006/main">
               <a:ext uri="{FF2B5EF4-FFF2-40B4-BE49-F238E27FC236}">
-                <a16:creationId xmlns:a16="http://schemas.microsoft.com/office/drawing/2014/main" id="{457FE7E9-DE85-416B-B0EA-0B4FBC0759F4}"/>
+                <a16:creationId xmlns:a16="http://schemas.microsoft.com/office/drawing/2014/main" id="{BEB433D6-804B-4B8B-91AC-5511B1169286}"/>
               </a:ext>
             </a:extLst>
           </p:cNvPr>
@@ -24793,7 +24850,7 @@
           <p:cNvPr id="6" name="">
             <a:extLst xmlns:a="http://schemas.openxmlformats.org/drawingml/2006/main">
               <a:ext uri="{FF2B5EF4-FFF2-40B4-BE49-F238E27FC236}">
-                <a16:creationId xmlns:a16="http://schemas.microsoft.com/office/drawing/2014/main" id="{A70450AC-D325-46F5-9DD3-36A3A84813BB}"/>
+                <a16:creationId xmlns:a16="http://schemas.microsoft.com/office/drawing/2014/main" id="{B1E3A34C-6858-442B-8075-5DE28E1529B5}"/>
               </a:ext>
             </a:extLst>
           </p:cNvPr>
@@ -24845,7 +24902,7 @@
           <p:cNvPr id="7" name="">
             <a:extLst xmlns:a="http://schemas.openxmlformats.org/drawingml/2006/main">
               <a:ext uri="{FF2B5EF4-FFF2-40B4-BE49-F238E27FC236}">
-                <a16:creationId xmlns:a16="http://schemas.microsoft.com/office/drawing/2014/main" id="{977DD23E-2413-4594-9540-C2A9EEB0ECF3}"/>
+                <a16:creationId xmlns:a16="http://schemas.microsoft.com/office/drawing/2014/main" id="{ADCE4C5F-31DB-48EC-AA5E-0CA74A1CC9A7}"/>
               </a:ext>
             </a:extLst>
           </p:cNvPr>
@@ -24982,7 +25039,7 @@
           <p:cNvPr id="8" name="">
             <a:extLst xmlns:a="http://schemas.openxmlformats.org/drawingml/2006/main">
               <a:ext uri="{FF2B5EF4-FFF2-40B4-BE49-F238E27FC236}">
-                <a16:creationId xmlns:a16="http://schemas.microsoft.com/office/drawing/2014/main" id="{81104C1C-BACC-4FF8-9D6D-AFEC1756E4BD}"/>
+                <a16:creationId xmlns:a16="http://schemas.microsoft.com/office/drawing/2014/main" id="{F549D5AF-45FD-40A6-B4AE-918E5D8C36E9}"/>
               </a:ext>
             </a:extLst>
           </p:cNvPr>
@@ -25013,7 +25070,7 @@
           <p:cNvPr id="9" name="">
             <a:extLst xmlns:a="http://schemas.openxmlformats.org/drawingml/2006/main">
               <a:ext uri="{FF2B5EF4-FFF2-40B4-BE49-F238E27FC236}">
-                <a16:creationId xmlns:a16="http://schemas.microsoft.com/office/drawing/2014/main" id="{A4B3FF26-C6EA-446D-B073-F049E908C8EE}"/>
+                <a16:creationId xmlns:a16="http://schemas.microsoft.com/office/drawing/2014/main" id="{BA871BDE-73E3-41EE-AEB6-A78DC94339CE}"/>
               </a:ext>
             </a:extLst>
           </p:cNvPr>
@@ -25065,7 +25122,7 @@
           <p:cNvPr id="10" name="">
             <a:extLst xmlns:a="http://schemas.openxmlformats.org/drawingml/2006/main">
               <a:ext uri="{FF2B5EF4-FFF2-40B4-BE49-F238E27FC236}">
-                <a16:creationId xmlns:a16="http://schemas.microsoft.com/office/drawing/2014/main" id="{5A91FCE0-3A13-4FF8-8858-683FD4ACD6F1}"/>
+                <a16:creationId xmlns:a16="http://schemas.microsoft.com/office/drawing/2014/main" id="{7AED2FD5-12E4-49A4-A37A-E2168748B0FD}"/>
               </a:ext>
             </a:extLst>
           </p:cNvPr>
@@ -25202,7 +25259,7 @@
           <p:cNvPr id="11" name="">
             <a:extLst xmlns:a="http://schemas.openxmlformats.org/drawingml/2006/main">
               <a:ext uri="{FF2B5EF4-FFF2-40B4-BE49-F238E27FC236}">
-                <a16:creationId xmlns:a16="http://schemas.microsoft.com/office/drawing/2014/main" id="{98859558-F810-4927-975B-0555A62FCD52}"/>
+                <a16:creationId xmlns:a16="http://schemas.microsoft.com/office/drawing/2014/main" id="{0183F07A-600C-47CC-802F-9896DA19E512}"/>
               </a:ext>
             </a:extLst>
           </p:cNvPr>
@@ -25254,7 +25311,7 @@
           <p:cNvPr id="12" name="">
             <a:extLst xmlns:a="http://schemas.openxmlformats.org/drawingml/2006/main">
               <a:ext uri="{FF2B5EF4-FFF2-40B4-BE49-F238E27FC236}">
-                <a16:creationId xmlns:a16="http://schemas.microsoft.com/office/drawing/2014/main" id="{5CCBE730-3B00-4828-BE04-D0C7AF1BE60B}"/>
+                <a16:creationId xmlns:a16="http://schemas.microsoft.com/office/drawing/2014/main" id="{1FECD76E-3C93-40F9-9A71-C3174148CD8D}"/>
               </a:ext>
             </a:extLst>
           </p:cNvPr>
@@ -25304,7 +25361,7 @@
     </p:spTree>
     <p:extLst>
       <p:ext uri="{BB962C8B-B14F-4D97-AF65-F5344CB8AC3E}">
-        <p14:creationId xmlns:p14="http://schemas.microsoft.com/office/powerpoint/2010/main" val="2129018403"/>
+        <p14:creationId xmlns:p14="http://schemas.microsoft.com/office/powerpoint/2010/main" val="919652168"/>
       </p:ext>
     </p:extLst>
   </p:cSld>
@@ -25328,7 +25385,7 @@
           <p:cNvPr id="14" name="">
             <a:extLst xmlns:a="http://schemas.openxmlformats.org/drawingml/2006/main">
               <a:ext uri="{FF2B5EF4-FFF2-40B4-BE49-F238E27FC236}">
-                <a16:creationId xmlns:a16="http://schemas.microsoft.com/office/drawing/2014/main" id="{C4586351-3A70-41EB-9B43-6C154440EB87}"/>
+                <a16:creationId xmlns:a16="http://schemas.microsoft.com/office/drawing/2014/main" id="{34CBFFD1-8D6C-45C3-AE9B-35F815196BCA}"/>
               </a:ext>
             </a:extLst>
           </p:cNvPr>
@@ -25380,7 +25437,7 @@
           <p:cNvPr id="2" name="">
             <a:extLst xmlns:a="http://schemas.openxmlformats.org/drawingml/2006/main">
               <a:ext uri="{FF2B5EF4-FFF2-40B4-BE49-F238E27FC236}">
-                <a16:creationId xmlns:a16="http://schemas.microsoft.com/office/drawing/2014/main" id="{C30A0764-3EA7-4B43-95EC-FE1B818DDCE2}"/>
+                <a16:creationId xmlns:a16="http://schemas.microsoft.com/office/drawing/2014/main" id="{7B32258E-7752-48A6-A8BE-1432026408F8}"/>
               </a:ext>
             </a:extLst>
           </p:cNvPr>
@@ -25454,7 +25511,7 @@
           <p:cNvPr id="4" name="">
             <a:extLst xmlns:a="http://schemas.openxmlformats.org/drawingml/2006/main">
               <a:ext uri="{FF2B5EF4-FFF2-40B4-BE49-F238E27FC236}">
-                <a16:creationId xmlns:a16="http://schemas.microsoft.com/office/drawing/2014/main" id="{954F8131-43D2-4A7E-B167-5D8320811EF5}"/>
+                <a16:creationId xmlns:a16="http://schemas.microsoft.com/office/drawing/2014/main" id="{E4AB4E7E-FDE7-4331-8DA8-DBC379BB57F3}"/>
               </a:ext>
             </a:extLst>
           </p:cNvPr>
@@ -25506,7 +25563,7 @@
           <p:cNvPr id="5" name="">
             <a:extLst xmlns:a="http://schemas.openxmlformats.org/drawingml/2006/main">
               <a:ext uri="{FF2B5EF4-FFF2-40B4-BE49-F238E27FC236}">
-                <a16:creationId xmlns:a16="http://schemas.microsoft.com/office/drawing/2014/main" id="{90427323-9FCB-4FF5-B6EE-0832DA255442}"/>
+                <a16:creationId xmlns:a16="http://schemas.microsoft.com/office/drawing/2014/main" id="{DD185474-2065-476E-A9A8-A343AC16BC89}"/>
               </a:ext>
             </a:extLst>
           </p:cNvPr>
@@ -25537,7 +25594,7 @@
           <p:cNvPr id="6" name="">
             <a:extLst xmlns:a="http://schemas.openxmlformats.org/drawingml/2006/main">
               <a:ext uri="{FF2B5EF4-FFF2-40B4-BE49-F238E27FC236}">
-                <a16:creationId xmlns:a16="http://schemas.microsoft.com/office/drawing/2014/main" id="{742F7326-3684-41CF-A784-1298F44B76E8}"/>
+                <a16:creationId xmlns:a16="http://schemas.microsoft.com/office/drawing/2014/main" id="{8589A8D3-E37F-41D0-ABF4-358A00F60B2E}"/>
               </a:ext>
             </a:extLst>
           </p:cNvPr>
@@ -25589,7 +25646,7 @@
           <p:cNvPr id="7" name="">
             <a:extLst xmlns:a="http://schemas.openxmlformats.org/drawingml/2006/main">
               <a:ext uri="{FF2B5EF4-FFF2-40B4-BE49-F238E27FC236}">
-                <a16:creationId xmlns:a16="http://schemas.microsoft.com/office/drawing/2014/main" id="{B51418E1-E51A-4ADA-BBB6-0F3DDAD05BAE}"/>
+                <a16:creationId xmlns:a16="http://schemas.microsoft.com/office/drawing/2014/main" id="{A6ECAB88-ABAA-4675-A484-78E8667237BA}"/>
               </a:ext>
             </a:extLst>
           </p:cNvPr>
@@ -25685,7 +25742,7 @@
           <p:cNvPr id="8" name="">
             <a:extLst xmlns:a="http://schemas.openxmlformats.org/drawingml/2006/main">
               <a:ext uri="{FF2B5EF4-FFF2-40B4-BE49-F238E27FC236}">
-                <a16:creationId xmlns:a16="http://schemas.microsoft.com/office/drawing/2014/main" id="{3EF6189B-BAD1-46A2-8EF7-2A79E66E7FDB}"/>
+                <a16:creationId xmlns:a16="http://schemas.microsoft.com/office/drawing/2014/main" id="{58A07C13-299D-45E6-B3D3-0D9DC59E26CD}"/>
               </a:ext>
             </a:extLst>
           </p:cNvPr>
@@ -25716,7 +25773,7 @@
           <p:cNvPr id="9" name="">
             <a:extLst xmlns:a="http://schemas.openxmlformats.org/drawingml/2006/main">
               <a:ext uri="{FF2B5EF4-FFF2-40B4-BE49-F238E27FC236}">
-                <a16:creationId xmlns:a16="http://schemas.microsoft.com/office/drawing/2014/main" id="{5445F6B5-0F4C-468E-83A2-1C86209D1D69}"/>
+                <a16:creationId xmlns:a16="http://schemas.microsoft.com/office/drawing/2014/main" id="{FFE730B8-6174-4D75-8E85-B3148478CE7E}"/>
               </a:ext>
             </a:extLst>
           </p:cNvPr>
@@ -25768,7 +25825,7 @@
           <p:cNvPr id="10" name="">
             <a:extLst xmlns:a="http://schemas.openxmlformats.org/drawingml/2006/main">
               <a:ext uri="{FF2B5EF4-FFF2-40B4-BE49-F238E27FC236}">
-                <a16:creationId xmlns:a16="http://schemas.microsoft.com/office/drawing/2014/main" id="{45A5303E-AC28-4ABB-BBC3-FD8BD8485C2B}"/>
+                <a16:creationId xmlns:a16="http://schemas.microsoft.com/office/drawing/2014/main" id="{659AE8A8-4891-4E03-8897-E2BF7F83BB84}"/>
               </a:ext>
             </a:extLst>
           </p:cNvPr>
@@ -25886,7 +25943,7 @@
           <p:cNvPr id="11" name="">
             <a:extLst xmlns:a="http://schemas.openxmlformats.org/drawingml/2006/main">
               <a:ext uri="{FF2B5EF4-FFF2-40B4-BE49-F238E27FC236}">
-                <a16:creationId xmlns:a16="http://schemas.microsoft.com/office/drawing/2014/main" id="{AE77B41C-0CCF-4414-A659-DC29F874E127}"/>
+                <a16:creationId xmlns:a16="http://schemas.microsoft.com/office/drawing/2014/main" id="{EF18487F-D94B-418E-9E18-F16AACAB8844}"/>
               </a:ext>
             </a:extLst>
           </p:cNvPr>
@@ -25917,7 +25974,7 @@
           <p:cNvPr id="12" name="">
             <a:extLst xmlns:a="http://schemas.openxmlformats.org/drawingml/2006/main">
               <a:ext uri="{FF2B5EF4-FFF2-40B4-BE49-F238E27FC236}">
-                <a16:creationId xmlns:a16="http://schemas.microsoft.com/office/drawing/2014/main" id="{0FB8712F-6FE7-4AF6-BCA0-083F54368089}"/>
+                <a16:creationId xmlns:a16="http://schemas.microsoft.com/office/drawing/2014/main" id="{C7B2845C-B246-4CC5-970E-783A4F5F4BF4}"/>
               </a:ext>
             </a:extLst>
           </p:cNvPr>
@@ -25969,7 +26026,7 @@
           <p:cNvPr id="13" name="">
             <a:extLst xmlns:a="http://schemas.openxmlformats.org/drawingml/2006/main">
               <a:ext uri="{FF2B5EF4-FFF2-40B4-BE49-F238E27FC236}">
-                <a16:creationId xmlns:a16="http://schemas.microsoft.com/office/drawing/2014/main" id="{E0A0763D-B4B2-4C4B-8246-A438AA6A8F0A}"/>
+                <a16:creationId xmlns:a16="http://schemas.microsoft.com/office/drawing/2014/main" id="{B7C4B75B-E58E-46B1-B771-A031F8CFB82A}"/>
               </a:ext>
             </a:extLst>
           </p:cNvPr>
@@ -26085,7 +26142,7 @@
     </p:spTree>
     <p:extLst>
       <p:ext uri="{BB962C8B-B14F-4D97-AF65-F5344CB8AC3E}">
-        <p14:creationId xmlns:p14="http://schemas.microsoft.com/office/powerpoint/2010/main" val="776095497"/>
+        <p14:creationId xmlns:p14="http://schemas.microsoft.com/office/powerpoint/2010/main" val="30853870"/>
       </p:ext>
     </p:extLst>
   </p:cSld>

</xml_diff>